<commit_message>
docs: add Jev HS benchmark appendix and reproducible experiment results
</commit_message>
<xml_diff>
--- a/portfolio/crossborder-portfolio.pptx
+++ b/portfolio/crossborder-portfolio.pptx
@@ -2,27 +2,30 @@
 <file path=ppt/presentation.xml><?xml version="1.0" encoding="utf-8"?>
 <p:presentation xmlns:p="http://schemas.openxmlformats.org/presentationml/2006/main">
   <p:sldMasterIdLst>
-    <p:sldMasterId xmlns:r="http://schemas.openxmlformats.org/officeDocument/2006/relationships" id="2147483648" r:id="R3eef06e516fd4b31"/>
+    <p:sldMasterId xmlns:r="http://schemas.openxmlformats.org/officeDocument/2006/relationships" id="2147483648" r:id="R3157283dd8794a62"/>
   </p:sldMasterIdLst>
   <p:notesMasterIdLst>
-    <p:notesMasterId xmlns:r="http://schemas.openxmlformats.org/officeDocument/2006/relationships" r:id="Reeb47bd3e5c240b2"/>
+    <p:notesMasterId xmlns:r="http://schemas.openxmlformats.org/officeDocument/2006/relationships" r:id="R77263c22734d4965"/>
   </p:notesMasterIdLst>
   <p:sldIdLst>
-    <p:sldId xmlns:r="http://schemas.openxmlformats.org/officeDocument/2006/relationships" id="256" r:id="R23172851a2cd4aa2"/>
-    <p:sldId xmlns:r="http://schemas.openxmlformats.org/officeDocument/2006/relationships" id="257" r:id="Rcad3765695de462a"/>
-    <p:sldId xmlns:r="http://schemas.openxmlformats.org/officeDocument/2006/relationships" id="258" r:id="R8693631f82464c01"/>
-    <p:sldId xmlns:r="http://schemas.openxmlformats.org/officeDocument/2006/relationships" id="259" r:id="Rd2eda6f0e0fb4198"/>
-    <p:sldId xmlns:r="http://schemas.openxmlformats.org/officeDocument/2006/relationships" id="260" r:id="R1f3840cc4d034df2"/>
-    <p:sldId xmlns:r="http://schemas.openxmlformats.org/officeDocument/2006/relationships" id="261" r:id="R0ef7b146b4624635"/>
-    <p:sldId xmlns:r="http://schemas.openxmlformats.org/officeDocument/2006/relationships" id="262" r:id="R156b8dcd7e2b47ec"/>
-    <p:sldId xmlns:r="http://schemas.openxmlformats.org/officeDocument/2006/relationships" id="263" r:id="R96a3e5f9dcbf47a9"/>
-    <p:sldId xmlns:r="http://schemas.openxmlformats.org/officeDocument/2006/relationships" id="264" r:id="R2ec28832341f4940"/>
-    <p:sldId xmlns:r="http://schemas.openxmlformats.org/officeDocument/2006/relationships" id="265" r:id="Rbc4b679bb0584cac"/>
-    <p:sldId xmlns:r="http://schemas.openxmlformats.org/officeDocument/2006/relationships" id="266" r:id="R4ca18a9865274786"/>
-    <p:sldId xmlns:r="http://schemas.openxmlformats.org/officeDocument/2006/relationships" id="267" r:id="Rff4d19d975fe4873"/>
-    <p:sldId xmlns:r="http://schemas.openxmlformats.org/officeDocument/2006/relationships" id="268" r:id="Rbc509349d9544881"/>
-    <p:sldId xmlns:r="http://schemas.openxmlformats.org/officeDocument/2006/relationships" id="269" r:id="R6f75c481d24e4915"/>
-    <p:sldId xmlns:r="http://schemas.openxmlformats.org/officeDocument/2006/relationships" id="270" r:id="R4d5a51f2ba60420f"/>
+    <p:sldId xmlns:r="http://schemas.openxmlformats.org/officeDocument/2006/relationships" id="256" r:id="R862a2ca4f3004e36"/>
+    <p:sldId xmlns:r="http://schemas.openxmlformats.org/officeDocument/2006/relationships" id="257" r:id="R54971af92ee74dff"/>
+    <p:sldId xmlns:r="http://schemas.openxmlformats.org/officeDocument/2006/relationships" id="258" r:id="Ref203dc51db1464d"/>
+    <p:sldId xmlns:r="http://schemas.openxmlformats.org/officeDocument/2006/relationships" id="259" r:id="Rc1e2cf908d0144af"/>
+    <p:sldId xmlns:r="http://schemas.openxmlformats.org/officeDocument/2006/relationships" id="260" r:id="R59d81729e3b84d1b"/>
+    <p:sldId xmlns:r="http://schemas.openxmlformats.org/officeDocument/2006/relationships" id="261" r:id="Reb139b5876264df3"/>
+    <p:sldId xmlns:r="http://schemas.openxmlformats.org/officeDocument/2006/relationships" id="262" r:id="Raf99b9311bba41aa"/>
+    <p:sldId xmlns:r="http://schemas.openxmlformats.org/officeDocument/2006/relationships" id="263" r:id="R42f678bd30394e8f"/>
+    <p:sldId xmlns:r="http://schemas.openxmlformats.org/officeDocument/2006/relationships" id="264" r:id="R28c9c9e9ef8e4171"/>
+    <p:sldId xmlns:r="http://schemas.openxmlformats.org/officeDocument/2006/relationships" id="265" r:id="R73329b35ee9141f3"/>
+    <p:sldId xmlns:r="http://schemas.openxmlformats.org/officeDocument/2006/relationships" id="266" r:id="R74b38976f44548dc"/>
+    <p:sldId xmlns:r="http://schemas.openxmlformats.org/officeDocument/2006/relationships" id="267" r:id="Rb4398cbde8fe4d59"/>
+    <p:sldId xmlns:r="http://schemas.openxmlformats.org/officeDocument/2006/relationships" id="268" r:id="Ra3108d3f84084d8d"/>
+    <p:sldId xmlns:r="http://schemas.openxmlformats.org/officeDocument/2006/relationships" id="269" r:id="Ra86c9de4263f4b6e"/>
+    <p:sldId xmlns:r="http://schemas.openxmlformats.org/officeDocument/2006/relationships" id="270" r:id="R7dd9ca1ed5b043f4"/>
+    <p:sldId xmlns:r="http://schemas.openxmlformats.org/officeDocument/2006/relationships" id="271" r:id="R2fedfa829ac94987"/>
+    <p:sldId xmlns:r="http://schemas.openxmlformats.org/officeDocument/2006/relationships" id="272" r:id="Rce8bd3a6ae90499f"/>
+    <p:sldId xmlns:r="http://schemas.openxmlformats.org/officeDocument/2006/relationships" id="273" r:id="Rb603702e941f42c8"/>
   </p:sldIdLst>
   <p:sldSz cx="15240000" cy="8572500"/>
   <p:notesSz cx="6858000" cy="9144000"/>
@@ -906,6 +909,216 @@
 </p:notes>
 </file>
 
+<file path=ppt/notesSlides/notesSlide16.xml><?xml version="1.0" encoding="utf-8"?>
+<p:notes xmlns:p="http://schemas.openxmlformats.org/presentationml/2006/main">
+  <p:cSld>
+    <p:spTree>
+      <p:nvGrpSpPr>
+        <p:cNvPr id="1" name=""/>
+        <p:cNvGrpSpPr/>
+        <p:nvPr/>
+      </p:nvGrpSpPr>
+      <p:grpSpPr>
+        <a:xfrm xmlns:a="http://schemas.openxmlformats.org/drawingml/2006/main"/>
+      </p:grpSpPr>
+      <p:sp>
+        <p:nvSpPr>
+          <p:cNvPr id="2" name="Slide Image Placeholder 1"/>
+          <p:cNvSpPr>
+            <a:spLocks xmlns:a="http://schemas.openxmlformats.org/drawingml/2006/main" noGrp="1"/>
+          </p:cNvSpPr>
+          <p:nvPr>
+            <p:ph type="sldImg" idx="0"/>
+          </p:nvPr>
+        </p:nvSpPr>
+        <p:spPr/>
+      </p:sp>
+      <p:sp>
+        <p:nvSpPr>
+          <p:cNvPr id="3" name="Notes Placeholder 2"/>
+          <p:cNvSpPr>
+            <a:spLocks xmlns:a="http://schemas.openxmlformats.org/drawingml/2006/main" noGrp="1"/>
+          </p:cNvSpPr>
+          <p:nvPr>
+            <p:ph type="body" idx="1"/>
+          </p:nvPr>
+        </p:nvSpPr>
+        <p:spPr/>
+        <p:txBody>
+          <a:bodyPr xmlns:a="http://schemas.openxmlformats.org/drawingml/2006/main"/>
+          <a:lstStyle xmlns:a="http://schemas.openxmlformats.org/drawingml/2006/main"/>
+          <a:p xmlns:a="http://schemas.openxmlformats.org/drawingml/2006/main">
+            <a:r>
+              <a:t>https://github.com/y00nZZang/product-catalog/blob/main/docs/jev-experiment-2026-10-06.md ; https://github.com/y00nZZang/product-catalog/blob/main/notebooks/two-datasets-results-2026-10-06.json ; https://docs.typesafe.ai/primitives/choice ; https://huggingface.co/datasets/ATH-MaaS/HSCodeComp . 실험은 운영 서비스 변경이나 전체 URL 분석시간 비교가 아니다.</a:t>
+            </a:r>
+          </a:p>
+        </p:txBody>
+      </p:sp>
+      <p:sp>
+        <p:nvSpPr>
+          <p:cNvPr id="4" name="Slide Number Placeholder 3"/>
+          <p:cNvSpPr>
+            <a:spLocks xmlns:a="http://schemas.openxmlformats.org/drawingml/2006/main" noGrp="1"/>
+          </p:cNvSpPr>
+          <p:nvPr>
+            <p:ph type="sldNum" idx="5"/>
+          </p:nvPr>
+        </p:nvSpPr>
+        <p:spPr/>
+        <p:txBody>
+          <a:bodyPr xmlns:a="http://schemas.openxmlformats.org/drawingml/2006/main"/>
+          <a:lstStyle xmlns:a="http://schemas.openxmlformats.org/drawingml/2006/main"/>
+          <a:p xmlns:a="http://schemas.openxmlformats.org/drawingml/2006/main"/>
+        </p:txBody>
+      </p:sp>
+    </p:spTree>
+  </p:cSld>
+  <p:clrMapOvr>
+    <a:masterClrMapping xmlns:a="http://schemas.openxmlformats.org/drawingml/2006/main"/>
+  </p:clrMapOvr>
+</p:notes>
+</file>
+
+<file path=ppt/notesSlides/notesSlide17.xml><?xml version="1.0" encoding="utf-8"?>
+<p:notes xmlns:p="http://schemas.openxmlformats.org/presentationml/2006/main">
+  <p:cSld>
+    <p:spTree>
+      <p:nvGrpSpPr>
+        <p:cNvPr id="1" name=""/>
+        <p:cNvGrpSpPr/>
+        <p:nvPr/>
+      </p:nvGrpSpPr>
+      <p:grpSpPr>
+        <a:xfrm xmlns:a="http://schemas.openxmlformats.org/drawingml/2006/main"/>
+      </p:grpSpPr>
+      <p:sp>
+        <p:nvSpPr>
+          <p:cNvPr id="2" name="Slide Image Placeholder 1"/>
+          <p:cNvSpPr>
+            <a:spLocks xmlns:a="http://schemas.openxmlformats.org/drawingml/2006/main" noGrp="1"/>
+          </p:cNvSpPr>
+          <p:nvPr>
+            <p:ph type="sldImg" idx="0"/>
+          </p:nvPr>
+        </p:nvSpPr>
+        <p:spPr/>
+      </p:sp>
+      <p:sp>
+        <p:nvSpPr>
+          <p:cNvPr id="3" name="Notes Placeholder 2"/>
+          <p:cNvSpPr>
+            <a:spLocks xmlns:a="http://schemas.openxmlformats.org/drawingml/2006/main" noGrp="1"/>
+          </p:cNvSpPr>
+          <p:nvPr>
+            <p:ph type="body" idx="1"/>
+          </p:nvPr>
+        </p:nvSpPr>
+        <p:spPr/>
+        <p:txBody>
+          <a:bodyPr xmlns:a="http://schemas.openxmlformats.org/drawingml/2006/main"/>
+          <a:lstStyle xmlns:a="http://schemas.openxmlformats.org/drawingml/2006/main"/>
+          <a:p xmlns:a="http://schemas.openxmlformats.org/drawingml/2006/main">
+            <a:r>
+              <a:t>https://github.com/y00nZZang/product-catalog/blob/main/docs/jev-experiment-2026-10-06.md . HF94개: Jev0.6747679375초/Luna4.296453624초, 비용0.023445996/0.0544944USD. Mercari30개:0.6689978755/3.79168373초, 비용0.00719754/0.01560205USD. 시간은 각 순차 HTTP+파싱+검증 시간 합의 중앙값. 공급사2개 동시 실행, 단계는 순차. 수집·포장·세금 계산·큐 대기시간 제외. 비용은 usage기반 추정, 청구서 확정액 아님.</a:t>
+            </a:r>
+          </a:p>
+        </p:txBody>
+      </p:sp>
+      <p:sp>
+        <p:nvSpPr>
+          <p:cNvPr id="4" name="Slide Number Placeholder 3"/>
+          <p:cNvSpPr>
+            <a:spLocks xmlns:a="http://schemas.openxmlformats.org/drawingml/2006/main" noGrp="1"/>
+          </p:cNvSpPr>
+          <p:nvPr>
+            <p:ph type="sldNum" idx="5"/>
+          </p:nvPr>
+        </p:nvSpPr>
+        <p:spPr/>
+        <p:txBody>
+          <a:bodyPr xmlns:a="http://schemas.openxmlformats.org/drawingml/2006/main"/>
+          <a:lstStyle xmlns:a="http://schemas.openxmlformats.org/drawingml/2006/main"/>
+          <a:p xmlns:a="http://schemas.openxmlformats.org/drawingml/2006/main"/>
+        </p:txBody>
+      </p:sp>
+    </p:spTree>
+  </p:cSld>
+  <p:clrMapOvr>
+    <a:masterClrMapping xmlns:a="http://schemas.openxmlformats.org/drawingml/2006/main"/>
+  </p:clrMapOvr>
+</p:notes>
+</file>
+
+<file path=ppt/notesSlides/notesSlide18.xml><?xml version="1.0" encoding="utf-8"?>
+<p:notes xmlns:p="http://schemas.openxmlformats.org/presentationml/2006/main">
+  <p:cSld>
+    <p:spTree>
+      <p:nvGrpSpPr>
+        <p:cNvPr id="1" name=""/>
+        <p:cNvGrpSpPr/>
+        <p:nvPr/>
+      </p:nvGrpSpPr>
+      <p:grpSpPr>
+        <a:xfrm xmlns:a="http://schemas.openxmlformats.org/drawingml/2006/main"/>
+      </p:grpSpPr>
+      <p:sp>
+        <p:nvSpPr>
+          <p:cNvPr id="2" name="Slide Image Placeholder 1"/>
+          <p:cNvSpPr>
+            <a:spLocks xmlns:a="http://schemas.openxmlformats.org/drawingml/2006/main" noGrp="1"/>
+          </p:cNvSpPr>
+          <p:nvPr>
+            <p:ph type="sldImg" idx="0"/>
+          </p:nvPr>
+        </p:nvSpPr>
+        <p:spPr/>
+      </p:sp>
+      <p:sp>
+        <p:nvSpPr>
+          <p:cNvPr id="3" name="Notes Placeholder 2"/>
+          <p:cNvSpPr>
+            <a:spLocks xmlns:a="http://schemas.openxmlformats.org/drawingml/2006/main" noGrp="1"/>
+          </p:cNvSpPr>
+          <p:nvPr>
+            <p:ph type="body" idx="1"/>
+          </p:nvPr>
+        </p:nvSpPr>
+        <p:spPr/>
+        <p:txBody>
+          <a:bodyPr xmlns:a="http://schemas.openxmlformats.org/drawingml/2006/main"/>
+          <a:lstStyle xmlns:a="http://schemas.openxmlformats.org/drawingml/2006/main"/>
+          <a:p xmlns:a="http://schemas.openxmlformats.org/drawingml/2006/main">
+            <a:r>
+              <a:t>https://github.com/y00nZZang/product-catalog/blob/main/docs/jev-experiment-2026-10-06.md ; https://github.com/y00nZZang/product-catalog/blob/main/notebooks/two-datasets-results-2026-10-06.json . HF94개: Jev28/94(29.8%), Luna36/94(38.3%), 보류 포함. 답변 사례만:28/81(34.6%),36/65(55.4%). 독립 Sol이HS6를 선택한Mercari25개에서Jev21/25(84%),Luna19/25(76%). 보류 포함30개 전체판단은Jev21/30(70%),Luna23/30(76.7%). Sol은정답/사람검토아님, 공유모델군편향가능. 운영도입하지않았으며 제안은 실험 결과에 대한 해석이다.</a:t>
+            </a:r>
+          </a:p>
+        </p:txBody>
+      </p:sp>
+      <p:sp>
+        <p:nvSpPr>
+          <p:cNvPr id="4" name="Slide Number Placeholder 3"/>
+          <p:cNvSpPr>
+            <a:spLocks xmlns:a="http://schemas.openxmlformats.org/drawingml/2006/main" noGrp="1"/>
+          </p:cNvSpPr>
+          <p:nvPr>
+            <p:ph type="sldNum" idx="5"/>
+          </p:nvPr>
+        </p:nvSpPr>
+        <p:spPr/>
+        <p:txBody>
+          <a:bodyPr xmlns:a="http://schemas.openxmlformats.org/drawingml/2006/main"/>
+          <a:lstStyle xmlns:a="http://schemas.openxmlformats.org/drawingml/2006/main"/>
+          <a:p xmlns:a="http://schemas.openxmlformats.org/drawingml/2006/main"/>
+        </p:txBody>
+      </p:sp>
+    </p:spTree>
+  </p:cSld>
+  <p:clrMapOvr>
+    <a:masterClrMapping xmlns:a="http://schemas.openxmlformats.org/drawingml/2006/main"/>
+  </p:clrMapOvr>
+</p:notes>
+</file>
+
 <file path=ppt/notesSlides/notesSlide2.xml><?xml version="1.0" encoding="utf-8"?>
 <p:notes xmlns:p="http://schemas.openxmlformats.org/presentationml/2006/main">
   <p:cSld>
@@ -1504,7 +1717,7 @@
   </p:cSld>
   <p:clrMap bg1="lt1" tx1="dk1" bg2="lt2" tx2="dk2" accent1="accent1" accent2="accent2" accent3="accent3" accent4="accent4" accent5="accent5" accent6="accent6" hlink="hlink" folHlink="folHlink"/>
   <p:sldLayoutIdLst>
-    <p:sldLayoutId xmlns:r="http://schemas.openxmlformats.org/officeDocument/2006/relationships" id="2147483649" r:id="R0ba0212dbc844fbb"/>
+    <p:sldLayoutId xmlns:r="http://schemas.openxmlformats.org/officeDocument/2006/relationships" id="2147483649" r:id="R9b4a47241f8b4d6b"/>
   </p:sldLayoutIdLst>
   <p:txStyles>
     <p:titleStyle>
@@ -2031,6 +2244,280 @@
 </a:theme>
 </file>
 
+<file path=ppt/slides/charts/chart1.xml><?xml version="1.0" encoding="utf-8"?>
+<c:chartSpace xmlns:c="http://schemas.openxmlformats.org/drawingml/2006/chart" xmlns:r="http://schemas.openxmlformats.org/officeDocument/2006/relationships">
+  <c:lang val="en-US"/>
+  <c:chart>
+    <c:plotArea>
+      <c:barChart>
+        <c:barDir val="col"/>
+        <c:grouping val="clustered"/>
+        <c:varyColors val="0"/>
+        <c:ser>
+          <c:idx val="0"/>
+          <c:order val="0"/>
+          <c:tx>
+            <c:v>Jev</c:v>
+          </c:tx>
+          <c:spPr>
+            <a:solidFill xmlns:a="http://schemas.openxmlformats.org/drawingml/2006/main">
+              <a:srgbClr val="156E58"/>
+            </a:solidFill>
+          </c:spPr>
+          <c:cat>
+            <c:strRef>
+              <c:f>'Chart Data'!$A$2:$A$3</c:f>
+              <c:strCache>
+                <c:ptCount val="2"/>
+                <c:pt idx="0">
+                  <c:v>HF 표본94개</c:v>
+                </c:pt>
+                <c:pt idx="1">
+                  <c:v>메루카리30개</c:v>
+                </c:pt>
+              </c:strCache>
+            </c:strRef>
+          </c:cat>
+          <c:val>
+            <c:numRef>
+              <c:f>'Chart Data'!$B$2:$B$3</c:f>
+              <c:numCache>
+                <c:formatCode>General</c:formatCode>
+                <c:ptCount val="2"/>
+                <c:pt idx="0">
+                  <c:v>0.675</c:v>
+                </c:pt>
+                <c:pt idx="1">
+                  <c:v>0.669</c:v>
+                </c:pt>
+              </c:numCache>
+            </c:numRef>
+          </c:val>
+        </c:ser>
+        <c:ser>
+          <c:idx val="1"/>
+          <c:order val="1"/>
+          <c:tx>
+            <c:v>GPT-6 Luna</c:v>
+          </c:tx>
+          <c:spPr>
+            <a:solidFill xmlns:a="http://schemas.openxmlformats.org/drawingml/2006/main">
+              <a:srgbClr val="85948D"/>
+            </a:solidFill>
+          </c:spPr>
+          <c:cat>
+            <c:strRef>
+              <c:f>'Chart Data'!$C$2:$C$3</c:f>
+              <c:strCache>
+                <c:ptCount val="2"/>
+                <c:pt idx="0">
+                  <c:v>HF 표본94개</c:v>
+                </c:pt>
+                <c:pt idx="1">
+                  <c:v>메루카리30개</c:v>
+                </c:pt>
+              </c:strCache>
+            </c:strRef>
+          </c:cat>
+          <c:val>
+            <c:numRef>
+              <c:f>'Chart Data'!$D$2:$D$3</c:f>
+              <c:numCache>
+                <c:formatCode>General</c:formatCode>
+                <c:ptCount val="2"/>
+                <c:pt idx="0">
+                  <c:v>4.296</c:v>
+                </c:pt>
+                <c:pt idx="1">
+                  <c:v>3.792</c:v>
+                </c:pt>
+              </c:numCache>
+            </c:numRef>
+          </c:val>
+        </c:ser>
+        <c:dLbls>
+          <c:txPr>
+            <a:bodyPr xmlns:a="http://schemas.openxmlformats.org/drawingml/2006/main" anchorCtr="1"/>
+            <a:lstStyle xmlns:a="http://schemas.openxmlformats.org/drawingml/2006/main"/>
+            <a:p xmlns:a="http://schemas.openxmlformats.org/drawingml/2006/main">
+              <a:pPr>
+                <a:defRPr sz="1875">
+                  <a:solidFill>
+                    <a:srgbClr val="182C29"/>
+                  </a:solidFill>
+                  <a:latin typeface="Apple SD Gothic Neo"/>
+                  <a:ea typeface="Apple SD Gothic Neo"/>
+                  <a:cs typeface="Apple SD Gothic Neo"/>
+                </a:defRPr>
+              </a:pPr>
+            </a:p>
+          </c:txPr>
+          <c:dLblPos val="outEnd"/>
+          <c:showLegendKey val="0"/>
+          <c:showVal val="1"/>
+          <c:showCatName val="0"/>
+          <c:showSerName val="0"/>
+          <c:showPercent val="0"/>
+          <c:showBubbleSize val="0"/>
+          <c:showLeaderLines val="0"/>
+        </c:dLbls>
+        <c:gapWidth val="90"/>
+        <c:axId val="48650112"/>
+        <c:axId val="48672768"/>
+      </c:barChart>
+      <c:catAx>
+        <c:axId val="48650112"/>
+        <c:scaling>
+          <c:orientation val="minMax"/>
+        </c:scaling>
+        <c:delete val="0"/>
+        <c:axPos val="b"/>
+        <c:numFmt formatCode="General"/>
+        <c:majorTickMark val="none"/>
+        <c:minorTickMark val="none"/>
+        <c:spPr>
+          <a:ln xmlns:a="http://schemas.openxmlformats.org/drawingml/2006/main" w="9525">
+            <a:solidFill>
+              <a:srgbClr val="D4D4D4"/>
+            </a:solidFill>
+            <a:prstDash val="solid"/>
+          </a:ln>
+        </c:spPr>
+        <c:txPr>
+          <a:bodyPr xmlns:a="http://schemas.openxmlformats.org/drawingml/2006/main" anchorCtr="1"/>
+          <a:lstStyle xmlns:a="http://schemas.openxmlformats.org/drawingml/2006/main"/>
+          <a:p xmlns:a="http://schemas.openxmlformats.org/drawingml/2006/main">
+            <a:pPr>
+              <a:defRPr sz="1950">
+                <a:solidFill>
+                  <a:srgbClr val="182C29"/>
+                </a:solidFill>
+                <a:latin typeface="Apple SD Gothic Neo"/>
+                <a:ea typeface="Apple SD Gothic Neo"/>
+                <a:cs typeface="Apple SD Gothic Neo"/>
+              </a:defRPr>
+            </a:pPr>
+          </a:p>
+        </c:txPr>
+        <c:crossAx val="48672768"/>
+      </c:catAx>
+      <c:valAx>
+        <c:axId val="48672768"/>
+        <c:scaling>
+          <c:orientation val="minMax"/>
+          <c:max val="5"/>
+          <c:min val="0"/>
+        </c:scaling>
+        <c:delete val="0"/>
+        <c:axPos val="l"/>
+        <c:title>
+          <c:tx>
+            <c:rich>
+              <a:bodyPr xmlns:a="http://schemas.openxmlformats.org/drawingml/2006/main"/>
+              <a:lstStyle xmlns:a="http://schemas.openxmlformats.org/drawingml/2006/main"/>
+              <a:p xmlns:a="http://schemas.openxmlformats.org/drawingml/2006/main">
+                <a:r>
+                  <a:rPr sz="1950">
+                    <a:solidFill>
+                      <a:srgbClr val="182C29"/>
+                    </a:solidFill>
+                    <a:latin typeface="Apple SD Gothic Neo"/>
+                    <a:ea typeface="Apple SD Gothic Neo"/>
+                    <a:cs typeface="Apple SD Gothic Neo"/>
+                  </a:rPr>
+                  <a:t>중앙 처리시간 (초)</a:t>
+                </a:r>
+              </a:p>
+            </c:rich>
+          </c:tx>
+          <c:overlay val="0"/>
+          <c:txPr>
+            <a:bodyPr xmlns:a="http://schemas.openxmlformats.org/drawingml/2006/main" anchorCtr="1"/>
+            <a:lstStyle xmlns:a="http://schemas.openxmlformats.org/drawingml/2006/main"/>
+            <a:p xmlns:a="http://schemas.openxmlformats.org/drawingml/2006/main">
+              <a:pPr>
+                <a:defRPr sz="1950">
+                  <a:solidFill>
+                    <a:srgbClr val="182C29"/>
+                  </a:solidFill>
+                  <a:latin typeface="Apple SD Gothic Neo"/>
+                  <a:ea typeface="Apple SD Gothic Neo"/>
+                  <a:cs typeface="Apple SD Gothic Neo"/>
+                </a:defRPr>
+              </a:pPr>
+            </a:p>
+          </c:txPr>
+        </c:title>
+        <c:numFmt formatCode="General"/>
+        <c:majorTickMark val="none"/>
+        <c:minorTickMark val="none"/>
+        <c:spPr>
+          <a:ln xmlns:a="http://schemas.openxmlformats.org/drawingml/2006/main" w="9525">
+            <a:solidFill>
+              <a:srgbClr val="D4D4D4"/>
+            </a:solidFill>
+            <a:prstDash val="solid"/>
+          </a:ln>
+        </c:spPr>
+        <c:txPr>
+          <a:bodyPr xmlns:a="http://schemas.openxmlformats.org/drawingml/2006/main" anchorCtr="1"/>
+          <a:lstStyle xmlns:a="http://schemas.openxmlformats.org/drawingml/2006/main"/>
+          <a:p xmlns:a="http://schemas.openxmlformats.org/drawingml/2006/main">
+            <a:pPr>
+              <a:defRPr sz="1800">
+                <a:solidFill>
+                  <a:srgbClr val="5E706B"/>
+                </a:solidFill>
+                <a:latin typeface="Apple SD Gothic Neo"/>
+                <a:ea typeface="Apple SD Gothic Neo"/>
+                <a:cs typeface="Apple SD Gothic Neo"/>
+              </a:defRPr>
+            </a:pPr>
+          </a:p>
+        </c:txPr>
+        <c:crossAx val="48650112"/>
+        <c:crossBetween val="between"/>
+        <c:majorUnit val="1"/>
+      </c:valAx>
+      <c:spPr>
+        <a:solidFill xmlns:a="http://schemas.openxmlformats.org/drawingml/2006/main">
+          <a:srgbClr val="F8F8F3"/>
+        </a:solidFill>
+      </c:spPr>
+    </c:plotArea>
+    <c:legend>
+      <c:legendPos val="b"/>
+      <c:overlay val="0"/>
+      <c:txPr>
+        <a:bodyPr xmlns:a="http://schemas.openxmlformats.org/drawingml/2006/main" anchorCtr="1"/>
+        <a:lstStyle xmlns:a="http://schemas.openxmlformats.org/drawingml/2006/main"/>
+        <a:p xmlns:a="http://schemas.openxmlformats.org/drawingml/2006/main">
+          <a:pPr>
+            <a:defRPr sz="1950">
+              <a:solidFill>
+                <a:srgbClr val="182C29"/>
+              </a:solidFill>
+              <a:latin typeface="Apple SD Gothic Neo"/>
+              <a:ea typeface="Apple SD Gothic Neo"/>
+              <a:cs typeface="Apple SD Gothic Neo"/>
+            </a:defRPr>
+          </a:pPr>
+        </a:p>
+      </c:txPr>
+    </c:legend>
+    <c:plotVisOnly val="1"/>
+  </c:chart>
+  <c:spPr>
+    <a:solidFill xmlns:a="http://schemas.openxmlformats.org/drawingml/2006/main">
+      <a:srgbClr val="F8F8F3"/>
+    </a:solidFill>
+  </c:spPr>
+  <c:externalData r:id="rIdChartSnapshot1">
+    <c:autoUpdate val="0"/>
+  </c:externalData>
+</c:chartSpace>
+</file>
+
 <file path=ppt/slides/slide1.xml><?xml version="1.0" encoding="utf-8"?>
 <p:sld xmlns:p="http://schemas.openxmlformats.org/presentationml/2006/main">
   <p:cSld>
@@ -2123,6 +2610,7 @@
           <a:lstStyle xmlns:a="http://schemas.openxmlformats.org/drawingml/2006/main"/>
           <a:p xmlns:a="http://schemas.openxmlformats.org/drawingml/2006/main">
             <a:pPr>
+              <a:buNone/>
               <a:defRPr sz="1350" b="0">
                 <a:solidFill>
                   <a:srgbClr val="5E706B"/>
@@ -2180,6 +2668,7 @@
           <a:lstStyle xmlns:a="http://schemas.openxmlformats.org/drawingml/2006/main"/>
           <a:p xmlns:a="http://schemas.openxmlformats.org/drawingml/2006/main">
             <a:pPr>
+              <a:buNone/>
               <a:defRPr sz="2100" b="0">
                 <a:solidFill>
                   <a:srgbClr val="B8D9C9"/>
@@ -2237,6 +2726,7 @@
           <a:lstStyle xmlns:a="http://schemas.openxmlformats.org/drawingml/2006/main"/>
           <a:p xmlns:a="http://schemas.openxmlformats.org/drawingml/2006/main">
             <a:pPr>
+              <a:buNone/>
               <a:defRPr sz="5100" b="1">
                 <a:solidFill>
                   <a:srgbClr val="FFFFFF"/>
@@ -2260,6 +2750,7 @@
           </a:p>
           <a:p xmlns:a="http://schemas.openxmlformats.org/drawingml/2006/main">
             <a:pPr>
+              <a:buNone/>
               <a:defRPr sz="5100" b="1">
                 <a:solidFill>
                   <a:srgbClr val="FFFFFF"/>
@@ -2317,6 +2808,7 @@
           <a:lstStyle xmlns:a="http://schemas.openxmlformats.org/drawingml/2006/main"/>
           <a:p xmlns:a="http://schemas.openxmlformats.org/drawingml/2006/main">
             <a:pPr>
+              <a:buNone/>
               <a:defRPr sz="2700" b="0">
                 <a:solidFill>
                   <a:srgbClr val="D8E7DE"/>
@@ -2374,6 +2866,7 @@
           <a:lstStyle xmlns:a="http://schemas.openxmlformats.org/drawingml/2006/main"/>
           <a:p xmlns:a="http://schemas.openxmlformats.org/drawingml/2006/main">
             <a:pPr>
+              <a:buNone/>
               <a:defRPr sz="2025" b="0">
                 <a:solidFill>
                   <a:srgbClr val="B8D9C9"/>
@@ -2460,6 +2953,7 @@
           <a:lstStyle xmlns:a="http://schemas.openxmlformats.org/drawingml/2006/main"/>
           <a:p xmlns:a="http://schemas.openxmlformats.org/drawingml/2006/main">
             <a:pPr>
+              <a:buNone/>
               <a:defRPr sz="3675" b="1">
                 <a:solidFill>
                   <a:srgbClr val="182C29"/>
@@ -2517,6 +3011,7 @@
           <a:lstStyle xmlns:a="http://schemas.openxmlformats.org/drawingml/2006/main"/>
           <a:p xmlns:a="http://schemas.openxmlformats.org/drawingml/2006/main">
             <a:pPr>
+              <a:buNone/>
               <a:defRPr sz="2100" b="0">
                 <a:solidFill>
                   <a:srgbClr val="5E706B"/>
@@ -2574,6 +3069,7 @@
           <a:lstStyle xmlns:a="http://schemas.openxmlformats.org/drawingml/2006/main"/>
           <a:p xmlns:a="http://schemas.openxmlformats.org/drawingml/2006/main">
             <a:pPr>
+              <a:buNone/>
               <a:defRPr sz="1350" b="0">
                 <a:solidFill>
                   <a:srgbClr val="5E706B"/>
@@ -2631,14 +3127,14 @@
       </p:sp>
       <p:pic>
         <p:nvPicPr>
-          <p:cNvPr id="14" name=""/>
+          <p:cNvPr id="16" name=""/>
           <p:cNvPicPr>
             <a:picLocks xmlns:a="http://schemas.openxmlformats.org/drawingml/2006/main" noChangeAspect="1"/>
           </p:cNvPicPr>
           <p:nvPr/>
         </p:nvPicPr>
         <p:blipFill>
-          <a:blip xmlns:r="http://schemas.openxmlformats.org/officeDocument/2006/relationships" xmlns:a="http://schemas.openxmlformats.org/drawingml/2006/main" r:embed="R8c6b1be854324325"/>
+          <a:blip xmlns:r="http://schemas.openxmlformats.org/officeDocument/2006/relationships" xmlns:a="http://schemas.openxmlformats.org/drawingml/2006/main" r:embed="Ra655bc335cb84b21"/>
           <a:stretch xmlns:a="http://schemas.openxmlformats.org/drawingml/2006/main"/>
         </p:blipFill>
         <p:spPr>
@@ -2685,6 +3181,7 @@
           <a:lstStyle xmlns:a="http://schemas.openxmlformats.org/drawingml/2006/main"/>
           <a:p xmlns:a="http://schemas.openxmlformats.org/drawingml/2006/main">
             <a:pPr>
+              <a:buNone/>
               <a:defRPr sz="2550" b="1">
                 <a:solidFill>
                   <a:srgbClr val="156E58"/>
@@ -2742,6 +3239,7 @@
           <a:lstStyle xmlns:a="http://schemas.openxmlformats.org/drawingml/2006/main"/>
           <a:p xmlns:a="http://schemas.openxmlformats.org/drawingml/2006/main">
             <a:pPr>
+              <a:buNone/>
               <a:defRPr sz="2250" b="0">
                 <a:solidFill>
                   <a:srgbClr val="182C29"/>
@@ -2765,6 +3263,7 @@
           </a:p>
           <a:p xmlns:a="http://schemas.openxmlformats.org/drawingml/2006/main">
             <a:pPr>
+              <a:buNone/>
               <a:defRPr sz="2250" b="0">
                 <a:solidFill>
                   <a:srgbClr val="182C29"/>
@@ -2822,6 +3321,7 @@
           <a:lstStyle xmlns:a="http://schemas.openxmlformats.org/drawingml/2006/main"/>
           <a:p xmlns:a="http://schemas.openxmlformats.org/drawingml/2006/main">
             <a:pPr>
+              <a:buNone/>
               <a:defRPr sz="2550" b="1">
                 <a:solidFill>
                   <a:srgbClr val="156E58"/>
@@ -2879,6 +3379,7 @@
           <a:lstStyle xmlns:a="http://schemas.openxmlformats.org/drawingml/2006/main"/>
           <a:p xmlns:a="http://schemas.openxmlformats.org/drawingml/2006/main">
             <a:pPr>
+              <a:buNone/>
               <a:defRPr sz="2250" b="0">
                 <a:solidFill>
                   <a:srgbClr val="182C29"/>
@@ -2902,6 +3403,7 @@
           </a:p>
           <a:p xmlns:a="http://schemas.openxmlformats.org/drawingml/2006/main">
             <a:pPr>
+              <a:buNone/>
               <a:defRPr sz="2250" b="0">
                 <a:solidFill>
                   <a:srgbClr val="182C29"/>
@@ -2925,6 +3427,7 @@
           </a:p>
           <a:p xmlns:a="http://schemas.openxmlformats.org/drawingml/2006/main">
             <a:pPr>
+              <a:buNone/>
               <a:defRPr sz="2250" b="0">
                 <a:solidFill>
                   <a:srgbClr val="182C29"/>
@@ -3011,6 +3514,7 @@
           <a:lstStyle xmlns:a="http://schemas.openxmlformats.org/drawingml/2006/main"/>
           <a:p xmlns:a="http://schemas.openxmlformats.org/drawingml/2006/main">
             <a:pPr>
+              <a:buNone/>
               <a:defRPr sz="3675" b="1">
                 <a:solidFill>
                   <a:srgbClr val="182C29"/>
@@ -3068,6 +3572,7 @@
           <a:lstStyle xmlns:a="http://schemas.openxmlformats.org/drawingml/2006/main"/>
           <a:p xmlns:a="http://schemas.openxmlformats.org/drawingml/2006/main">
             <a:pPr>
+              <a:buNone/>
               <a:defRPr sz="2100" b="0">
                 <a:solidFill>
                   <a:srgbClr val="5E706B"/>
@@ -3125,6 +3630,7 @@
           <a:lstStyle xmlns:a="http://schemas.openxmlformats.org/drawingml/2006/main"/>
           <a:p xmlns:a="http://schemas.openxmlformats.org/drawingml/2006/main">
             <a:pPr>
+              <a:buNone/>
               <a:defRPr sz="1350" b="0">
                 <a:solidFill>
                   <a:srgbClr val="5E706B"/>
@@ -3184,6 +3690,7 @@
           <a:lstStyle xmlns:a="http://schemas.openxmlformats.org/drawingml/2006/main"/>
           <a:p xmlns:a="http://schemas.openxmlformats.org/drawingml/2006/main">
             <a:pPr algn="ctr">
+              <a:buNone/>
               <a:defRPr sz="2175" b="1">
                 <a:solidFill>
                   <a:srgbClr val="182C29"/>
@@ -3243,6 +3750,7 @@
           <a:lstStyle xmlns:a="http://schemas.openxmlformats.org/drawingml/2006/main"/>
           <a:p xmlns:a="http://schemas.openxmlformats.org/drawingml/2006/main">
             <a:pPr algn="ctr">
+              <a:buNone/>
               <a:defRPr sz="2175" b="1">
                 <a:solidFill>
                   <a:srgbClr val="182C29"/>
@@ -3268,7 +3776,7 @@
       </p:sp>
       <p:cxnSp>
         <p:nvCxnSpPr>
-          <p:cNvPr id="19" name=""/>
+          <p:cNvPr id="27" name=""/>
           <p:cNvCxnSpPr>
             <a:stCxn xmlns:a="http://schemas.openxmlformats.org/drawingml/2006/main" id="4" idx="3"/>
             <a:endCxn xmlns:a="http://schemas.openxmlformats.org/drawingml/2006/main" id="5" idx="1"/>
@@ -3327,6 +3835,7 @@
           <a:lstStyle xmlns:a="http://schemas.openxmlformats.org/drawingml/2006/main"/>
           <a:p xmlns:a="http://schemas.openxmlformats.org/drawingml/2006/main">
             <a:pPr algn="ctr">
+              <a:buNone/>
               <a:defRPr sz="2175" b="1">
                 <a:solidFill>
                   <a:srgbClr val="182C29"/>
@@ -3352,7 +3861,7 @@
       </p:sp>
       <p:cxnSp>
         <p:nvCxnSpPr>
-          <p:cNvPr id="21" name=""/>
+          <p:cNvPr id="29" name=""/>
           <p:cNvCxnSpPr>
             <a:stCxn xmlns:a="http://schemas.openxmlformats.org/drawingml/2006/main" id="5" idx="3"/>
             <a:endCxn xmlns:a="http://schemas.openxmlformats.org/drawingml/2006/main" id="7" idx="1"/>
@@ -3409,6 +3918,7 @@
           <a:lstStyle xmlns:a="http://schemas.openxmlformats.org/drawingml/2006/main"/>
           <a:p xmlns:a="http://schemas.openxmlformats.org/drawingml/2006/main">
             <a:pPr>
+              <a:buNone/>
               <a:defRPr sz="2325" b="0">
                 <a:solidFill>
                   <a:srgbClr val="182C29"/>
@@ -3432,6 +3942,7 @@
           </a:p>
           <a:p xmlns:a="http://schemas.openxmlformats.org/drawingml/2006/main">
             <a:pPr>
+              <a:buNone/>
               <a:defRPr sz="2325" b="0">
                 <a:solidFill>
                   <a:srgbClr val="182C29"/>
@@ -3489,6 +4000,7 @@
           <a:lstStyle xmlns:a="http://schemas.openxmlformats.org/drawingml/2006/main"/>
           <a:p xmlns:a="http://schemas.openxmlformats.org/drawingml/2006/main">
             <a:pPr>
+              <a:buNone/>
               <a:defRPr sz="2325" b="0">
                 <a:solidFill>
                   <a:srgbClr val="182C29"/>
@@ -3512,6 +4024,7 @@
           </a:p>
           <a:p xmlns:a="http://schemas.openxmlformats.org/drawingml/2006/main">
             <a:pPr>
+              <a:buNone/>
               <a:defRPr sz="2325" b="0">
                 <a:solidFill>
                   <a:srgbClr val="182C29"/>
@@ -3569,6 +4082,7 @@
           <a:lstStyle xmlns:a="http://schemas.openxmlformats.org/drawingml/2006/main"/>
           <a:p xmlns:a="http://schemas.openxmlformats.org/drawingml/2006/main">
             <a:pPr>
+              <a:buNone/>
               <a:defRPr sz="2175" b="0">
                 <a:solidFill>
                   <a:srgbClr val="182C29"/>
@@ -3592,6 +4106,7 @@
           </a:p>
           <a:p xmlns:a="http://schemas.openxmlformats.org/drawingml/2006/main">
             <a:pPr>
+              <a:buNone/>
               <a:defRPr sz="2175" b="0">
                 <a:solidFill>
                   <a:srgbClr val="182C29"/>
@@ -3649,6 +4164,7 @@
           <a:lstStyle xmlns:a="http://schemas.openxmlformats.org/drawingml/2006/main"/>
           <a:p xmlns:a="http://schemas.openxmlformats.org/drawingml/2006/main">
             <a:pPr>
+              <a:buNone/>
               <a:defRPr sz="2325" b="0">
                 <a:solidFill>
                   <a:srgbClr val="182C29"/>
@@ -3706,6 +4222,7 @@
           <a:lstStyle xmlns:a="http://schemas.openxmlformats.org/drawingml/2006/main"/>
           <a:p xmlns:a="http://schemas.openxmlformats.org/drawingml/2006/main">
             <a:pPr>
+              <a:buNone/>
               <a:defRPr sz="1800" b="0">
                 <a:solidFill>
                   <a:srgbClr val="5E706B"/>
@@ -3792,6 +4309,7 @@
           <a:lstStyle xmlns:a="http://schemas.openxmlformats.org/drawingml/2006/main"/>
           <a:p xmlns:a="http://schemas.openxmlformats.org/drawingml/2006/main">
             <a:pPr>
+              <a:buNone/>
               <a:defRPr sz="3675" b="1">
                 <a:solidFill>
                   <a:srgbClr val="182C29"/>
@@ -3849,6 +4367,7 @@
           <a:lstStyle xmlns:a="http://schemas.openxmlformats.org/drawingml/2006/main"/>
           <a:p xmlns:a="http://schemas.openxmlformats.org/drawingml/2006/main">
             <a:pPr>
+              <a:buNone/>
               <a:defRPr sz="2100" b="0">
                 <a:solidFill>
                   <a:srgbClr val="5E706B"/>
@@ -3906,6 +4425,7 @@
           <a:lstStyle xmlns:a="http://schemas.openxmlformats.org/drawingml/2006/main"/>
           <a:p xmlns:a="http://schemas.openxmlformats.org/drawingml/2006/main">
             <a:pPr>
+              <a:buNone/>
               <a:defRPr sz="1350" b="0">
                 <a:solidFill>
                   <a:srgbClr val="5E706B"/>
@@ -3931,7 +4451,7 @@
       </p:sp>
       <p:graphicFrame>
         <p:nvGraphicFramePr>
-          <p:cNvPr id="9" name=""/>
+          <p:cNvPr id="11" name=""/>
           <p:cNvGraphicFramePr/>
           <p:nvPr/>
         </p:nvGraphicFramePr>
@@ -4508,6 +5028,7 @@
           <a:lstStyle xmlns:a="http://schemas.openxmlformats.org/drawingml/2006/main"/>
           <a:p xmlns:a="http://schemas.openxmlformats.org/drawingml/2006/main">
             <a:pPr>
+              <a:buNone/>
               <a:defRPr sz="1725" b="0">
                 <a:solidFill>
                   <a:srgbClr val="5E706B"/>
@@ -4594,6 +5115,7 @@
           <a:lstStyle xmlns:a="http://schemas.openxmlformats.org/drawingml/2006/main"/>
           <a:p xmlns:a="http://schemas.openxmlformats.org/drawingml/2006/main">
             <a:pPr>
+              <a:buNone/>
               <a:defRPr sz="3675" b="1">
                 <a:solidFill>
                   <a:srgbClr val="182C29"/>
@@ -4651,6 +5173,7 @@
           <a:lstStyle xmlns:a="http://schemas.openxmlformats.org/drawingml/2006/main"/>
           <a:p xmlns:a="http://schemas.openxmlformats.org/drawingml/2006/main">
             <a:pPr>
+              <a:buNone/>
               <a:defRPr sz="2100" b="0">
                 <a:solidFill>
                   <a:srgbClr val="5E706B"/>
@@ -4708,6 +5231,7 @@
           <a:lstStyle xmlns:a="http://schemas.openxmlformats.org/drawingml/2006/main"/>
           <a:p xmlns:a="http://schemas.openxmlformats.org/drawingml/2006/main">
             <a:pPr>
+              <a:buNone/>
               <a:defRPr sz="1350" b="0">
                 <a:solidFill>
                   <a:srgbClr val="5E706B"/>
@@ -4733,7 +5257,7 @@
       </p:sp>
       <p:graphicFrame>
         <p:nvGraphicFramePr>
-          <p:cNvPr id="9" name=""/>
+          <p:cNvPr id="11" name=""/>
           <p:cNvGraphicFramePr/>
           <p:nvPr/>
         </p:nvGraphicFramePr>
@@ -4963,6 +5487,7 @@
           <a:lstStyle xmlns:a="http://schemas.openxmlformats.org/drawingml/2006/main"/>
           <a:p xmlns:a="http://schemas.openxmlformats.org/drawingml/2006/main">
             <a:pPr>
+              <a:buNone/>
               <a:defRPr sz="2100" b="0">
                 <a:solidFill>
                   <a:srgbClr val="182C29"/>
@@ -4986,6 +5511,7 @@
           </a:p>
           <a:p xmlns:a="http://schemas.openxmlformats.org/drawingml/2006/main">
             <a:pPr>
+              <a:buNone/>
               <a:defRPr sz="2100" b="0">
                 <a:solidFill>
                   <a:srgbClr val="182C29"/>
@@ -5072,6 +5598,7 @@
           <a:lstStyle xmlns:a="http://schemas.openxmlformats.org/drawingml/2006/main"/>
           <a:p xmlns:a="http://schemas.openxmlformats.org/drawingml/2006/main">
             <a:pPr>
+              <a:buNone/>
               <a:defRPr sz="3675" b="1">
                 <a:solidFill>
                   <a:srgbClr val="182C29"/>
@@ -5129,6 +5656,7 @@
           <a:lstStyle xmlns:a="http://schemas.openxmlformats.org/drawingml/2006/main"/>
           <a:p xmlns:a="http://schemas.openxmlformats.org/drawingml/2006/main">
             <a:pPr>
+              <a:buNone/>
               <a:defRPr sz="2100" b="0">
                 <a:solidFill>
                   <a:srgbClr val="5E706B"/>
@@ -5186,6 +5714,7 @@
           <a:lstStyle xmlns:a="http://schemas.openxmlformats.org/drawingml/2006/main"/>
           <a:p xmlns:a="http://schemas.openxmlformats.org/drawingml/2006/main">
             <a:pPr>
+              <a:buNone/>
               <a:defRPr sz="1350" b="0">
                 <a:solidFill>
                   <a:srgbClr val="5E706B"/>
@@ -5243,6 +5772,7 @@
           <a:lstStyle xmlns:a="http://schemas.openxmlformats.org/drawingml/2006/main"/>
           <a:p xmlns:a="http://schemas.openxmlformats.org/drawingml/2006/main">
             <a:pPr>
+              <a:buNone/>
               <a:defRPr sz="2700" b="1">
                 <a:solidFill>
                   <a:srgbClr val="156E58"/>
@@ -5300,6 +5830,7 @@
           <a:lstStyle xmlns:a="http://schemas.openxmlformats.org/drawingml/2006/main"/>
           <a:p xmlns:a="http://schemas.openxmlformats.org/drawingml/2006/main">
             <a:pPr>
+              <a:buNone/>
               <a:defRPr sz="2325" b="0">
                 <a:solidFill>
                   <a:srgbClr val="182C29"/>
@@ -5323,6 +5854,7 @@
           </a:p>
           <a:p xmlns:a="http://schemas.openxmlformats.org/drawingml/2006/main">
             <a:pPr>
+              <a:buNone/>
               <a:defRPr sz="2325" b="0">
                 <a:solidFill>
                   <a:srgbClr val="182C29"/>
@@ -5351,6 +5883,7 @@
           </a:p>
           <a:p xmlns:a="http://schemas.openxmlformats.org/drawingml/2006/main">
             <a:pPr>
+              <a:buNone/>
               <a:defRPr sz="2325" b="0">
                 <a:solidFill>
                   <a:srgbClr val="182C29"/>
@@ -5374,6 +5907,7 @@
           </a:p>
           <a:p xmlns:a="http://schemas.openxmlformats.org/drawingml/2006/main">
             <a:pPr>
+              <a:buNone/>
               <a:defRPr sz="2325" b="0">
                 <a:solidFill>
                   <a:srgbClr val="182C29"/>
@@ -5431,6 +5965,7 @@
           <a:lstStyle xmlns:a="http://schemas.openxmlformats.org/drawingml/2006/main"/>
           <a:p xmlns:a="http://schemas.openxmlformats.org/drawingml/2006/main">
             <a:pPr>
+              <a:buNone/>
               <a:defRPr sz="2700" b="1">
                 <a:solidFill>
                   <a:srgbClr val="156E58"/>
@@ -5488,6 +6023,7 @@
           <a:lstStyle xmlns:a="http://schemas.openxmlformats.org/drawingml/2006/main"/>
           <a:p xmlns:a="http://schemas.openxmlformats.org/drawingml/2006/main">
             <a:pPr>
+              <a:buNone/>
               <a:defRPr sz="2325" b="0">
                 <a:solidFill>
                   <a:srgbClr val="182C29"/>
@@ -5511,6 +6047,7 @@
           </a:p>
           <a:p xmlns:a="http://schemas.openxmlformats.org/drawingml/2006/main">
             <a:pPr>
+              <a:buNone/>
               <a:defRPr sz="2325" b="0">
                 <a:solidFill>
                   <a:srgbClr val="182C29"/>
@@ -5539,6 +6076,7 @@
           </a:p>
           <a:p xmlns:a="http://schemas.openxmlformats.org/drawingml/2006/main">
             <a:pPr>
+              <a:buNone/>
               <a:defRPr sz="2325" b="0">
                 <a:solidFill>
                   <a:srgbClr val="182C29"/>
@@ -5562,6 +6100,7 @@
           </a:p>
           <a:p xmlns:a="http://schemas.openxmlformats.org/drawingml/2006/main">
             <a:pPr>
+              <a:buNone/>
               <a:defRPr sz="2325" b="0">
                 <a:solidFill>
                   <a:srgbClr val="182C29"/>
@@ -5619,6 +6158,7 @@
           <a:lstStyle xmlns:a="http://schemas.openxmlformats.org/drawingml/2006/main"/>
           <a:p xmlns:a="http://schemas.openxmlformats.org/drawingml/2006/main">
             <a:pPr>
+              <a:buNone/>
               <a:defRPr sz="2100" b="0">
                 <a:solidFill>
                   <a:srgbClr val="182C29"/>
@@ -5642,6 +6182,7 @@
           </a:p>
           <a:p xmlns:a="http://schemas.openxmlformats.org/drawingml/2006/main">
             <a:pPr>
+              <a:buNone/>
               <a:defRPr sz="2100" b="0">
                 <a:solidFill>
                   <a:srgbClr val="182C29"/>
@@ -5699,6 +6240,7 @@
           <a:lstStyle xmlns:a="http://schemas.openxmlformats.org/drawingml/2006/main"/>
           <a:p xmlns:a="http://schemas.openxmlformats.org/drawingml/2006/main">
             <a:pPr>
+              <a:buNone/>
               <a:defRPr sz="1575" b="0">
                 <a:solidFill>
                   <a:srgbClr val="5E706B"/>
@@ -5785,6 +6327,7 @@
           <a:lstStyle xmlns:a="http://schemas.openxmlformats.org/drawingml/2006/main"/>
           <a:p xmlns:a="http://schemas.openxmlformats.org/drawingml/2006/main">
             <a:pPr>
+              <a:buNone/>
               <a:defRPr sz="3675" b="1">
                 <a:solidFill>
                   <a:srgbClr val="182C29"/>
@@ -5842,6 +6385,7 @@
           <a:lstStyle xmlns:a="http://schemas.openxmlformats.org/drawingml/2006/main"/>
           <a:p xmlns:a="http://schemas.openxmlformats.org/drawingml/2006/main">
             <a:pPr>
+              <a:buNone/>
               <a:defRPr sz="2100" b="0">
                 <a:solidFill>
                   <a:srgbClr val="5E706B"/>
@@ -5899,6 +6443,7 @@
           <a:lstStyle xmlns:a="http://schemas.openxmlformats.org/drawingml/2006/main"/>
           <a:p xmlns:a="http://schemas.openxmlformats.org/drawingml/2006/main">
             <a:pPr>
+              <a:buNone/>
               <a:defRPr sz="1350" b="0">
                 <a:solidFill>
                   <a:srgbClr val="5E706B"/>
@@ -5956,6 +6501,7 @@
           <a:lstStyle xmlns:a="http://schemas.openxmlformats.org/drawingml/2006/main"/>
           <a:p xmlns:a="http://schemas.openxmlformats.org/drawingml/2006/main">
             <a:pPr>
+              <a:buNone/>
               <a:defRPr sz="2475" b="0">
                 <a:solidFill>
                   <a:srgbClr val="182C29"/>
@@ -5979,6 +6525,7 @@
           </a:p>
           <a:p xmlns:a="http://schemas.openxmlformats.org/drawingml/2006/main">
             <a:pPr>
+              <a:buNone/>
               <a:defRPr sz="2475" b="0">
                 <a:solidFill>
                   <a:srgbClr val="182C29"/>
@@ -6038,6 +6585,7 @@
           <a:lstStyle xmlns:a="http://schemas.openxmlformats.org/drawingml/2006/main"/>
           <a:p xmlns:a="http://schemas.openxmlformats.org/drawingml/2006/main">
             <a:pPr algn="ctr">
+              <a:buNone/>
               <a:defRPr sz="2175" b="1">
                 <a:solidFill>
                   <a:srgbClr val="182C29"/>
@@ -6097,6 +6645,7 @@
           <a:lstStyle xmlns:a="http://schemas.openxmlformats.org/drawingml/2006/main"/>
           <a:p xmlns:a="http://schemas.openxmlformats.org/drawingml/2006/main">
             <a:pPr algn="ctr">
+              <a:buNone/>
               <a:defRPr sz="2175" b="1">
                 <a:solidFill>
                   <a:srgbClr val="182C29"/>
@@ -6122,7 +6671,7 @@
       </p:sp>
       <p:cxnSp>
         <p:nvCxnSpPr>
-          <p:cNvPr id="18" name=""/>
+          <p:cNvPr id="27" name=""/>
           <p:cNvCxnSpPr>
             <a:stCxn xmlns:a="http://schemas.openxmlformats.org/drawingml/2006/main" id="5" idx="3"/>
             <a:endCxn xmlns:a="http://schemas.openxmlformats.org/drawingml/2006/main" id="6" idx="1"/>
@@ -6181,6 +6730,7 @@
           <a:lstStyle xmlns:a="http://schemas.openxmlformats.org/drawingml/2006/main"/>
           <a:p xmlns:a="http://schemas.openxmlformats.org/drawingml/2006/main">
             <a:pPr algn="ctr">
+              <a:buNone/>
               <a:defRPr sz="2175" b="1">
                 <a:solidFill>
                   <a:srgbClr val="182C29"/>
@@ -6206,7 +6756,7 @@
       </p:sp>
       <p:cxnSp>
         <p:nvCxnSpPr>
-          <p:cNvPr id="20" name=""/>
+          <p:cNvPr id="29" name=""/>
           <p:cNvCxnSpPr>
             <a:stCxn xmlns:a="http://schemas.openxmlformats.org/drawingml/2006/main" id="6" idx="3"/>
             <a:endCxn xmlns:a="http://schemas.openxmlformats.org/drawingml/2006/main" id="8" idx="1"/>
@@ -6263,6 +6813,7 @@
           <a:lstStyle xmlns:a="http://schemas.openxmlformats.org/drawingml/2006/main"/>
           <a:p xmlns:a="http://schemas.openxmlformats.org/drawingml/2006/main">
             <a:pPr>
+              <a:buNone/>
               <a:defRPr sz="2475" b="0">
                 <a:solidFill>
                   <a:srgbClr val="182C29"/>
@@ -6286,6 +6837,7 @@
           </a:p>
           <a:p xmlns:a="http://schemas.openxmlformats.org/drawingml/2006/main">
             <a:pPr>
+              <a:buNone/>
               <a:defRPr sz="2475" b="0">
                 <a:solidFill>
                   <a:srgbClr val="182C29"/>
@@ -6309,6 +6861,7 @@
           </a:p>
           <a:p xmlns:a="http://schemas.openxmlformats.org/drawingml/2006/main">
             <a:pPr>
+              <a:buNone/>
               <a:defRPr sz="2475" b="0">
                 <a:solidFill>
                   <a:srgbClr val="182C29"/>
@@ -6366,6 +6919,7 @@
           <a:lstStyle xmlns:a="http://schemas.openxmlformats.org/drawingml/2006/main"/>
           <a:p xmlns:a="http://schemas.openxmlformats.org/drawingml/2006/main">
             <a:pPr>
+              <a:buNone/>
               <a:defRPr sz="1575" b="0">
                 <a:solidFill>
                   <a:srgbClr val="5E706B"/>
@@ -6393,6 +6947,1950 @@
     <p:extLst>
       <p:ext uri="{BB962C8B-B14F-4D97-AF65-F5344CB8AC3E}">
         <p14:creationId xmlns:p14="http://schemas.microsoft.com/office/powerpoint/2010/main" val="65866022"/>
+      </p:ext>
+    </p:extLst>
+  </p:cSld>
+</p:sld>
+</file>
+
+<file path=ppt/slides/slide16.xml><?xml version="1.0" encoding="utf-8"?>
+<p:sld xmlns:p="http://schemas.openxmlformats.org/presentationml/2006/main">
+  <p:cSld>
+    <p:bg>
+      <p:bgPr>
+        <a:solidFill xmlns:a="http://schemas.openxmlformats.org/drawingml/2006/main">
+          <a:srgbClr val="F8F8F3"/>
+        </a:solidFill>
+      </p:bgPr>
+    </p:bg>
+    <p:spTree>
+      <p:nvGrpSpPr>
+        <p:cNvPr id="1" name=""/>
+        <p:cNvGrpSpPr/>
+        <p:nvPr/>
+      </p:nvGrpSpPr>
+      <p:grpSpPr>
+        <a:xfrm xmlns:a="http://schemas.openxmlformats.org/drawingml/2006/main"/>
+      </p:grpSpPr>
+      <p:sp>
+        <p:nvSpPr>
+          <p:cNvPr id="8" name="">
+            <a:extLst xmlns:a="http://schemas.openxmlformats.org/drawingml/2006/main">
+              <a:ext uri="{FF2B5EF4-FFF2-40B4-BE49-F238E27FC236}">
+                <a16:creationId xmlns:a16="http://schemas.microsoft.com/office/drawing/2014/main" id="{32208E57-18E6-46B5-8C98-0B617BA6AF3E}"/>
+              </a:ext>
+            </a:extLst>
+          </p:cNvPr>
+          <p:cNvSpPr>
+            <a:spLocks xmlns:a="http://schemas.openxmlformats.org/drawingml/2006/main" noGrp="1"/>
+          </p:cNvSpPr>
+          <p:nvPr/>
+        </p:nvSpPr>
+        <p:spPr>
+          <a:xfrm xmlns:a="http://schemas.openxmlformats.org/drawingml/2006/main">
+            <a:off x="800100" y="609600"/>
+            <a:ext cx="13620750" cy="781050"/>
+          </a:xfrm>
+          <a:prstGeom xmlns:a="http://schemas.openxmlformats.org/drawingml/2006/main" prst="rect">
+            <a:avLst/>
+          </a:prstGeom>
+          <a:noFill xmlns:a="http://schemas.openxmlformats.org/drawingml/2006/main"/>
+          <a:ln xmlns:a="http://schemas.openxmlformats.org/drawingml/2006/main" w="0">
+            <a:noFill/>
+          </a:ln>
+        </p:spPr>
+        <p:txBody>
+          <a:bodyPr xmlns:a="http://schemas.openxmlformats.org/drawingml/2006/main" wrap="square" lIns="0" tIns="0" rIns="0" bIns="0">
+            <a:noAutofit/>
+          </a:bodyPr>
+          <a:lstStyle xmlns:a="http://schemas.openxmlformats.org/drawingml/2006/main"/>
+          <a:p xmlns:a="http://schemas.openxmlformats.org/drawingml/2006/main">
+            <a:pPr>
+              <a:defRPr sz="3675" b="1">
+                <a:solidFill>
+                  <a:srgbClr val="182C29"/>
+                </a:solidFill>
+                <a:latin typeface="Apple SD Gothic Neo"/>
+                <a:ea typeface="Apple SD Gothic Neo"/>
+                <a:cs typeface="Apple SD Gothic Neo"/>
+              </a:defRPr>
+            </a:pPr>
+            <a:r>
+              <a:rPr sz="3675" b="1">
+                <a:solidFill>
+                  <a:srgbClr val="182C29"/>
+                </a:solidFill>
+                <a:latin typeface="Apple SD Gothic Neo"/>
+                <a:ea typeface="Apple SD Gothic Neo"/>
+                <a:cs typeface="Apple SD Gothic Neo"/>
+              </a:rPr>
+              <a:t>부록 · Jev 판단 모델 비교 실험</a:t>
+            </a:r>
+          </a:p>
+        </p:txBody>
+      </p:sp>
+      <p:sp>
+        <p:nvSpPr>
+          <p:cNvPr id="2" name="">
+            <a:extLst xmlns:a="http://schemas.openxmlformats.org/drawingml/2006/main">
+              <a:ext uri="{FF2B5EF4-FFF2-40B4-BE49-F238E27FC236}">
+                <a16:creationId xmlns:a16="http://schemas.microsoft.com/office/drawing/2014/main" id="{EF7A26ED-E82B-4BBB-8FAA-EE00C720382B}"/>
+              </a:ext>
+            </a:extLst>
+          </p:cNvPr>
+          <p:cNvSpPr>
+            <a:spLocks xmlns:a="http://schemas.openxmlformats.org/drawingml/2006/main" noGrp="1"/>
+          </p:cNvSpPr>
+          <p:nvPr/>
+        </p:nvSpPr>
+        <p:spPr>
+          <a:xfrm xmlns:a="http://schemas.openxmlformats.org/drawingml/2006/main">
+            <a:off x="819150" y="1533525"/>
+            <a:ext cx="13525500" cy="781050"/>
+          </a:xfrm>
+          <a:prstGeom xmlns:a="http://schemas.openxmlformats.org/drawingml/2006/main" prst="rect">
+            <a:avLst/>
+          </a:prstGeom>
+          <a:noFill xmlns:a="http://schemas.openxmlformats.org/drawingml/2006/main"/>
+          <a:ln xmlns:a="http://schemas.openxmlformats.org/drawingml/2006/main" w="0">
+            <a:noFill/>
+          </a:ln>
+        </p:spPr>
+        <p:txBody>
+          <a:bodyPr xmlns:a="http://schemas.openxmlformats.org/drawingml/2006/main" wrap="square" lIns="0" tIns="0" rIns="0" bIns="0">
+            <a:noAutofit/>
+          </a:bodyPr>
+          <a:lstStyle xmlns:a="http://schemas.openxmlformats.org/drawingml/2006/main"/>
+          <a:p xmlns:a="http://schemas.openxmlformats.org/drawingml/2006/main">
+            <a:pPr>
+              <a:defRPr sz="2100" b="0">
+                <a:solidFill>
+                  <a:srgbClr val="5E706B"/>
+                </a:solidFill>
+                <a:latin typeface="Apple SD Gothic Neo"/>
+                <a:ea typeface="Apple SD Gothic Neo"/>
+                <a:cs typeface="Apple SD Gothic Neo"/>
+              </a:defRPr>
+            </a:pPr>
+            <a:r>
+              <a:rPr sz="2100" b="0">
+                <a:solidFill>
+                  <a:srgbClr val="5E706B"/>
+                </a:solidFill>
+                <a:latin typeface="Apple SD Gothic Neo"/>
+                <a:ea typeface="Apple SD Gothic Neo"/>
+                <a:cs typeface="Apple SD Gothic Neo"/>
+              </a:rPr>
+              <a:t>관세 후보 선택의 처리시간과 품질을 따로 측정했습니다.</a:t>
+            </a:r>
+          </a:p>
+        </p:txBody>
+      </p:sp>
+      <p:sp>
+        <p:nvSpPr>
+          <p:cNvPr id="3" name="">
+            <a:extLst xmlns:a="http://schemas.openxmlformats.org/drawingml/2006/main">
+              <a:ext uri="{FF2B5EF4-FFF2-40B4-BE49-F238E27FC236}">
+                <a16:creationId xmlns:a16="http://schemas.microsoft.com/office/drawing/2014/main" id="{C57488CA-0878-4414-A0DC-BE367E4438A7}"/>
+              </a:ext>
+            </a:extLst>
+          </p:cNvPr>
+          <p:cNvSpPr>
+            <a:spLocks xmlns:a="http://schemas.openxmlformats.org/drawingml/2006/main" noGrp="1"/>
+          </p:cNvSpPr>
+          <p:nvPr/>
+        </p:nvSpPr>
+        <p:spPr>
+          <a:xfrm xmlns:a="http://schemas.openxmlformats.org/drawingml/2006/main">
+            <a:off x="819150" y="8058150"/>
+            <a:ext cx="13620750" cy="285750"/>
+          </a:xfrm>
+          <a:prstGeom xmlns:a="http://schemas.openxmlformats.org/drawingml/2006/main" prst="rect">
+            <a:avLst/>
+          </a:prstGeom>
+          <a:noFill xmlns:a="http://schemas.openxmlformats.org/drawingml/2006/main"/>
+          <a:ln xmlns:a="http://schemas.openxmlformats.org/drawingml/2006/main" w="0">
+            <a:noFill/>
+          </a:ln>
+        </p:spPr>
+        <p:txBody>
+          <a:bodyPr xmlns:a="http://schemas.openxmlformats.org/drawingml/2006/main" wrap="square" lIns="0" tIns="0" rIns="0" bIns="0">
+            <a:noAutofit/>
+          </a:bodyPr>
+          <a:lstStyle xmlns:a="http://schemas.openxmlformats.org/drawingml/2006/main"/>
+          <a:p xmlns:a="http://schemas.openxmlformats.org/drawingml/2006/main">
+            <a:pPr>
+              <a:defRPr sz="1350" b="0">
+                <a:solidFill>
+                  <a:srgbClr val="5E706B"/>
+                </a:solidFill>
+                <a:latin typeface="Apple SD Gothic Neo"/>
+                <a:ea typeface="Apple SD Gothic Neo"/>
+                <a:cs typeface="Apple SD Gothic Neo"/>
+              </a:defRPr>
+            </a:pPr>
+            <a:r>
+              <a:rPr sz="1350" b="0">
+                <a:solidFill>
+                  <a:srgbClr val="5E706B"/>
+                </a:solidFill>
+                <a:latin typeface="Apple SD Gothic Neo"/>
+                <a:ea typeface="Apple SD Gothic Neo"/>
+                <a:cs typeface="Apple SD Gothic Neo"/>
+              </a:rPr>
+              <a:t>16   윤장한 · 직구 조사와 도구 구현 · 부록 · 2026.10.06</a:t>
+            </a:r>
+          </a:p>
+        </p:txBody>
+      </p:sp>
+      <p:sp>
+        <p:nvSpPr>
+          <p:cNvPr id="4" name="">
+            <a:extLst xmlns:a="http://schemas.openxmlformats.org/drawingml/2006/main">
+              <a:ext uri="{FF2B5EF4-FFF2-40B4-BE49-F238E27FC236}">
+                <a16:creationId xmlns:a16="http://schemas.microsoft.com/office/drawing/2014/main" id="{C3F5F128-AC86-473A-B614-3C28D06784FF}"/>
+              </a:ext>
+            </a:extLst>
+          </p:cNvPr>
+          <p:cNvSpPr>
+            <a:spLocks xmlns:a="http://schemas.openxmlformats.org/drawingml/2006/main" noGrp="1"/>
+          </p:cNvSpPr>
+          <p:nvPr/>
+        </p:nvSpPr>
+        <p:spPr>
+          <a:xfrm xmlns:a="http://schemas.openxmlformats.org/drawingml/2006/main">
+            <a:off x="819150" y="2638425"/>
+            <a:ext cx="13525500" cy="1095375"/>
+          </a:xfrm>
+          <a:prstGeom xmlns:a="http://schemas.openxmlformats.org/drawingml/2006/main" prst="rect">
+            <a:avLst/>
+          </a:prstGeom>
+          <a:noFill xmlns:a="http://schemas.openxmlformats.org/drawingml/2006/main"/>
+          <a:ln xmlns:a="http://schemas.openxmlformats.org/drawingml/2006/main" w="0">
+            <a:noFill/>
+          </a:ln>
+        </p:spPr>
+        <p:txBody>
+          <a:bodyPr xmlns:a="http://schemas.openxmlformats.org/drawingml/2006/main" wrap="square" lIns="0" tIns="0" rIns="0" bIns="0">
+            <a:noAutofit/>
+          </a:bodyPr>
+          <a:lstStyle xmlns:a="http://schemas.openxmlformats.org/drawingml/2006/main"/>
+          <a:p xmlns:a="http://schemas.openxmlformats.org/drawingml/2006/main">
+            <a:pPr>
+              <a:defRPr sz="2475" b="0">
+                <a:solidFill>
+                  <a:srgbClr val="182C29"/>
+                </a:solidFill>
+                <a:latin typeface="Apple SD Gothic Neo"/>
+                <a:ea typeface="Apple SD Gothic Neo"/>
+                <a:cs typeface="Apple SD Gothic Neo"/>
+              </a:defRPr>
+            </a:pPr>
+            <a:r>
+              <a:rPr sz="2475" b="0">
+                <a:solidFill>
+                  <a:srgbClr val="182C29"/>
+                </a:solidFill>
+                <a:latin typeface="Apple SD Gothic Neo"/>
+                <a:ea typeface="Apple SD Gothic Neo"/>
+                <a:cs typeface="Apple SD Gothic Neo"/>
+              </a:rPr>
+              <a:t>문장을 생성하는 LLM과, 정해진 후보·확률을 반환하는 Jev를 비교했습니다.</a:t>
+            </a:r>
+          </a:p>
+          <a:p xmlns:a="http://schemas.openxmlformats.org/drawingml/2006/main">
+            <a:pPr>
+              <a:defRPr sz="2475" b="0">
+                <a:solidFill>
+                  <a:srgbClr val="182C29"/>
+                </a:solidFill>
+                <a:latin typeface="Apple SD Gothic Neo"/>
+                <a:ea typeface="Apple SD Gothic Neo"/>
+                <a:cs typeface="Apple SD Gothic Neo"/>
+              </a:defRPr>
+            </a:pPr>
+            <a:r>
+              <a:rPr sz="2475" b="0">
+                <a:solidFill>
+                  <a:srgbClr val="182C29"/>
+                </a:solidFill>
+                <a:latin typeface="Apple SD Gothic Neo"/>
+                <a:ea typeface="Apple SD Gothic Neo"/>
+                <a:cs typeface="Apple SD Gothic Neo"/>
+              </a:rPr>
+              <a:t>상품 입력과 공식 HS 목록을 동일하게 제공해 2→4→6자리 경로를 선택했습니다.</a:t>
+            </a:r>
+          </a:p>
+        </p:txBody>
+      </p:sp>
+      <p:graphicFrame>
+        <p:nvGraphicFramePr>
+          <p:cNvPr id="12" name=""/>
+          <p:cNvGraphicFramePr/>
+          <p:nvPr/>
+        </p:nvGraphicFramePr>
+        <p:xfrm>
+          <a:off xmlns:a="http://schemas.openxmlformats.org/drawingml/2006/main" x="819150" y="4124325"/>
+          <a:ext xmlns:a="http://schemas.openxmlformats.org/drawingml/2006/main" cx="13601700" cy="2266950"/>
+        </p:xfrm>
+        <a:graphic xmlns:a="http://schemas.openxmlformats.org/drawingml/2006/main">
+          <a:graphicData uri="http://schemas.openxmlformats.org/drawingml/2006/table">
+            <a:tbl>
+              <a:tblPr/>
+              <a:tblGrid>
+                <a:gridCol w="3048000"/>
+                <a:gridCol w="4238625"/>
+                <a:gridCol w="6315075"/>
+              </a:tblGrid>
+              <a:tr h="755650">
+                <a:tc>
+                  <a:txBody>
+                    <a:bodyPr/>
+                    <a:lstStyle/>
+                    <a:p>
+                      <a:r>
+                        <a:rPr sz="2025" b="1">
+                          <a:solidFill>
+                            <a:srgbClr val="FFFFFF"/>
+                          </a:solidFill>
+                          <a:latin typeface="Apple SD Gothic Neo"/>
+                          <a:ea typeface="Apple SD Gothic Neo"/>
+                          <a:cs typeface="Apple SD Gothic Neo"/>
+                        </a:rPr>
+                        <a:t>데이터</a:t>
+                      </a:r>
+                    </a:p>
+                  </a:txBody>
+                  <a:tcPr marL="91440" marR="91440" marT="45720" marB="45720">
+                    <a:solidFill>
+                      <a:srgbClr val="182C29"/>
+                    </a:solidFill>
+                  </a:tcPr>
+                </a:tc>
+                <a:tc>
+                  <a:txBody>
+                    <a:bodyPr/>
+                    <a:lstStyle/>
+                    <a:p>
+                      <a:r>
+                        <a:rPr sz="2025" b="1">
+                          <a:solidFill>
+                            <a:srgbClr val="FFFFFF"/>
+                          </a:solidFill>
+                          <a:latin typeface="Apple SD Gothic Neo"/>
+                          <a:ea typeface="Apple SD Gothic Neo"/>
+                          <a:cs typeface="Apple SD Gothic Neo"/>
+                        </a:rPr>
+                        <a:t>실행 범위</a:t>
+                      </a:r>
+                    </a:p>
+                  </a:txBody>
+                  <a:tcPr marL="91440" marR="91440" marT="45720" marB="45720">
+                    <a:solidFill>
+                      <a:srgbClr val="182C29"/>
+                    </a:solidFill>
+                  </a:tcPr>
+                </a:tc>
+                <a:tc>
+                  <a:txBody>
+                    <a:bodyPr/>
+                    <a:lstStyle/>
+                    <a:p>
+                      <a:r>
+                        <a:rPr sz="2025" b="1">
+                          <a:solidFill>
+                            <a:srgbClr val="FFFFFF"/>
+                          </a:solidFill>
+                          <a:latin typeface="Apple SD Gothic Neo"/>
+                          <a:ea typeface="Apple SD Gothic Neo"/>
+                          <a:cs typeface="Apple SD Gothic Neo"/>
+                        </a:rPr>
+                        <a:t>품질 평가 기준</a:t>
+                      </a:r>
+                    </a:p>
+                  </a:txBody>
+                  <a:tcPr marL="91440" marR="91440" marT="45720" marB="45720">
+                    <a:solidFill>
+                      <a:srgbClr val="182C29"/>
+                    </a:solidFill>
+                  </a:tcPr>
+                </a:tc>
+              </a:tr>
+              <a:tr h="755650">
+                <a:tc>
+                  <a:txBody>
+                    <a:bodyPr/>
+                    <a:lstStyle/>
+                    <a:p>
+                      <a:r>
+                        <a:rPr sz="2175" b="0">
+                          <a:solidFill>
+                            <a:srgbClr val="182C29"/>
+                          </a:solidFill>
+                          <a:latin typeface="Apple SD Gothic Neo"/>
+                          <a:ea typeface="Apple SD Gothic Neo"/>
+                          <a:cs typeface="Apple SD Gothic Neo"/>
+                        </a:rPr>
+                        <a:t>HSCodeComp</a:t>
+                      </a:r>
+                    </a:p>
+                  </a:txBody>
+                  <a:tcPr marL="91440" marR="91440" marT="45720" marB="45720">
+                    <a:solidFill>
+                      <a:srgbClr val="FFFFFF"/>
+                    </a:solidFill>
+                  </a:tcPr>
+                </a:tc>
+                <a:tc>
+                  <a:txBody>
+                    <a:bodyPr/>
+                    <a:lstStyle/>
+                    <a:p>
+                      <a:r>
+                        <a:rPr sz="2175" b="0">
+                          <a:solidFill>
+                            <a:srgbClr val="182C29"/>
+                          </a:solidFill>
+                          <a:latin typeface="Apple SD Gothic Neo"/>
+                          <a:ea typeface="Apple SD Gothic Neo"/>
+                          <a:cs typeface="Apple SD Gothic Neo"/>
+                        </a:rPr>
+                        <a:t>94개 층화 표본 / 전체632개</a:t>
+                      </a:r>
+                    </a:p>
+                  </a:txBody>
+                  <a:tcPr marL="91440" marR="91440" marT="45720" marB="45720">
+                    <a:solidFill>
+                      <a:srgbClr val="FFFFFF"/>
+                    </a:solidFill>
+                  </a:tcPr>
+                </a:tc>
+                <a:tc>
+                  <a:txBody>
+                    <a:bodyPr/>
+                    <a:lstStyle/>
+                    <a:p>
+                      <a:r>
+                        <a:rPr sz="2175" b="0">
+                          <a:solidFill>
+                            <a:srgbClr val="182C29"/>
+                          </a:solidFill>
+                          <a:latin typeface="Apple SD Gothic Neo"/>
+                          <a:ea typeface="Apple SD Gothic Neo"/>
+                          <a:cs typeface="Apple SD Gothic Neo"/>
+                        </a:rPr>
+                        <a:t>공개 전문가 라벨과 HS6 일치</a:t>
+                      </a:r>
+                    </a:p>
+                  </a:txBody>
+                  <a:tcPr marL="91440" marR="91440" marT="45720" marB="45720">
+                    <a:solidFill>
+                      <a:srgbClr val="FFFFFF"/>
+                    </a:solidFill>
+                  </a:tcPr>
+                </a:tc>
+              </a:tr>
+              <a:tr h="755650">
+                <a:tc>
+                  <a:txBody>
+                    <a:bodyPr/>
+                    <a:lstStyle/>
+                    <a:p>
+                      <a:r>
+                        <a:rPr sz="2175" b="0">
+                          <a:solidFill>
+                            <a:srgbClr val="182C29"/>
+                          </a:solidFill>
+                          <a:latin typeface="Apple SD Gothic Neo"/>
+                          <a:ea typeface="Apple SD Gothic Neo"/>
+                          <a:cs typeface="Apple SD Gothic Neo"/>
+                        </a:rPr>
+                        <a:t>메루카리</a:t>
+                      </a:r>
+                    </a:p>
+                  </a:txBody>
+                  <a:tcPr marL="91440" marR="91440" marT="45720" marB="45720">
+                    <a:solidFill>
+                      <a:srgbClr val="F8F8F3"/>
+                    </a:solidFill>
+                  </a:tcPr>
+                </a:tc>
+                <a:tc>
+                  <a:txBody>
+                    <a:bodyPr/>
+                    <a:lstStyle/>
+                    <a:p>
+                      <a:r>
+                        <a:rPr sz="2175" b="0">
+                          <a:solidFill>
+                            <a:srgbClr val="182C29"/>
+                          </a:solidFill>
+                          <a:latin typeface="Apple SD Gothic Neo"/>
+                          <a:ea typeface="Apple SD Gothic Neo"/>
+                          <a:cs typeface="Apple SD Gothic Neo"/>
+                        </a:rPr>
+                        <a:t>실제 판매글30개 전체</a:t>
+                      </a:r>
+                    </a:p>
+                  </a:txBody>
+                  <a:tcPr marL="91440" marR="91440" marT="45720" marB="45720">
+                    <a:solidFill>
+                      <a:srgbClr val="F8F8F3"/>
+                    </a:solidFill>
+                  </a:tcPr>
+                </a:tc>
+                <a:tc>
+                  <a:txBody>
+                    <a:bodyPr/>
+                    <a:lstStyle/>
+                    <a:p>
+                      <a:r>
+                        <a:rPr sz="2175" b="0">
+                          <a:solidFill>
+                            <a:srgbClr val="182C29"/>
+                          </a:solidFill>
+                          <a:latin typeface="Apple SD Gothic Neo"/>
+                          <a:ea typeface="Apple SD Gothic Neo"/>
+                          <a:cs typeface="Apple SD Gothic Neo"/>
+                        </a:rPr>
+                        <a:t>독립 GPT-6 Sol 심사 결과와 일치</a:t>
+                      </a:r>
+                    </a:p>
+                  </a:txBody>
+                  <a:tcPr marL="91440" marR="91440" marT="45720" marB="45720">
+                    <a:solidFill>
+                      <a:srgbClr val="F8F8F3"/>
+                    </a:solidFill>
+                  </a:tcPr>
+                </a:tc>
+              </a:tr>
+            </a:tbl>
+          </a:graphicData>
+        </a:graphic>
+      </p:graphicFrame>
+      <p:sp>
+        <p:nvSpPr>
+          <p:cNvPr id="6" name="">
+            <a:extLst xmlns:a="http://schemas.openxmlformats.org/drawingml/2006/main">
+              <a:ext uri="{FF2B5EF4-FFF2-40B4-BE49-F238E27FC236}">
+                <a16:creationId xmlns:a16="http://schemas.microsoft.com/office/drawing/2014/main" id="{FFEE9D22-BAD4-4A19-979B-E83025455E69}"/>
+              </a:ext>
+            </a:extLst>
+          </p:cNvPr>
+          <p:cNvSpPr>
+            <a:spLocks xmlns:a="http://schemas.openxmlformats.org/drawingml/2006/main" noGrp="1"/>
+          </p:cNvSpPr>
+          <p:nvPr/>
+        </p:nvSpPr>
+        <p:spPr>
+          <a:xfrm xmlns:a="http://schemas.openxmlformats.org/drawingml/2006/main">
+            <a:off x="819150" y="6810375"/>
+            <a:ext cx="13525500" cy="571500"/>
+          </a:xfrm>
+          <a:prstGeom xmlns:a="http://schemas.openxmlformats.org/drawingml/2006/main" prst="rect">
+            <a:avLst/>
+          </a:prstGeom>
+          <a:noFill xmlns:a="http://schemas.openxmlformats.org/drawingml/2006/main"/>
+          <a:ln xmlns:a="http://schemas.openxmlformats.org/drawingml/2006/main" w="0">
+            <a:noFill/>
+          </a:ln>
+        </p:spPr>
+        <p:txBody>
+          <a:bodyPr xmlns:a="http://schemas.openxmlformats.org/drawingml/2006/main" wrap="square" lIns="0" tIns="0" rIns="0" bIns="0">
+            <a:noAutofit/>
+          </a:bodyPr>
+          <a:lstStyle xmlns:a="http://schemas.openxmlformats.org/drawingml/2006/main"/>
+          <a:p xmlns:a="http://schemas.openxmlformats.org/drawingml/2006/main">
+            <a:pPr>
+              <a:defRPr sz="2025" b="0">
+                <a:solidFill>
+                  <a:srgbClr val="182C29"/>
+                </a:solidFill>
+                <a:latin typeface="Apple SD Gothic Neo"/>
+                <a:ea typeface="Apple SD Gothic Neo"/>
+                <a:cs typeface="Apple SD Gothic Neo"/>
+              </a:defRPr>
+            </a:pPr>
+            <a:r>
+              <a:rPr sz="2025" b="0">
+                <a:solidFill>
+                  <a:srgbClr val="182C29"/>
+                </a:solidFill>
+                <a:latin typeface="Apple SD Gothic Neo"/>
+                <a:ea typeface="Apple SD Gothic Neo"/>
+                <a:cs typeface="Apple SD Gothic Neo"/>
+              </a:rPr>
+              <a:t>비교: Jev 1.13 ↔ GPT-6 Luna low. 심사자는 기존 예측과 공급사 이름을 보지 않았습니다.</a:t>
+            </a:r>
+          </a:p>
+        </p:txBody>
+      </p:sp>
+      <p:sp>
+        <p:nvSpPr>
+          <p:cNvPr id="7" name="">
+            <a:extLst xmlns:a="http://schemas.openxmlformats.org/drawingml/2006/main">
+              <a:ext uri="{FF2B5EF4-FFF2-40B4-BE49-F238E27FC236}">
+                <a16:creationId xmlns:a16="http://schemas.microsoft.com/office/drawing/2014/main" id="{4D396F42-9085-4613-962A-A2E6EC17D4F0}"/>
+              </a:ext>
+            </a:extLst>
+          </p:cNvPr>
+          <p:cNvSpPr>
+            <a:spLocks xmlns:a="http://schemas.openxmlformats.org/drawingml/2006/main" noGrp="1"/>
+          </p:cNvSpPr>
+          <p:nvPr/>
+        </p:nvSpPr>
+        <p:spPr>
+          <a:xfrm xmlns:a="http://schemas.openxmlformats.org/drawingml/2006/main">
+            <a:off x="819150" y="7524750"/>
+            <a:ext cx="13525500" cy="342900"/>
+          </a:xfrm>
+          <a:prstGeom xmlns:a="http://schemas.openxmlformats.org/drawingml/2006/main" prst="rect">
+            <a:avLst/>
+          </a:prstGeom>
+          <a:noFill xmlns:a="http://schemas.openxmlformats.org/drawingml/2006/main"/>
+          <a:ln xmlns:a="http://schemas.openxmlformats.org/drawingml/2006/main" w="0">
+            <a:noFill/>
+          </a:ln>
+        </p:spPr>
+        <p:txBody>
+          <a:bodyPr xmlns:a="http://schemas.openxmlformats.org/drawingml/2006/main" wrap="square" lIns="0" tIns="0" rIns="0" bIns="0">
+            <a:noAutofit/>
+          </a:bodyPr>
+          <a:lstStyle xmlns:a="http://schemas.openxmlformats.org/drawingml/2006/main"/>
+          <a:p xmlns:a="http://schemas.openxmlformats.org/drawingml/2006/main">
+            <a:pPr>
+              <a:defRPr sz="1725" b="0">
+                <a:solidFill>
+                  <a:srgbClr val="5E706B"/>
+                </a:solidFill>
+                <a:latin typeface="Apple SD Gothic Neo"/>
+                <a:ea typeface="Apple SD Gothic Neo"/>
+                <a:cs typeface="Apple SD Gothic Neo"/>
+              </a:defRPr>
+            </a:pPr>
+            <a:r>
+              <a:rPr sz="1725" b="0">
+                <a:solidFill>
+                  <a:srgbClr val="5E706B"/>
+                </a:solidFill>
+                <a:latin typeface="Apple SD Gothic Neo"/>
+                <a:ea typeface="Apple SD Gothic Neo"/>
+                <a:cs typeface="Apple SD Gothic Neo"/>
+              </a:rPr>
+              <a:t>텍스트만 사용한 단일 경로 실험입니다. 웹 검색·이미지 분석·정답으로 후보 축소는 하지 않았습니다.</a:t>
+            </a:r>
+          </a:p>
+        </p:txBody>
+      </p:sp>
+    </p:spTree>
+    <p:extLst>
+      <p:ext uri="{BB962C8B-B14F-4D97-AF65-F5344CB8AC3E}">
+        <p14:creationId xmlns:p14="http://schemas.microsoft.com/office/powerpoint/2010/main" val="1928326010"/>
+      </p:ext>
+    </p:extLst>
+  </p:cSld>
+</p:sld>
+</file>
+
+<file path=ppt/slides/slide17.xml><?xml version="1.0" encoding="utf-8"?>
+<p:sld xmlns:p="http://schemas.openxmlformats.org/presentationml/2006/main">
+  <p:cSld>
+    <p:bg>
+      <p:bgPr>
+        <a:solidFill xmlns:a="http://schemas.openxmlformats.org/drawingml/2006/main">
+          <a:srgbClr val="F8F8F3"/>
+        </a:solidFill>
+      </p:bgPr>
+    </p:bg>
+    <p:spTree>
+      <p:nvGrpSpPr>
+        <p:cNvPr id="1" name=""/>
+        <p:cNvGrpSpPr/>
+        <p:nvPr/>
+      </p:nvGrpSpPr>
+      <p:grpSpPr>
+        <a:xfrm xmlns:a="http://schemas.openxmlformats.org/drawingml/2006/main"/>
+      </p:grpSpPr>
+      <p:sp>
+        <p:nvSpPr>
+          <p:cNvPr id="12" name="">
+            <a:extLst xmlns:a="http://schemas.openxmlformats.org/drawingml/2006/main">
+              <a:ext uri="{FF2B5EF4-FFF2-40B4-BE49-F238E27FC236}">
+                <a16:creationId xmlns:a16="http://schemas.microsoft.com/office/drawing/2014/main" id="{76AFBD16-BB63-40AD-A67C-25EBF9EE0FE8}"/>
+              </a:ext>
+            </a:extLst>
+          </p:cNvPr>
+          <p:cNvSpPr>
+            <a:spLocks xmlns:a="http://schemas.openxmlformats.org/drawingml/2006/main" noGrp="1"/>
+          </p:cNvSpPr>
+          <p:nvPr/>
+        </p:nvSpPr>
+        <p:spPr>
+          <a:xfrm xmlns:a="http://schemas.openxmlformats.org/drawingml/2006/main">
+            <a:off x="800100" y="609600"/>
+            <a:ext cx="13620750" cy="781050"/>
+          </a:xfrm>
+          <a:prstGeom xmlns:a="http://schemas.openxmlformats.org/drawingml/2006/main" prst="rect">
+            <a:avLst/>
+          </a:prstGeom>
+          <a:noFill xmlns:a="http://schemas.openxmlformats.org/drawingml/2006/main"/>
+          <a:ln xmlns:a="http://schemas.openxmlformats.org/drawingml/2006/main" w="0">
+            <a:noFill/>
+          </a:ln>
+        </p:spPr>
+        <p:txBody>
+          <a:bodyPr xmlns:a="http://schemas.openxmlformats.org/drawingml/2006/main" wrap="square" lIns="0" tIns="0" rIns="0" bIns="0">
+            <a:noAutofit/>
+          </a:bodyPr>
+          <a:lstStyle xmlns:a="http://schemas.openxmlformats.org/drawingml/2006/main"/>
+          <a:p xmlns:a="http://schemas.openxmlformats.org/drawingml/2006/main">
+            <a:pPr>
+              <a:defRPr sz="3675" b="1">
+                <a:solidFill>
+                  <a:srgbClr val="182C29"/>
+                </a:solidFill>
+                <a:latin typeface="Apple SD Gothic Neo"/>
+                <a:ea typeface="Apple SD Gothic Neo"/>
+                <a:cs typeface="Apple SD Gothic Neo"/>
+              </a:defRPr>
+            </a:pPr>
+            <a:r>
+              <a:rPr sz="3675" b="1">
+                <a:solidFill>
+                  <a:srgbClr val="182C29"/>
+                </a:solidFill>
+                <a:latin typeface="Apple SD Gothic Neo"/>
+                <a:ea typeface="Apple SD Gothic Neo"/>
+                <a:cs typeface="Apple SD Gothic Neo"/>
+              </a:rPr>
+              <a:t>HS 후보 판단시간을 5~6배 줄였습니다</a:t>
+            </a:r>
+          </a:p>
+        </p:txBody>
+      </p:sp>
+      <p:sp>
+        <p:nvSpPr>
+          <p:cNvPr id="2" name="">
+            <a:extLst xmlns:a="http://schemas.openxmlformats.org/drawingml/2006/main">
+              <a:ext uri="{FF2B5EF4-FFF2-40B4-BE49-F238E27FC236}">
+                <a16:creationId xmlns:a16="http://schemas.microsoft.com/office/drawing/2014/main" id="{811E44A2-D536-469D-98DF-20510C7E28F6}"/>
+              </a:ext>
+            </a:extLst>
+          </p:cNvPr>
+          <p:cNvSpPr>
+            <a:spLocks xmlns:a="http://schemas.openxmlformats.org/drawingml/2006/main" noGrp="1"/>
+          </p:cNvSpPr>
+          <p:nvPr/>
+        </p:nvSpPr>
+        <p:spPr>
+          <a:xfrm xmlns:a="http://schemas.openxmlformats.org/drawingml/2006/main">
+            <a:off x="819150" y="1533525"/>
+            <a:ext cx="13525500" cy="781050"/>
+          </a:xfrm>
+          <a:prstGeom xmlns:a="http://schemas.openxmlformats.org/drawingml/2006/main" prst="rect">
+            <a:avLst/>
+          </a:prstGeom>
+          <a:noFill xmlns:a="http://schemas.openxmlformats.org/drawingml/2006/main"/>
+          <a:ln xmlns:a="http://schemas.openxmlformats.org/drawingml/2006/main" w="0">
+            <a:noFill/>
+          </a:ln>
+        </p:spPr>
+        <p:txBody>
+          <a:bodyPr xmlns:a="http://schemas.openxmlformats.org/drawingml/2006/main" wrap="square" lIns="0" tIns="0" rIns="0" bIns="0">
+            <a:noAutofit/>
+          </a:bodyPr>
+          <a:lstStyle xmlns:a="http://schemas.openxmlformats.org/drawingml/2006/main"/>
+          <a:p xmlns:a="http://schemas.openxmlformats.org/drawingml/2006/main">
+            <a:pPr>
+              <a:defRPr sz="2100" b="0">
+                <a:solidFill>
+                  <a:srgbClr val="5E706B"/>
+                </a:solidFill>
+                <a:latin typeface="Apple SD Gothic Neo"/>
+                <a:ea typeface="Apple SD Gothic Neo"/>
+                <a:cs typeface="Apple SD Gothic Neo"/>
+              </a:defRPr>
+            </a:pPr>
+            <a:r>
+              <a:rPr sz="2100" b="0">
+                <a:solidFill>
+                  <a:srgbClr val="5E706B"/>
+                </a:solidFill>
+                <a:latin typeface="Apple SD Gothic Neo"/>
+                <a:ea typeface="Apple SD Gothic Neo"/>
+                <a:cs typeface="Apple SD Gothic Neo"/>
+              </a:rPr>
+              <a:t>동일한 입력에서 Jev의 중앙 처리시간과 추정 비용이 더 낮았습니다.</a:t>
+            </a:r>
+          </a:p>
+        </p:txBody>
+      </p:sp>
+      <p:sp>
+        <p:nvSpPr>
+          <p:cNvPr id="3" name="">
+            <a:extLst xmlns:a="http://schemas.openxmlformats.org/drawingml/2006/main">
+              <a:ext uri="{FF2B5EF4-FFF2-40B4-BE49-F238E27FC236}">
+                <a16:creationId xmlns:a16="http://schemas.microsoft.com/office/drawing/2014/main" id="{E58BD48B-AC29-45F2-A860-07B1D6838A80}"/>
+              </a:ext>
+            </a:extLst>
+          </p:cNvPr>
+          <p:cNvSpPr>
+            <a:spLocks xmlns:a="http://schemas.openxmlformats.org/drawingml/2006/main" noGrp="1"/>
+          </p:cNvSpPr>
+          <p:nvPr/>
+        </p:nvSpPr>
+        <p:spPr>
+          <a:xfrm xmlns:a="http://schemas.openxmlformats.org/drawingml/2006/main">
+            <a:off x="819150" y="8058150"/>
+            <a:ext cx="13620750" cy="285750"/>
+          </a:xfrm>
+          <a:prstGeom xmlns:a="http://schemas.openxmlformats.org/drawingml/2006/main" prst="rect">
+            <a:avLst/>
+          </a:prstGeom>
+          <a:noFill xmlns:a="http://schemas.openxmlformats.org/drawingml/2006/main"/>
+          <a:ln xmlns:a="http://schemas.openxmlformats.org/drawingml/2006/main" w="0">
+            <a:noFill/>
+          </a:ln>
+        </p:spPr>
+        <p:txBody>
+          <a:bodyPr xmlns:a="http://schemas.openxmlformats.org/drawingml/2006/main" wrap="square" lIns="0" tIns="0" rIns="0" bIns="0">
+            <a:noAutofit/>
+          </a:bodyPr>
+          <a:lstStyle xmlns:a="http://schemas.openxmlformats.org/drawingml/2006/main"/>
+          <a:p xmlns:a="http://schemas.openxmlformats.org/drawingml/2006/main">
+            <a:pPr>
+              <a:defRPr sz="1350" b="0">
+                <a:solidFill>
+                  <a:srgbClr val="5E706B"/>
+                </a:solidFill>
+                <a:latin typeface="Apple SD Gothic Neo"/>
+                <a:ea typeface="Apple SD Gothic Neo"/>
+                <a:cs typeface="Apple SD Gothic Neo"/>
+              </a:defRPr>
+            </a:pPr>
+            <a:r>
+              <a:rPr sz="1350" b="0">
+                <a:solidFill>
+                  <a:srgbClr val="5E706B"/>
+                </a:solidFill>
+                <a:latin typeface="Apple SD Gothic Neo"/>
+                <a:ea typeface="Apple SD Gothic Neo"/>
+                <a:cs typeface="Apple SD Gothic Neo"/>
+              </a:rPr>
+              <a:t>17   윤장한 · 직구 조사와 도구 구현 · 부록 · 2026.10.06</a:t>
+            </a:r>
+          </a:p>
+        </p:txBody>
+      </p:sp>
+      <p:graphicFrame>
+        <p:nvGraphicFramePr>
+          <p:cNvPr id="15" name="Chart"/>
+          <p:cNvGraphicFramePr/>
+          <p:nvPr/>
+        </p:nvGraphicFramePr>
+        <p:xfrm>
+          <a:off xmlns:a="http://schemas.openxmlformats.org/drawingml/2006/main" x="819150" y="2647950"/>
+          <a:ext xmlns:a="http://schemas.openxmlformats.org/drawingml/2006/main" cx="8715375" cy="4000500"/>
+        </p:xfrm>
+        <a:graphic xmlns:a="http://schemas.openxmlformats.org/drawingml/2006/main">
+          <a:graphicData uri="http://schemas.openxmlformats.org/drawingml/2006/chart">
+            <c:chart xmlns:r="http://schemas.openxmlformats.org/officeDocument/2006/relationships" xmlns:c="http://schemas.openxmlformats.org/drawingml/2006/chart" r:id="Rf3f219ec14d3420b"/>
+          </a:graphicData>
+        </a:graphic>
+      </p:graphicFrame>
+      <p:sp>
+        <p:nvSpPr>
+          <p:cNvPr id="5" name="">
+            <a:extLst xmlns:a="http://schemas.openxmlformats.org/drawingml/2006/main">
+              <a:ext uri="{FF2B5EF4-FFF2-40B4-BE49-F238E27FC236}">
+                <a16:creationId xmlns:a16="http://schemas.microsoft.com/office/drawing/2014/main" id="{904456F5-EC6A-4EC9-B4F5-432C07FB1370}"/>
+              </a:ext>
+            </a:extLst>
+          </p:cNvPr>
+          <p:cNvSpPr>
+            <a:spLocks xmlns:a="http://schemas.openxmlformats.org/drawingml/2006/main" noGrp="1"/>
+          </p:cNvSpPr>
+          <p:nvPr/>
+        </p:nvSpPr>
+        <p:spPr>
+          <a:xfrm xmlns:a="http://schemas.openxmlformats.org/drawingml/2006/main">
+            <a:off x="10287000" y="2781300"/>
+            <a:ext cx="4000500" cy="476250"/>
+          </a:xfrm>
+          <a:prstGeom xmlns:a="http://schemas.openxmlformats.org/drawingml/2006/main" prst="rect">
+            <a:avLst/>
+          </a:prstGeom>
+          <a:noFill xmlns:a="http://schemas.openxmlformats.org/drawingml/2006/main"/>
+          <a:ln xmlns:a="http://schemas.openxmlformats.org/drawingml/2006/main" w="0">
+            <a:noFill/>
+          </a:ln>
+        </p:spPr>
+        <p:txBody>
+          <a:bodyPr xmlns:a="http://schemas.openxmlformats.org/drawingml/2006/main" wrap="square" lIns="0" tIns="0" rIns="0" bIns="0">
+            <a:noAutofit/>
+          </a:bodyPr>
+          <a:lstStyle xmlns:a="http://schemas.openxmlformats.org/drawingml/2006/main"/>
+          <a:p xmlns:a="http://schemas.openxmlformats.org/drawingml/2006/main">
+            <a:pPr>
+              <a:defRPr sz="2400" b="1">
+                <a:solidFill>
+                  <a:srgbClr val="156E58"/>
+                </a:solidFill>
+                <a:latin typeface="Apple SD Gothic Neo"/>
+                <a:ea typeface="Apple SD Gothic Neo"/>
+                <a:cs typeface="Apple SD Gothic Neo"/>
+              </a:defRPr>
+            </a:pPr>
+            <a:r>
+              <a:rPr sz="2400" b="1">
+                <a:solidFill>
+                  <a:srgbClr val="156E58"/>
+                </a:solidFill>
+                <a:latin typeface="Apple SD Gothic Neo"/>
+                <a:ea typeface="Apple SD Gothic Neo"/>
+                <a:cs typeface="Apple SD Gothic Neo"/>
+              </a:rPr>
+              <a:t>HF 표본</a:t>
+            </a:r>
+          </a:p>
+        </p:txBody>
+      </p:sp>
+      <p:sp>
+        <p:nvSpPr>
+          <p:cNvPr id="6" name="">
+            <a:extLst xmlns:a="http://schemas.openxmlformats.org/drawingml/2006/main">
+              <a:ext uri="{FF2B5EF4-FFF2-40B4-BE49-F238E27FC236}">
+                <a16:creationId xmlns:a16="http://schemas.microsoft.com/office/drawing/2014/main" id="{476D8F6E-DA11-4B04-8FF1-8241BA08D036}"/>
+              </a:ext>
+            </a:extLst>
+          </p:cNvPr>
+          <p:cNvSpPr>
+            <a:spLocks xmlns:a="http://schemas.openxmlformats.org/drawingml/2006/main" noGrp="1"/>
+          </p:cNvSpPr>
+          <p:nvPr/>
+        </p:nvSpPr>
+        <p:spPr>
+          <a:xfrm xmlns:a="http://schemas.openxmlformats.org/drawingml/2006/main">
+            <a:off x="10287000" y="3371850"/>
+            <a:ext cx="4000500" cy="619125"/>
+          </a:xfrm>
+          <a:prstGeom xmlns:a="http://schemas.openxmlformats.org/drawingml/2006/main" prst="rect">
+            <a:avLst/>
+          </a:prstGeom>
+          <a:noFill xmlns:a="http://schemas.openxmlformats.org/drawingml/2006/main"/>
+          <a:ln xmlns:a="http://schemas.openxmlformats.org/drawingml/2006/main" w="0">
+            <a:noFill/>
+          </a:ln>
+        </p:spPr>
+        <p:txBody>
+          <a:bodyPr xmlns:a="http://schemas.openxmlformats.org/drawingml/2006/main" wrap="square" lIns="0" tIns="0" rIns="0" bIns="0">
+            <a:noAutofit/>
+          </a:bodyPr>
+          <a:lstStyle xmlns:a="http://schemas.openxmlformats.org/drawingml/2006/main"/>
+          <a:p xmlns:a="http://schemas.openxmlformats.org/drawingml/2006/main">
+            <a:pPr>
+              <a:defRPr sz="3150" b="1">
+                <a:solidFill>
+                  <a:srgbClr val="182C29"/>
+                </a:solidFill>
+                <a:latin typeface="Apple SD Gothic Neo"/>
+                <a:ea typeface="Apple SD Gothic Neo"/>
+                <a:cs typeface="Apple SD Gothic Neo"/>
+              </a:defRPr>
+            </a:pPr>
+            <a:r>
+              <a:rPr sz="3150" b="1">
+                <a:solidFill>
+                  <a:srgbClr val="182C29"/>
+                </a:solidFill>
+                <a:latin typeface="Apple SD Gothic Neo"/>
+                <a:ea typeface="Apple SD Gothic Neo"/>
+                <a:cs typeface="Apple SD Gothic Neo"/>
+              </a:rPr>
+              <a:t>6.4배 빠르게</a:t>
+            </a:r>
+          </a:p>
+        </p:txBody>
+      </p:sp>
+      <p:sp>
+        <p:nvSpPr>
+          <p:cNvPr id="7" name="">
+            <a:extLst xmlns:a="http://schemas.openxmlformats.org/drawingml/2006/main">
+              <a:ext uri="{FF2B5EF4-FFF2-40B4-BE49-F238E27FC236}">
+                <a16:creationId xmlns:a16="http://schemas.microsoft.com/office/drawing/2014/main" id="{A22D3943-DD8F-4BFC-A707-D7FAAAE682F2}"/>
+              </a:ext>
+            </a:extLst>
+          </p:cNvPr>
+          <p:cNvSpPr>
+            <a:spLocks xmlns:a="http://schemas.openxmlformats.org/drawingml/2006/main" noGrp="1"/>
+          </p:cNvSpPr>
+          <p:nvPr/>
+        </p:nvSpPr>
+        <p:spPr>
+          <a:xfrm xmlns:a="http://schemas.openxmlformats.org/drawingml/2006/main">
+            <a:off x="10287000" y="4086225"/>
+            <a:ext cx="4000500" cy="523875"/>
+          </a:xfrm>
+          <a:prstGeom xmlns:a="http://schemas.openxmlformats.org/drawingml/2006/main" prst="rect">
+            <a:avLst/>
+          </a:prstGeom>
+          <a:noFill xmlns:a="http://schemas.openxmlformats.org/drawingml/2006/main"/>
+          <a:ln xmlns:a="http://schemas.openxmlformats.org/drawingml/2006/main" w="0">
+            <a:noFill/>
+          </a:ln>
+        </p:spPr>
+        <p:txBody>
+          <a:bodyPr xmlns:a="http://schemas.openxmlformats.org/drawingml/2006/main" wrap="square" lIns="0" tIns="0" rIns="0" bIns="0">
+            <a:noAutofit/>
+          </a:bodyPr>
+          <a:lstStyle xmlns:a="http://schemas.openxmlformats.org/drawingml/2006/main"/>
+          <a:p xmlns:a="http://schemas.openxmlformats.org/drawingml/2006/main">
+            <a:pPr>
+              <a:defRPr sz="2100" b="0">
+                <a:solidFill>
+                  <a:srgbClr val="182C29"/>
+                </a:solidFill>
+                <a:latin typeface="Apple SD Gothic Neo"/>
+                <a:ea typeface="Apple SD Gothic Neo"/>
+                <a:cs typeface="Apple SD Gothic Neo"/>
+              </a:defRPr>
+            </a:pPr>
+            <a:r>
+              <a:rPr sz="2100" b="0">
+                <a:solidFill>
+                  <a:srgbClr val="182C29"/>
+                </a:solidFill>
+                <a:latin typeface="Apple SD Gothic Neo"/>
+                <a:ea typeface="Apple SD Gothic Neo"/>
+                <a:cs typeface="Apple SD Gothic Neo"/>
+              </a:rPr>
+              <a:t>추정 비용57.0% 감소</a:t>
+            </a:r>
+          </a:p>
+        </p:txBody>
+      </p:sp>
+      <p:sp>
+        <p:nvSpPr>
+          <p:cNvPr id="8" name="">
+            <a:extLst xmlns:a="http://schemas.openxmlformats.org/drawingml/2006/main">
+              <a:ext uri="{FF2B5EF4-FFF2-40B4-BE49-F238E27FC236}">
+                <a16:creationId xmlns:a16="http://schemas.microsoft.com/office/drawing/2014/main" id="{4945892D-3F47-4E7B-BC70-D5DCD05FA923}"/>
+              </a:ext>
+            </a:extLst>
+          </p:cNvPr>
+          <p:cNvSpPr>
+            <a:spLocks xmlns:a="http://schemas.openxmlformats.org/drawingml/2006/main" noGrp="1"/>
+          </p:cNvSpPr>
+          <p:nvPr/>
+        </p:nvSpPr>
+        <p:spPr>
+          <a:xfrm xmlns:a="http://schemas.openxmlformats.org/drawingml/2006/main">
+            <a:off x="10287000" y="4953000"/>
+            <a:ext cx="4000500" cy="476250"/>
+          </a:xfrm>
+          <a:prstGeom xmlns:a="http://schemas.openxmlformats.org/drawingml/2006/main" prst="rect">
+            <a:avLst/>
+          </a:prstGeom>
+          <a:noFill xmlns:a="http://schemas.openxmlformats.org/drawingml/2006/main"/>
+          <a:ln xmlns:a="http://schemas.openxmlformats.org/drawingml/2006/main" w="0">
+            <a:noFill/>
+          </a:ln>
+        </p:spPr>
+        <p:txBody>
+          <a:bodyPr xmlns:a="http://schemas.openxmlformats.org/drawingml/2006/main" wrap="square" lIns="0" tIns="0" rIns="0" bIns="0">
+            <a:noAutofit/>
+          </a:bodyPr>
+          <a:lstStyle xmlns:a="http://schemas.openxmlformats.org/drawingml/2006/main"/>
+          <a:p xmlns:a="http://schemas.openxmlformats.org/drawingml/2006/main">
+            <a:pPr>
+              <a:defRPr sz="2400" b="1">
+                <a:solidFill>
+                  <a:srgbClr val="156E58"/>
+                </a:solidFill>
+                <a:latin typeface="Apple SD Gothic Neo"/>
+                <a:ea typeface="Apple SD Gothic Neo"/>
+                <a:cs typeface="Apple SD Gothic Neo"/>
+              </a:defRPr>
+            </a:pPr>
+            <a:r>
+              <a:rPr sz="2400" b="1">
+                <a:solidFill>
+                  <a:srgbClr val="156E58"/>
+                </a:solidFill>
+                <a:latin typeface="Apple SD Gothic Neo"/>
+                <a:ea typeface="Apple SD Gothic Neo"/>
+                <a:cs typeface="Apple SD Gothic Neo"/>
+              </a:rPr>
+              <a:t>메루카리</a:t>
+            </a:r>
+          </a:p>
+        </p:txBody>
+      </p:sp>
+      <p:sp>
+        <p:nvSpPr>
+          <p:cNvPr id="9" name="">
+            <a:extLst xmlns:a="http://schemas.openxmlformats.org/drawingml/2006/main">
+              <a:ext uri="{FF2B5EF4-FFF2-40B4-BE49-F238E27FC236}">
+                <a16:creationId xmlns:a16="http://schemas.microsoft.com/office/drawing/2014/main" id="{1833C4A1-62AA-4EDC-A677-F0E4BE2AFFC6}"/>
+              </a:ext>
+            </a:extLst>
+          </p:cNvPr>
+          <p:cNvSpPr>
+            <a:spLocks xmlns:a="http://schemas.openxmlformats.org/drawingml/2006/main" noGrp="1"/>
+          </p:cNvSpPr>
+          <p:nvPr/>
+        </p:nvSpPr>
+        <p:spPr>
+          <a:xfrm xmlns:a="http://schemas.openxmlformats.org/drawingml/2006/main">
+            <a:off x="10287000" y="5543550"/>
+            <a:ext cx="4000500" cy="619125"/>
+          </a:xfrm>
+          <a:prstGeom xmlns:a="http://schemas.openxmlformats.org/drawingml/2006/main" prst="rect">
+            <a:avLst/>
+          </a:prstGeom>
+          <a:noFill xmlns:a="http://schemas.openxmlformats.org/drawingml/2006/main"/>
+          <a:ln xmlns:a="http://schemas.openxmlformats.org/drawingml/2006/main" w="0">
+            <a:noFill/>
+          </a:ln>
+        </p:spPr>
+        <p:txBody>
+          <a:bodyPr xmlns:a="http://schemas.openxmlformats.org/drawingml/2006/main" wrap="square" lIns="0" tIns="0" rIns="0" bIns="0">
+            <a:noAutofit/>
+          </a:bodyPr>
+          <a:lstStyle xmlns:a="http://schemas.openxmlformats.org/drawingml/2006/main"/>
+          <a:p xmlns:a="http://schemas.openxmlformats.org/drawingml/2006/main">
+            <a:pPr>
+              <a:defRPr sz="3150" b="1">
+                <a:solidFill>
+                  <a:srgbClr val="182C29"/>
+                </a:solidFill>
+                <a:latin typeface="Apple SD Gothic Neo"/>
+                <a:ea typeface="Apple SD Gothic Neo"/>
+                <a:cs typeface="Apple SD Gothic Neo"/>
+              </a:defRPr>
+            </a:pPr>
+            <a:r>
+              <a:rPr sz="3150" b="1">
+                <a:solidFill>
+                  <a:srgbClr val="182C29"/>
+                </a:solidFill>
+                <a:latin typeface="Apple SD Gothic Neo"/>
+                <a:ea typeface="Apple SD Gothic Neo"/>
+                <a:cs typeface="Apple SD Gothic Neo"/>
+              </a:rPr>
+              <a:t>5.7배 빠르게</a:t>
+            </a:r>
+          </a:p>
+        </p:txBody>
+      </p:sp>
+      <p:sp>
+        <p:nvSpPr>
+          <p:cNvPr id="10" name="">
+            <a:extLst xmlns:a="http://schemas.openxmlformats.org/drawingml/2006/main">
+              <a:ext uri="{FF2B5EF4-FFF2-40B4-BE49-F238E27FC236}">
+                <a16:creationId xmlns:a16="http://schemas.microsoft.com/office/drawing/2014/main" id="{E85F53D6-3058-4200-A49A-1E71C9BA66B9}"/>
+              </a:ext>
+            </a:extLst>
+          </p:cNvPr>
+          <p:cNvSpPr>
+            <a:spLocks xmlns:a="http://schemas.openxmlformats.org/drawingml/2006/main" noGrp="1"/>
+          </p:cNvSpPr>
+          <p:nvPr/>
+        </p:nvSpPr>
+        <p:spPr>
+          <a:xfrm xmlns:a="http://schemas.openxmlformats.org/drawingml/2006/main">
+            <a:off x="10287000" y="6257925"/>
+            <a:ext cx="4000500" cy="523875"/>
+          </a:xfrm>
+          <a:prstGeom xmlns:a="http://schemas.openxmlformats.org/drawingml/2006/main" prst="rect">
+            <a:avLst/>
+          </a:prstGeom>
+          <a:noFill xmlns:a="http://schemas.openxmlformats.org/drawingml/2006/main"/>
+          <a:ln xmlns:a="http://schemas.openxmlformats.org/drawingml/2006/main" w="0">
+            <a:noFill/>
+          </a:ln>
+        </p:spPr>
+        <p:txBody>
+          <a:bodyPr xmlns:a="http://schemas.openxmlformats.org/drawingml/2006/main" wrap="square" lIns="0" tIns="0" rIns="0" bIns="0">
+            <a:noAutofit/>
+          </a:bodyPr>
+          <a:lstStyle xmlns:a="http://schemas.openxmlformats.org/drawingml/2006/main"/>
+          <a:p xmlns:a="http://schemas.openxmlformats.org/drawingml/2006/main">
+            <a:pPr>
+              <a:defRPr sz="2100" b="0">
+                <a:solidFill>
+                  <a:srgbClr val="182C29"/>
+                </a:solidFill>
+                <a:latin typeface="Apple SD Gothic Neo"/>
+                <a:ea typeface="Apple SD Gothic Neo"/>
+                <a:cs typeface="Apple SD Gothic Neo"/>
+              </a:defRPr>
+            </a:pPr>
+            <a:r>
+              <a:rPr sz="2100" b="0">
+                <a:solidFill>
+                  <a:srgbClr val="182C29"/>
+                </a:solidFill>
+                <a:latin typeface="Apple SD Gothic Neo"/>
+                <a:ea typeface="Apple SD Gothic Neo"/>
+                <a:cs typeface="Apple SD Gothic Neo"/>
+              </a:rPr>
+              <a:t>추정 비용53.9% 감소</a:t>
+            </a:r>
+          </a:p>
+        </p:txBody>
+      </p:sp>
+      <p:sp>
+        <p:nvSpPr>
+          <p:cNvPr id="11" name="">
+            <a:extLst xmlns:a="http://schemas.openxmlformats.org/drawingml/2006/main">
+              <a:ext uri="{FF2B5EF4-FFF2-40B4-BE49-F238E27FC236}">
+                <a16:creationId xmlns:a16="http://schemas.microsoft.com/office/drawing/2014/main" id="{15120C3A-8949-40DB-8D2F-14A2E8DA50D6}"/>
+              </a:ext>
+            </a:extLst>
+          </p:cNvPr>
+          <p:cNvSpPr>
+            <a:spLocks xmlns:a="http://schemas.openxmlformats.org/drawingml/2006/main" noGrp="1"/>
+          </p:cNvSpPr>
+          <p:nvPr/>
+        </p:nvSpPr>
+        <p:spPr>
+          <a:xfrm xmlns:a="http://schemas.openxmlformats.org/drawingml/2006/main">
+            <a:off x="819150" y="7258050"/>
+            <a:ext cx="13525500" cy="381000"/>
+          </a:xfrm>
+          <a:prstGeom xmlns:a="http://schemas.openxmlformats.org/drawingml/2006/main" prst="rect">
+            <a:avLst/>
+          </a:prstGeom>
+          <a:noFill xmlns:a="http://schemas.openxmlformats.org/drawingml/2006/main"/>
+          <a:ln xmlns:a="http://schemas.openxmlformats.org/drawingml/2006/main" w="0">
+            <a:noFill/>
+          </a:ln>
+        </p:spPr>
+        <p:txBody>
+          <a:bodyPr xmlns:a="http://schemas.openxmlformats.org/drawingml/2006/main" wrap="square" lIns="0" tIns="0" rIns="0" bIns="0">
+            <a:noAutofit/>
+          </a:bodyPr>
+          <a:lstStyle xmlns:a="http://schemas.openxmlformats.org/drawingml/2006/main"/>
+          <a:p xmlns:a="http://schemas.openxmlformats.org/drawingml/2006/main">
+            <a:pPr>
+              <a:defRPr sz="1875" b="0">
+                <a:solidFill>
+                  <a:srgbClr val="5E706B"/>
+                </a:solidFill>
+                <a:latin typeface="Apple SD Gothic Neo"/>
+                <a:ea typeface="Apple SD Gothic Neo"/>
+                <a:cs typeface="Apple SD Gothic Neo"/>
+              </a:defRPr>
+            </a:pPr>
+            <a:r>
+              <a:rPr sz="1875" b="0">
+                <a:solidFill>
+                  <a:srgbClr val="5E706B"/>
+                </a:solidFill>
+                <a:latin typeface="Apple SD Gothic Neo"/>
+                <a:ea typeface="Apple SD Gothic Neo"/>
+                <a:cs typeface="Apple SD Gothic Neo"/>
+              </a:rPr>
+              <a:t>HS 분류 단계만 비교했습니다. 전체 URL 분석시간이나 운영 SLA의 개선율이 아닙니다.</a:t>
+            </a:r>
+          </a:p>
+        </p:txBody>
+      </p:sp>
+    </p:spTree>
+    <p:extLst>
+      <p:ext uri="{BB962C8B-B14F-4D97-AF65-F5344CB8AC3E}">
+        <p14:creationId xmlns:p14="http://schemas.microsoft.com/office/powerpoint/2010/main" val="2062628700"/>
+      </p:ext>
+    </p:extLst>
+  </p:cSld>
+</p:sld>
+</file>
+
+<file path=ppt/slides/slide18.xml><?xml version="1.0" encoding="utf-8"?>
+<p:sld xmlns:p="http://schemas.openxmlformats.org/presentationml/2006/main">
+  <p:cSld>
+    <p:bg>
+      <p:bgPr>
+        <a:solidFill xmlns:a="http://schemas.openxmlformats.org/drawingml/2006/main">
+          <a:srgbClr val="F8F8F3"/>
+        </a:solidFill>
+      </p:bgPr>
+    </p:bg>
+    <p:spTree>
+      <p:nvGrpSpPr>
+        <p:cNvPr id="1" name=""/>
+        <p:cNvGrpSpPr/>
+        <p:nvPr/>
+      </p:nvGrpSpPr>
+      <p:grpSpPr>
+        <a:xfrm xmlns:a="http://schemas.openxmlformats.org/drawingml/2006/main"/>
+      </p:grpSpPr>
+      <p:sp>
+        <p:nvSpPr>
+          <p:cNvPr id="8" name="">
+            <a:extLst xmlns:a="http://schemas.openxmlformats.org/drawingml/2006/main">
+              <a:ext uri="{FF2B5EF4-FFF2-40B4-BE49-F238E27FC236}">
+                <a16:creationId xmlns:a16="http://schemas.microsoft.com/office/drawing/2014/main" id="{0BED836E-2E09-4737-8347-3EBAA0C1B807}"/>
+              </a:ext>
+            </a:extLst>
+          </p:cNvPr>
+          <p:cNvSpPr>
+            <a:spLocks xmlns:a="http://schemas.openxmlformats.org/drawingml/2006/main" noGrp="1"/>
+          </p:cNvSpPr>
+          <p:nvPr/>
+        </p:nvSpPr>
+        <p:spPr>
+          <a:xfrm xmlns:a="http://schemas.openxmlformats.org/drawingml/2006/main">
+            <a:off x="800100" y="609600"/>
+            <a:ext cx="13620750" cy="781050"/>
+          </a:xfrm>
+          <a:prstGeom xmlns:a="http://schemas.openxmlformats.org/drawingml/2006/main" prst="rect">
+            <a:avLst/>
+          </a:prstGeom>
+          <a:noFill xmlns:a="http://schemas.openxmlformats.org/drawingml/2006/main"/>
+          <a:ln xmlns:a="http://schemas.openxmlformats.org/drawingml/2006/main" w="0">
+            <a:noFill/>
+          </a:ln>
+        </p:spPr>
+        <p:txBody>
+          <a:bodyPr xmlns:a="http://schemas.openxmlformats.org/drawingml/2006/main" wrap="square" lIns="0" tIns="0" rIns="0" bIns="0">
+            <a:noAutofit/>
+          </a:bodyPr>
+          <a:lstStyle xmlns:a="http://schemas.openxmlformats.org/drawingml/2006/main"/>
+          <a:p xmlns:a="http://schemas.openxmlformats.org/drawingml/2006/main">
+            <a:pPr>
+              <a:defRPr sz="3675" b="1">
+                <a:solidFill>
+                  <a:srgbClr val="182C29"/>
+                </a:solidFill>
+                <a:latin typeface="Apple SD Gothic Neo"/>
+                <a:ea typeface="Apple SD Gothic Neo"/>
+                <a:cs typeface="Apple SD Gothic Neo"/>
+              </a:defRPr>
+            </a:pPr>
+            <a:r>
+              <a:rPr sz="3675" b="1">
+                <a:solidFill>
+                  <a:srgbClr val="182C29"/>
+                </a:solidFill>
+                <a:latin typeface="Apple SD Gothic Neo"/>
+                <a:ea typeface="Apple SD Gothic Neo"/>
+                <a:cs typeface="Apple SD Gothic Neo"/>
+              </a:rPr>
+              <a:t>품질은 평가 기준별로 구분했습니다</a:t>
+            </a:r>
+          </a:p>
+        </p:txBody>
+      </p:sp>
+      <p:sp>
+        <p:nvSpPr>
+          <p:cNvPr id="2" name="">
+            <a:extLst xmlns:a="http://schemas.openxmlformats.org/drawingml/2006/main">
+              <a:ext uri="{FF2B5EF4-FFF2-40B4-BE49-F238E27FC236}">
+                <a16:creationId xmlns:a16="http://schemas.microsoft.com/office/drawing/2014/main" id="{6AEFAC60-7114-4DA1-86BC-D3A68574D6B6}"/>
+              </a:ext>
+            </a:extLst>
+          </p:cNvPr>
+          <p:cNvSpPr>
+            <a:spLocks xmlns:a="http://schemas.openxmlformats.org/drawingml/2006/main" noGrp="1"/>
+          </p:cNvSpPr>
+          <p:nvPr/>
+        </p:nvSpPr>
+        <p:spPr>
+          <a:xfrm xmlns:a="http://schemas.openxmlformats.org/drawingml/2006/main">
+            <a:off x="819150" y="1533525"/>
+            <a:ext cx="13525500" cy="781050"/>
+          </a:xfrm>
+          <a:prstGeom xmlns:a="http://schemas.openxmlformats.org/drawingml/2006/main" prst="rect">
+            <a:avLst/>
+          </a:prstGeom>
+          <a:noFill xmlns:a="http://schemas.openxmlformats.org/drawingml/2006/main"/>
+          <a:ln xmlns:a="http://schemas.openxmlformats.org/drawingml/2006/main" w="0">
+            <a:noFill/>
+          </a:ln>
+        </p:spPr>
+        <p:txBody>
+          <a:bodyPr xmlns:a="http://schemas.openxmlformats.org/drawingml/2006/main" wrap="square" lIns="0" tIns="0" rIns="0" bIns="0">
+            <a:noAutofit/>
+          </a:bodyPr>
+          <a:lstStyle xmlns:a="http://schemas.openxmlformats.org/drawingml/2006/main"/>
+          <a:p xmlns:a="http://schemas.openxmlformats.org/drawingml/2006/main">
+            <a:pPr>
+              <a:defRPr sz="2100" b="0">
+                <a:solidFill>
+                  <a:srgbClr val="5E706B"/>
+                </a:solidFill>
+                <a:latin typeface="Apple SD Gothic Neo"/>
+                <a:ea typeface="Apple SD Gothic Neo"/>
+                <a:cs typeface="Apple SD Gothic Neo"/>
+              </a:defRPr>
+            </a:pPr>
+            <a:r>
+              <a:rPr sz="2100" b="0">
+                <a:solidFill>
+                  <a:srgbClr val="5E706B"/>
+                </a:solidFill>
+                <a:latin typeface="Apple SD Gothic Neo"/>
+                <a:ea typeface="Apple SD Gothic Neo"/>
+                <a:cs typeface="Apple SD Gothic Neo"/>
+              </a:rPr>
+              <a:t>메루카리의 상위 모델 HS6 일치율84%를 기록했고, HF 정확도 차이도 확인했습니다.</a:t>
+            </a:r>
+          </a:p>
+        </p:txBody>
+      </p:sp>
+      <p:sp>
+        <p:nvSpPr>
+          <p:cNvPr id="3" name="">
+            <a:extLst xmlns:a="http://schemas.openxmlformats.org/drawingml/2006/main">
+              <a:ext uri="{FF2B5EF4-FFF2-40B4-BE49-F238E27FC236}">
+                <a16:creationId xmlns:a16="http://schemas.microsoft.com/office/drawing/2014/main" id="{E248D299-3D70-4881-8335-A473265A68D3}"/>
+              </a:ext>
+            </a:extLst>
+          </p:cNvPr>
+          <p:cNvSpPr>
+            <a:spLocks xmlns:a="http://schemas.openxmlformats.org/drawingml/2006/main" noGrp="1"/>
+          </p:cNvSpPr>
+          <p:nvPr/>
+        </p:nvSpPr>
+        <p:spPr>
+          <a:xfrm xmlns:a="http://schemas.openxmlformats.org/drawingml/2006/main">
+            <a:off x="819150" y="8058150"/>
+            <a:ext cx="13620750" cy="285750"/>
+          </a:xfrm>
+          <a:prstGeom xmlns:a="http://schemas.openxmlformats.org/drawingml/2006/main" prst="rect">
+            <a:avLst/>
+          </a:prstGeom>
+          <a:noFill xmlns:a="http://schemas.openxmlformats.org/drawingml/2006/main"/>
+          <a:ln xmlns:a="http://schemas.openxmlformats.org/drawingml/2006/main" w="0">
+            <a:noFill/>
+          </a:ln>
+        </p:spPr>
+        <p:txBody>
+          <a:bodyPr xmlns:a="http://schemas.openxmlformats.org/drawingml/2006/main" wrap="square" lIns="0" tIns="0" rIns="0" bIns="0">
+            <a:noAutofit/>
+          </a:bodyPr>
+          <a:lstStyle xmlns:a="http://schemas.openxmlformats.org/drawingml/2006/main"/>
+          <a:p xmlns:a="http://schemas.openxmlformats.org/drawingml/2006/main">
+            <a:pPr>
+              <a:defRPr sz="1350" b="0">
+                <a:solidFill>
+                  <a:srgbClr val="5E706B"/>
+                </a:solidFill>
+                <a:latin typeface="Apple SD Gothic Neo"/>
+                <a:ea typeface="Apple SD Gothic Neo"/>
+                <a:cs typeface="Apple SD Gothic Neo"/>
+              </a:defRPr>
+            </a:pPr>
+            <a:r>
+              <a:rPr sz="1350" b="0">
+                <a:solidFill>
+                  <a:srgbClr val="5E706B"/>
+                </a:solidFill>
+                <a:latin typeface="Apple SD Gothic Neo"/>
+                <a:ea typeface="Apple SD Gothic Neo"/>
+                <a:cs typeface="Apple SD Gothic Neo"/>
+              </a:rPr>
+              <a:t>18   윤장한 · 직구 조사와 도구 구현 · 부록 · 2026.10.06</a:t>
+            </a:r>
+          </a:p>
+        </p:txBody>
+      </p:sp>
+      <p:graphicFrame>
+        <p:nvGraphicFramePr>
+          <p:cNvPr id="11" name=""/>
+          <p:cNvGraphicFramePr/>
+          <p:nvPr/>
+        </p:nvGraphicFramePr>
+        <p:xfrm>
+          <a:off xmlns:a="http://schemas.openxmlformats.org/drawingml/2006/main" x="819150" y="2695575"/>
+          <a:ext xmlns:a="http://schemas.openxmlformats.org/drawingml/2006/main" cx="13601700" cy="2781300"/>
+        </p:xfrm>
+        <a:graphic xmlns:a="http://schemas.openxmlformats.org/drawingml/2006/main">
+          <a:graphicData uri="http://schemas.openxmlformats.org/drawingml/2006/table">
+            <a:tbl>
+              <a:tblPr/>
+              <a:tblGrid>
+                <a:gridCol w="7734300"/>
+                <a:gridCol w="2933700"/>
+                <a:gridCol w="2933700"/>
+              </a:tblGrid>
+              <a:tr h="695325">
+                <a:tc>
+                  <a:txBody>
+                    <a:bodyPr/>
+                    <a:lstStyle/>
+                    <a:p>
+                      <a:r>
+                        <a:rPr sz="2025" b="1">
+                          <a:solidFill>
+                            <a:srgbClr val="FFFFFF"/>
+                          </a:solidFill>
+                          <a:latin typeface="Apple SD Gothic Neo"/>
+                          <a:ea typeface="Apple SD Gothic Neo"/>
+                          <a:cs typeface="Apple SD Gothic Neo"/>
+                        </a:rPr>
+                        <a:t>평가 기준</a:t>
+                      </a:r>
+                    </a:p>
+                  </a:txBody>
+                  <a:tcPr marL="91440" marR="91440" marT="45720" marB="45720">
+                    <a:solidFill>
+                      <a:srgbClr val="182C29"/>
+                    </a:solidFill>
+                  </a:tcPr>
+                </a:tc>
+                <a:tc>
+                  <a:txBody>
+                    <a:bodyPr/>
+                    <a:lstStyle/>
+                    <a:p>
+                      <a:r>
+                        <a:rPr sz="2025" b="1">
+                          <a:solidFill>
+                            <a:srgbClr val="FFFFFF"/>
+                          </a:solidFill>
+                          <a:latin typeface="Apple SD Gothic Neo"/>
+                          <a:ea typeface="Apple SD Gothic Neo"/>
+                          <a:cs typeface="Apple SD Gothic Neo"/>
+                        </a:rPr>
+                        <a:t>Jev</a:t>
+                      </a:r>
+                    </a:p>
+                  </a:txBody>
+                  <a:tcPr marL="91440" marR="91440" marT="45720" marB="45720">
+                    <a:solidFill>
+                      <a:srgbClr val="182C29"/>
+                    </a:solidFill>
+                  </a:tcPr>
+                </a:tc>
+                <a:tc>
+                  <a:txBody>
+                    <a:bodyPr/>
+                    <a:lstStyle/>
+                    <a:p>
+                      <a:r>
+                        <a:rPr sz="2025" b="1">
+                          <a:solidFill>
+                            <a:srgbClr val="FFFFFF"/>
+                          </a:solidFill>
+                          <a:latin typeface="Apple SD Gothic Neo"/>
+                          <a:ea typeface="Apple SD Gothic Neo"/>
+                          <a:cs typeface="Apple SD Gothic Neo"/>
+                        </a:rPr>
+                        <a:t>GPT-6 Luna</a:t>
+                      </a:r>
+                    </a:p>
+                  </a:txBody>
+                  <a:tcPr marL="91440" marR="91440" marT="45720" marB="45720">
+                    <a:solidFill>
+                      <a:srgbClr val="182C29"/>
+                    </a:solidFill>
+                  </a:tcPr>
+                </a:tc>
+              </a:tr>
+              <a:tr h="695325">
+                <a:tc>
+                  <a:txBody>
+                    <a:bodyPr/>
+                    <a:lstStyle/>
+                    <a:p>
+                      <a:r>
+                        <a:rPr sz="2175" b="0">
+                          <a:solidFill>
+                            <a:srgbClr val="182C29"/>
+                          </a:solidFill>
+                          <a:latin typeface="Apple SD Gothic Neo"/>
+                          <a:ea typeface="Apple SD Gothic Neo"/>
+                          <a:cs typeface="Apple SD Gothic Neo"/>
+                        </a:rPr>
+                        <a:t>HF 전문가 라벨 · 전체94개 HS6 정확도</a:t>
+                      </a:r>
+                    </a:p>
+                  </a:txBody>
+                  <a:tcPr marL="91440" marR="91440" marT="45720" marB="45720">
+                    <a:solidFill>
+                      <a:srgbClr val="FFFFFF"/>
+                    </a:solidFill>
+                  </a:tcPr>
+                </a:tc>
+                <a:tc>
+                  <a:txBody>
+                    <a:bodyPr/>
+                    <a:lstStyle/>
+                    <a:p>
+                      <a:r>
+                        <a:rPr sz="2175" b="0">
+                          <a:solidFill>
+                            <a:srgbClr val="182C29"/>
+                          </a:solidFill>
+                          <a:latin typeface="Apple SD Gothic Neo"/>
+                          <a:ea typeface="Apple SD Gothic Neo"/>
+                          <a:cs typeface="Apple SD Gothic Neo"/>
+                        </a:rPr>
+                        <a:t>29.8% (28/94)</a:t>
+                      </a:r>
+                    </a:p>
+                  </a:txBody>
+                  <a:tcPr marL="91440" marR="91440" marT="45720" marB="45720">
+                    <a:solidFill>
+                      <a:srgbClr val="FFFFFF"/>
+                    </a:solidFill>
+                  </a:tcPr>
+                </a:tc>
+                <a:tc>
+                  <a:txBody>
+                    <a:bodyPr/>
+                    <a:lstStyle/>
+                    <a:p>
+                      <a:r>
+                        <a:rPr sz="2175" b="0">
+                          <a:solidFill>
+                            <a:srgbClr val="182C29"/>
+                          </a:solidFill>
+                          <a:latin typeface="Apple SD Gothic Neo"/>
+                          <a:ea typeface="Apple SD Gothic Neo"/>
+                          <a:cs typeface="Apple SD Gothic Neo"/>
+                        </a:rPr>
+                        <a:t>38.3% (36/94)</a:t>
+                      </a:r>
+                    </a:p>
+                  </a:txBody>
+                  <a:tcPr marL="91440" marR="91440" marT="45720" marB="45720">
+                    <a:solidFill>
+                      <a:srgbClr val="FFFFFF"/>
+                    </a:solidFill>
+                  </a:tcPr>
+                </a:tc>
+              </a:tr>
+              <a:tr h="695325">
+                <a:tc>
+                  <a:txBody>
+                    <a:bodyPr/>
+                    <a:lstStyle/>
+                    <a:p>
+                      <a:r>
+                        <a:rPr sz="2175" b="0">
+                          <a:solidFill>
+                            <a:srgbClr val="182C29"/>
+                          </a:solidFill>
+                          <a:latin typeface="Apple SD Gothic Neo"/>
+                          <a:ea typeface="Apple SD Gothic Neo"/>
+                          <a:cs typeface="Apple SD Gothic Neo"/>
+                        </a:rPr>
+                        <a:t>메루카리 · 심사자 HS6 일치 (25개)</a:t>
+                      </a:r>
+                    </a:p>
+                  </a:txBody>
+                  <a:tcPr marL="91440" marR="91440" marT="45720" marB="45720">
+                    <a:solidFill>
+                      <a:srgbClr val="F8F8F3"/>
+                    </a:solidFill>
+                  </a:tcPr>
+                </a:tc>
+                <a:tc>
+                  <a:txBody>
+                    <a:bodyPr/>
+                    <a:lstStyle/>
+                    <a:p>
+                      <a:r>
+                        <a:rPr sz="2175" b="0">
+                          <a:solidFill>
+                            <a:srgbClr val="182C29"/>
+                          </a:solidFill>
+                          <a:latin typeface="Apple SD Gothic Neo"/>
+                          <a:ea typeface="Apple SD Gothic Neo"/>
+                          <a:cs typeface="Apple SD Gothic Neo"/>
+                        </a:rPr>
+                        <a:t>84.0% (21/25)</a:t>
+                      </a:r>
+                    </a:p>
+                  </a:txBody>
+                  <a:tcPr marL="91440" marR="91440" marT="45720" marB="45720">
+                    <a:solidFill>
+                      <a:srgbClr val="F8F8F3"/>
+                    </a:solidFill>
+                  </a:tcPr>
+                </a:tc>
+                <a:tc>
+                  <a:txBody>
+                    <a:bodyPr/>
+                    <a:lstStyle/>
+                    <a:p>
+                      <a:r>
+                        <a:rPr sz="2175" b="0">
+                          <a:solidFill>
+                            <a:srgbClr val="182C29"/>
+                          </a:solidFill>
+                          <a:latin typeface="Apple SD Gothic Neo"/>
+                          <a:ea typeface="Apple SD Gothic Neo"/>
+                          <a:cs typeface="Apple SD Gothic Neo"/>
+                        </a:rPr>
+                        <a:t>76.0% (19/25)</a:t>
+                      </a:r>
+                    </a:p>
+                  </a:txBody>
+                  <a:tcPr marL="91440" marR="91440" marT="45720" marB="45720">
+                    <a:solidFill>
+                      <a:srgbClr val="F8F8F3"/>
+                    </a:solidFill>
+                  </a:tcPr>
+                </a:tc>
+              </a:tr>
+              <a:tr h="695325">
+                <a:tc>
+                  <a:txBody>
+                    <a:bodyPr/>
+                    <a:lstStyle/>
+                    <a:p>
+                      <a:r>
+                        <a:rPr sz="2175" b="0">
+                          <a:solidFill>
+                            <a:srgbClr val="182C29"/>
+                          </a:solidFill>
+                          <a:latin typeface="Apple SD Gothic Neo"/>
+                          <a:ea typeface="Apple SD Gothic Neo"/>
+                          <a:cs typeface="Apple SD Gothic Neo"/>
+                        </a:rPr>
+                        <a:t>메루카리 · 보류 포함 전체 판단 일치</a:t>
+                      </a:r>
+                    </a:p>
+                  </a:txBody>
+                  <a:tcPr marL="91440" marR="91440" marT="45720" marB="45720">
+                    <a:solidFill>
+                      <a:srgbClr val="FFFFFF"/>
+                    </a:solidFill>
+                  </a:tcPr>
+                </a:tc>
+                <a:tc>
+                  <a:txBody>
+                    <a:bodyPr/>
+                    <a:lstStyle/>
+                    <a:p>
+                      <a:r>
+                        <a:rPr sz="2175" b="0">
+                          <a:solidFill>
+                            <a:srgbClr val="182C29"/>
+                          </a:solidFill>
+                          <a:latin typeface="Apple SD Gothic Neo"/>
+                          <a:ea typeface="Apple SD Gothic Neo"/>
+                          <a:cs typeface="Apple SD Gothic Neo"/>
+                        </a:rPr>
+                        <a:t>70.0% (21/30)</a:t>
+                      </a:r>
+                    </a:p>
+                  </a:txBody>
+                  <a:tcPr marL="91440" marR="91440" marT="45720" marB="45720">
+                    <a:solidFill>
+                      <a:srgbClr val="FFFFFF"/>
+                    </a:solidFill>
+                  </a:tcPr>
+                </a:tc>
+                <a:tc>
+                  <a:txBody>
+                    <a:bodyPr/>
+                    <a:lstStyle/>
+                    <a:p>
+                      <a:r>
+                        <a:rPr sz="2175" b="0">
+                          <a:solidFill>
+                            <a:srgbClr val="182C29"/>
+                          </a:solidFill>
+                          <a:latin typeface="Apple SD Gothic Neo"/>
+                          <a:ea typeface="Apple SD Gothic Neo"/>
+                          <a:cs typeface="Apple SD Gothic Neo"/>
+                        </a:rPr>
+                        <a:t>76.7% (23/30)</a:t>
+                      </a:r>
+                    </a:p>
+                  </a:txBody>
+                  <a:tcPr marL="91440" marR="91440" marT="45720" marB="45720">
+                    <a:solidFill>
+                      <a:srgbClr val="FFFFFF"/>
+                    </a:solidFill>
+                  </a:tcPr>
+                </a:tc>
+              </a:tr>
+            </a:tbl>
+          </a:graphicData>
+        </a:graphic>
+      </p:graphicFrame>
+      <p:sp>
+        <p:nvSpPr>
+          <p:cNvPr id="5" name="">
+            <a:extLst xmlns:a="http://schemas.openxmlformats.org/drawingml/2006/main">
+              <a:ext uri="{FF2B5EF4-FFF2-40B4-BE49-F238E27FC236}">
+                <a16:creationId xmlns:a16="http://schemas.microsoft.com/office/drawing/2014/main" id="{224A75FC-55E6-4362-9697-AAD1F7632591}"/>
+              </a:ext>
+            </a:extLst>
+          </p:cNvPr>
+          <p:cNvSpPr>
+            <a:spLocks xmlns:a="http://schemas.openxmlformats.org/drawingml/2006/main" noGrp="1"/>
+          </p:cNvSpPr>
+          <p:nvPr/>
+        </p:nvSpPr>
+        <p:spPr>
+          <a:xfrm xmlns:a="http://schemas.openxmlformats.org/drawingml/2006/main">
+            <a:off x="819150" y="5791200"/>
+            <a:ext cx="13525500" cy="523875"/>
+          </a:xfrm>
+          <a:prstGeom xmlns:a="http://schemas.openxmlformats.org/drawingml/2006/main" prst="rect">
+            <a:avLst/>
+          </a:prstGeom>
+          <a:noFill xmlns:a="http://schemas.openxmlformats.org/drawingml/2006/main"/>
+          <a:ln xmlns:a="http://schemas.openxmlformats.org/drawingml/2006/main" w="0">
+            <a:noFill/>
+          </a:ln>
+        </p:spPr>
+        <p:txBody>
+          <a:bodyPr xmlns:a="http://schemas.openxmlformats.org/drawingml/2006/main" wrap="square" lIns="0" tIns="0" rIns="0" bIns="0">
+            <a:noAutofit/>
+          </a:bodyPr>
+          <a:lstStyle xmlns:a="http://schemas.openxmlformats.org/drawingml/2006/main"/>
+          <a:p xmlns:a="http://schemas.openxmlformats.org/drawingml/2006/main">
+            <a:pPr>
+              <a:defRPr sz="2025" b="0">
+                <a:solidFill>
+                  <a:srgbClr val="5E706B"/>
+                </a:solidFill>
+                <a:latin typeface="Apple SD Gothic Neo"/>
+                <a:ea typeface="Apple SD Gothic Neo"/>
+                <a:cs typeface="Apple SD Gothic Neo"/>
+              </a:defRPr>
+            </a:pPr>
+            <a:r>
+              <a:rPr sz="2025" b="0">
+                <a:solidFill>
+                  <a:srgbClr val="5E706B"/>
+                </a:solidFill>
+                <a:latin typeface="Apple SD Gothic Neo"/>
+                <a:ea typeface="Apple SD Gothic Neo"/>
+                <a:cs typeface="Apple SD Gothic Neo"/>
+              </a:rPr>
+              <a:t>상위 모델과의 일치는 정답 정확도가 아닙니다. HF에서는 Jev의 정확도가 더 낮았습니다.</a:t>
+            </a:r>
+          </a:p>
+        </p:txBody>
+      </p:sp>
+      <p:sp>
+        <p:nvSpPr>
+          <p:cNvPr id="6" name="">
+            <a:extLst xmlns:a="http://schemas.openxmlformats.org/drawingml/2006/main">
+              <a:ext uri="{FF2B5EF4-FFF2-40B4-BE49-F238E27FC236}">
+                <a16:creationId xmlns:a16="http://schemas.microsoft.com/office/drawing/2014/main" id="{697E0B6D-485E-479C-BC00-9607A4BF7AE8}"/>
+              </a:ext>
+            </a:extLst>
+          </p:cNvPr>
+          <p:cNvSpPr>
+            <a:spLocks xmlns:a="http://schemas.openxmlformats.org/drawingml/2006/main" noGrp="1"/>
+          </p:cNvSpPr>
+          <p:nvPr/>
+        </p:nvSpPr>
+        <p:spPr>
+          <a:xfrm xmlns:a="http://schemas.openxmlformats.org/drawingml/2006/main">
+            <a:off x="819150" y="6477000"/>
+            <a:ext cx="13525500" cy="590550"/>
+          </a:xfrm>
+          <a:prstGeom xmlns:a="http://schemas.openxmlformats.org/drawingml/2006/main" prst="rect">
+            <a:avLst/>
+          </a:prstGeom>
+          <a:noFill xmlns:a="http://schemas.openxmlformats.org/drawingml/2006/main"/>
+          <a:ln xmlns:a="http://schemas.openxmlformats.org/drawingml/2006/main" w="0">
+            <a:noFill/>
+          </a:ln>
+        </p:spPr>
+        <p:txBody>
+          <a:bodyPr xmlns:a="http://schemas.openxmlformats.org/drawingml/2006/main" wrap="square" lIns="0" tIns="0" rIns="0" bIns="0">
+            <a:noAutofit/>
+          </a:bodyPr>
+          <a:lstStyle xmlns:a="http://schemas.openxmlformats.org/drawingml/2006/main"/>
+          <a:p xmlns:a="http://schemas.openxmlformats.org/drawingml/2006/main">
+            <a:pPr>
+              <a:defRPr sz="2250" b="1">
+                <a:solidFill>
+                  <a:srgbClr val="156E58"/>
+                </a:solidFill>
+                <a:latin typeface="Apple SD Gothic Neo"/>
+                <a:ea typeface="Apple SD Gothic Neo"/>
+                <a:cs typeface="Apple SD Gothic Neo"/>
+              </a:defRPr>
+            </a:pPr>
+            <a:r>
+              <a:rPr sz="2250" b="1">
+                <a:solidFill>
+                  <a:srgbClr val="156E58"/>
+                </a:solidFill>
+                <a:latin typeface="Apple SD Gothic Neo"/>
+                <a:ea typeface="Apple SD Gothic Neo"/>
+                <a:cs typeface="Apple SD Gothic Neo"/>
+              </a:rPr>
+              <a:t>도입 방향(제안): 초기 후보 판단을 빠르게 처리하고, 근거 부족·최종 분류는 추가 검토합니다.</a:t>
+            </a:r>
+          </a:p>
+        </p:txBody>
+      </p:sp>
+      <p:sp>
+        <p:nvSpPr>
+          <p:cNvPr id="7" name="">
+            <a:extLst xmlns:a="http://schemas.openxmlformats.org/drawingml/2006/main">
+              <a:ext uri="{FF2B5EF4-FFF2-40B4-BE49-F238E27FC236}">
+                <a16:creationId xmlns:a16="http://schemas.microsoft.com/office/drawing/2014/main" id="{0D8741C7-5AF5-4B15-B2C9-E7206E5AC3BB}"/>
+              </a:ext>
+            </a:extLst>
+          </p:cNvPr>
+          <p:cNvSpPr>
+            <a:spLocks xmlns:a="http://schemas.openxmlformats.org/drawingml/2006/main" noGrp="1"/>
+          </p:cNvSpPr>
+          <p:nvPr/>
+        </p:nvSpPr>
+        <p:spPr>
+          <a:xfrm xmlns:a="http://schemas.openxmlformats.org/drawingml/2006/main">
+            <a:off x="819150" y="7448550"/>
+            <a:ext cx="13525500" cy="371475"/>
+          </a:xfrm>
+          <a:prstGeom xmlns:a="http://schemas.openxmlformats.org/drawingml/2006/main" prst="rect">
+            <a:avLst/>
+          </a:prstGeom>
+          <a:noFill xmlns:a="http://schemas.openxmlformats.org/drawingml/2006/main"/>
+          <a:ln xmlns:a="http://schemas.openxmlformats.org/drawingml/2006/main" w="0">
+            <a:noFill/>
+          </a:ln>
+        </p:spPr>
+        <p:txBody>
+          <a:bodyPr xmlns:a="http://schemas.openxmlformats.org/drawingml/2006/main" wrap="square" lIns="0" tIns="0" rIns="0" bIns="0">
+            <a:noAutofit/>
+          </a:bodyPr>
+          <a:lstStyle xmlns:a="http://schemas.openxmlformats.org/drawingml/2006/main"/>
+          <a:p xmlns:a="http://schemas.openxmlformats.org/drawingml/2006/main">
+            <a:pPr>
+              <a:defRPr sz="1725" b="0">
+                <a:solidFill>
+                  <a:srgbClr val="5E706B"/>
+                </a:solidFill>
+                <a:latin typeface="Apple SD Gothic Neo"/>
+                <a:ea typeface="Apple SD Gothic Neo"/>
+                <a:cs typeface="Apple SD Gothic Neo"/>
+              </a:defRPr>
+            </a:pPr>
+            <a:r>
+              <a:rPr sz="1725" b="0">
+                <a:solidFill>
+                  <a:srgbClr val="5E706B"/>
+                </a:solidFill>
+                <a:latin typeface="Apple SD Gothic Neo"/>
+                <a:ea typeface="Apple SD Gothic Neo"/>
+                <a:cs typeface="Apple SD Gothic Neo"/>
+              </a:rPr>
+              <a:t>실험 코드·노트북·측정 결과: github.com/y00nZZang/product-catalog/tree/main/notebooks</a:t>
+            </a:r>
+          </a:p>
+        </p:txBody>
+      </p:sp>
+    </p:spTree>
+    <p:extLst>
+      <p:ext uri="{BB962C8B-B14F-4D97-AF65-F5344CB8AC3E}">
+        <p14:creationId xmlns:p14="http://schemas.microsoft.com/office/powerpoint/2010/main" val="1627327697"/>
       </p:ext>
     </p:extLst>
   </p:cSld>
@@ -6452,6 +8950,7 @@
           <a:lstStyle xmlns:a="http://schemas.openxmlformats.org/drawingml/2006/main"/>
           <a:p xmlns:a="http://schemas.openxmlformats.org/drawingml/2006/main">
             <a:pPr>
+              <a:buNone/>
               <a:defRPr sz="3675" b="1">
                 <a:solidFill>
                   <a:srgbClr val="182C29"/>
@@ -6509,6 +9008,7 @@
           <a:lstStyle xmlns:a="http://schemas.openxmlformats.org/drawingml/2006/main"/>
           <a:p xmlns:a="http://schemas.openxmlformats.org/drawingml/2006/main">
             <a:pPr>
+              <a:buNone/>
               <a:defRPr sz="2100" b="0">
                 <a:solidFill>
                   <a:srgbClr val="5E706B"/>
@@ -6566,6 +9066,7 @@
           <a:lstStyle xmlns:a="http://schemas.openxmlformats.org/drawingml/2006/main"/>
           <a:p xmlns:a="http://schemas.openxmlformats.org/drawingml/2006/main">
             <a:pPr>
+              <a:buNone/>
               <a:defRPr sz="1350" b="0">
                 <a:solidFill>
                   <a:srgbClr val="5E706B"/>
@@ -6623,6 +9124,7 @@
           <a:lstStyle xmlns:a="http://schemas.openxmlformats.org/drawingml/2006/main"/>
           <a:p xmlns:a="http://schemas.openxmlformats.org/drawingml/2006/main">
             <a:pPr>
+              <a:buNone/>
               <a:defRPr sz="2850" b="1">
                 <a:solidFill>
                   <a:srgbClr val="156E58"/>
@@ -6680,6 +9182,7 @@
           <a:lstStyle xmlns:a="http://schemas.openxmlformats.org/drawingml/2006/main"/>
           <a:p xmlns:a="http://schemas.openxmlformats.org/drawingml/2006/main">
             <a:pPr>
+              <a:buNone/>
               <a:defRPr sz="2775" b="0">
                 <a:solidFill>
                   <a:srgbClr val="182C29"/>
@@ -6703,6 +9206,7 @@
           </a:p>
           <a:p xmlns:a="http://schemas.openxmlformats.org/drawingml/2006/main">
             <a:pPr>
+              <a:buNone/>
               <a:defRPr sz="2775" b="0">
                 <a:solidFill>
                   <a:srgbClr val="182C29"/>
@@ -6726,6 +9230,7 @@
           </a:p>
           <a:p xmlns:a="http://schemas.openxmlformats.org/drawingml/2006/main">
             <a:pPr>
+              <a:buNone/>
               <a:defRPr sz="2775" b="0">
                 <a:solidFill>
                   <a:srgbClr val="182C29"/>
@@ -6783,6 +9288,7 @@
           <a:lstStyle xmlns:a="http://schemas.openxmlformats.org/drawingml/2006/main"/>
           <a:p xmlns:a="http://schemas.openxmlformats.org/drawingml/2006/main">
             <a:pPr>
+              <a:buNone/>
               <a:defRPr sz="2850" b="1">
                 <a:solidFill>
                   <a:srgbClr val="156E58"/>
@@ -6840,6 +9346,7 @@
           <a:lstStyle xmlns:a="http://schemas.openxmlformats.org/drawingml/2006/main"/>
           <a:p xmlns:a="http://schemas.openxmlformats.org/drawingml/2006/main">
             <a:pPr>
+              <a:buNone/>
               <a:defRPr sz="2700" b="0">
                 <a:solidFill>
                   <a:srgbClr val="182C29"/>
@@ -6863,6 +9370,7 @@
           </a:p>
           <a:p xmlns:a="http://schemas.openxmlformats.org/drawingml/2006/main">
             <a:pPr>
+              <a:buNone/>
               <a:defRPr sz="2700" b="0">
                 <a:solidFill>
                   <a:srgbClr val="182C29"/>
@@ -6886,6 +9394,7 @@
           </a:p>
           <a:p xmlns:a="http://schemas.openxmlformats.org/drawingml/2006/main">
             <a:pPr>
+              <a:buNone/>
               <a:defRPr sz="2700" b="0">
                 <a:solidFill>
                   <a:srgbClr val="182C29"/>
@@ -6943,6 +9452,7 @@
           <a:lstStyle xmlns:a="http://schemas.openxmlformats.org/drawingml/2006/main"/>
           <a:p xmlns:a="http://schemas.openxmlformats.org/drawingml/2006/main">
             <a:pPr>
+              <a:buNone/>
               <a:defRPr sz="2100" b="0">
                 <a:solidFill>
                   <a:srgbClr val="5E706B"/>
@@ -7029,6 +9539,7 @@
           <a:lstStyle xmlns:a="http://schemas.openxmlformats.org/drawingml/2006/main"/>
           <a:p xmlns:a="http://schemas.openxmlformats.org/drawingml/2006/main">
             <a:pPr>
+              <a:buNone/>
               <a:defRPr sz="3675" b="1">
                 <a:solidFill>
                   <a:srgbClr val="182C29"/>
@@ -7086,6 +9597,7 @@
           <a:lstStyle xmlns:a="http://schemas.openxmlformats.org/drawingml/2006/main"/>
           <a:p xmlns:a="http://schemas.openxmlformats.org/drawingml/2006/main">
             <a:pPr>
+              <a:buNone/>
               <a:defRPr sz="2100" b="0">
                 <a:solidFill>
                   <a:srgbClr val="5E706B"/>
@@ -7143,6 +9655,7 @@
           <a:lstStyle xmlns:a="http://schemas.openxmlformats.org/drawingml/2006/main"/>
           <a:p xmlns:a="http://schemas.openxmlformats.org/drawingml/2006/main">
             <a:pPr>
+              <a:buNone/>
               <a:defRPr sz="1350" b="0">
                 <a:solidFill>
                   <a:srgbClr val="5E706B"/>
@@ -7168,7 +9681,7 @@
       </p:sp>
       <p:graphicFrame>
         <p:nvGraphicFramePr>
-          <p:cNvPr id="9" name=""/>
+          <p:cNvPr id="11" name=""/>
           <p:cNvGraphicFramePr/>
           <p:nvPr/>
         </p:nvGraphicFramePr>
@@ -7485,6 +9998,7 @@
           <a:lstStyle xmlns:a="http://schemas.openxmlformats.org/drawingml/2006/main"/>
           <a:p xmlns:a="http://schemas.openxmlformats.org/drawingml/2006/main">
             <a:pPr>
+              <a:buNone/>
               <a:defRPr sz="2100" b="0">
                 <a:solidFill>
                   <a:srgbClr val="182C29"/>
@@ -7571,6 +10085,7 @@
           <a:lstStyle xmlns:a="http://schemas.openxmlformats.org/drawingml/2006/main"/>
           <a:p xmlns:a="http://schemas.openxmlformats.org/drawingml/2006/main">
             <a:pPr>
+              <a:buNone/>
               <a:defRPr sz="3675" b="1">
                 <a:solidFill>
                   <a:srgbClr val="182C29"/>
@@ -7628,6 +10143,7 @@
           <a:lstStyle xmlns:a="http://schemas.openxmlformats.org/drawingml/2006/main"/>
           <a:p xmlns:a="http://schemas.openxmlformats.org/drawingml/2006/main">
             <a:pPr>
+              <a:buNone/>
               <a:defRPr sz="2100" b="0">
                 <a:solidFill>
                   <a:srgbClr val="5E706B"/>
@@ -7685,6 +10201,7 @@
           <a:lstStyle xmlns:a="http://schemas.openxmlformats.org/drawingml/2006/main"/>
           <a:p xmlns:a="http://schemas.openxmlformats.org/drawingml/2006/main">
             <a:pPr>
+              <a:buNone/>
               <a:defRPr sz="1350" b="0">
                 <a:solidFill>
                   <a:srgbClr val="5E706B"/>
@@ -7710,14 +10227,14 @@
       </p:sp>
       <p:pic>
         <p:nvPicPr>
-          <p:cNvPr id="12" name=""/>
+          <p:cNvPr id="15" name=""/>
           <p:cNvPicPr>
             <a:picLocks xmlns:a="http://schemas.openxmlformats.org/drawingml/2006/main" noChangeAspect="1"/>
           </p:cNvPicPr>
           <p:nvPr/>
         </p:nvPicPr>
         <p:blipFill>
-          <a:blip xmlns:r="http://schemas.openxmlformats.org/officeDocument/2006/relationships" xmlns:a="http://schemas.openxmlformats.org/drawingml/2006/main" r:embed="Rfa41460f95094426"/>
+          <a:blip xmlns:r="http://schemas.openxmlformats.org/officeDocument/2006/relationships" xmlns:a="http://schemas.openxmlformats.org/drawingml/2006/main" r:embed="R5dd6ef231bbc4553"/>
           <a:stretch xmlns:a="http://schemas.openxmlformats.org/drawingml/2006/main"/>
         </p:blipFill>
         <p:spPr>
@@ -7732,7 +10249,7 @@
       </p:pic>
       <p:graphicFrame>
         <p:nvGraphicFramePr>
-          <p:cNvPr id="13" name=""/>
+          <p:cNvPr id="16" name=""/>
           <p:cNvGraphicFramePr/>
           <p:nvPr/>
         </p:nvGraphicFramePr>
@@ -8599,6 +11116,7 @@
           <a:lstStyle xmlns:a="http://schemas.openxmlformats.org/drawingml/2006/main"/>
           <a:p xmlns:a="http://schemas.openxmlformats.org/drawingml/2006/main">
             <a:pPr>
+              <a:buNone/>
               <a:defRPr sz="1650" b="0">
                 <a:solidFill>
                   <a:srgbClr val="182C29"/>
@@ -8656,6 +11174,7 @@
           <a:lstStyle xmlns:a="http://schemas.openxmlformats.org/drawingml/2006/main"/>
           <a:p xmlns:a="http://schemas.openxmlformats.org/drawingml/2006/main">
             <a:pPr>
+              <a:buNone/>
               <a:defRPr sz="1575" b="0">
                 <a:solidFill>
                   <a:srgbClr val="182C29"/>
@@ -8713,6 +11232,7 @@
           <a:lstStyle xmlns:a="http://schemas.openxmlformats.org/drawingml/2006/main"/>
           <a:p xmlns:a="http://schemas.openxmlformats.org/drawingml/2006/main">
             <a:pPr>
+              <a:buNone/>
               <a:defRPr sz="1575" b="0">
                 <a:solidFill>
                   <a:srgbClr val="5E706B"/>
@@ -8799,6 +11319,7 @@
           <a:lstStyle xmlns:a="http://schemas.openxmlformats.org/drawingml/2006/main"/>
           <a:p xmlns:a="http://schemas.openxmlformats.org/drawingml/2006/main">
             <a:pPr>
+              <a:buNone/>
               <a:defRPr sz="3675" b="1">
                 <a:solidFill>
                   <a:srgbClr val="182C29"/>
@@ -8856,6 +11377,7 @@
           <a:lstStyle xmlns:a="http://schemas.openxmlformats.org/drawingml/2006/main"/>
           <a:p xmlns:a="http://schemas.openxmlformats.org/drawingml/2006/main">
             <a:pPr>
+              <a:buNone/>
               <a:defRPr sz="2100" b="0">
                 <a:solidFill>
                   <a:srgbClr val="5E706B"/>
@@ -8913,6 +11435,7 @@
           <a:lstStyle xmlns:a="http://schemas.openxmlformats.org/drawingml/2006/main"/>
           <a:p xmlns:a="http://schemas.openxmlformats.org/drawingml/2006/main">
             <a:pPr>
+              <a:buNone/>
               <a:defRPr sz="1350" b="0">
                 <a:solidFill>
                   <a:srgbClr val="5E706B"/>
@@ -8970,6 +11493,7 @@
           <a:lstStyle xmlns:a="http://schemas.openxmlformats.org/drawingml/2006/main"/>
           <a:p xmlns:a="http://schemas.openxmlformats.org/drawingml/2006/main">
             <a:pPr>
+              <a:buNone/>
               <a:defRPr sz="2775" b="1">
                 <a:solidFill>
                   <a:srgbClr val="156E58"/>
@@ -9027,6 +11551,7 @@
           <a:lstStyle xmlns:a="http://schemas.openxmlformats.org/drawingml/2006/main"/>
           <a:p xmlns:a="http://schemas.openxmlformats.org/drawingml/2006/main">
             <a:pPr>
+              <a:buNone/>
               <a:defRPr sz="2400" b="0">
                 <a:solidFill>
                   <a:srgbClr val="182C29"/>
@@ -9050,6 +11575,7 @@
           </a:p>
           <a:p xmlns:a="http://schemas.openxmlformats.org/drawingml/2006/main">
             <a:pPr>
+              <a:buNone/>
               <a:defRPr sz="2400" b="0">
                 <a:solidFill>
                   <a:srgbClr val="182C29"/>
@@ -9073,6 +11599,7 @@
           </a:p>
           <a:p xmlns:a="http://schemas.openxmlformats.org/drawingml/2006/main">
             <a:pPr>
+              <a:buNone/>
               <a:defRPr sz="2400" b="0">
                 <a:solidFill>
                   <a:srgbClr val="182C29"/>
@@ -9130,6 +11657,7 @@
           <a:lstStyle xmlns:a="http://schemas.openxmlformats.org/drawingml/2006/main"/>
           <a:p xmlns:a="http://schemas.openxmlformats.org/drawingml/2006/main">
             <a:pPr>
+              <a:buNone/>
               <a:defRPr sz="2250" b="0">
                 <a:solidFill>
                   <a:srgbClr val="182C29"/>
@@ -9153,6 +11681,7 @@
           </a:p>
           <a:p xmlns:a="http://schemas.openxmlformats.org/drawingml/2006/main">
             <a:pPr>
+              <a:buNone/>
               <a:defRPr sz="2250" b="0">
                 <a:solidFill>
                   <a:srgbClr val="182C29"/>
@@ -9210,6 +11739,7 @@
           <a:lstStyle xmlns:a="http://schemas.openxmlformats.org/drawingml/2006/main"/>
           <a:p xmlns:a="http://schemas.openxmlformats.org/drawingml/2006/main">
             <a:pPr>
+              <a:buNone/>
               <a:defRPr sz="2775" b="1">
                 <a:solidFill>
                   <a:srgbClr val="156E58"/>
@@ -9267,6 +11797,7 @@
           <a:lstStyle xmlns:a="http://schemas.openxmlformats.org/drawingml/2006/main"/>
           <a:p xmlns:a="http://schemas.openxmlformats.org/drawingml/2006/main">
             <a:pPr>
+              <a:buNone/>
               <a:defRPr sz="2400" b="0">
                 <a:solidFill>
                   <a:srgbClr val="182C29"/>
@@ -9290,6 +11821,7 @@
           </a:p>
           <a:p xmlns:a="http://schemas.openxmlformats.org/drawingml/2006/main">
             <a:pPr>
+              <a:buNone/>
               <a:defRPr sz="2400" b="0">
                 <a:solidFill>
                   <a:srgbClr val="182C29"/>
@@ -9313,6 +11845,7 @@
           </a:p>
           <a:p xmlns:a="http://schemas.openxmlformats.org/drawingml/2006/main">
             <a:pPr>
+              <a:buNone/>
               <a:defRPr sz="2400" b="0">
                 <a:solidFill>
                   <a:srgbClr val="182C29"/>
@@ -9370,6 +11903,7 @@
           <a:lstStyle xmlns:a="http://schemas.openxmlformats.org/drawingml/2006/main"/>
           <a:p xmlns:a="http://schemas.openxmlformats.org/drawingml/2006/main">
             <a:pPr>
+              <a:buNone/>
               <a:defRPr sz="2250" b="0">
                 <a:solidFill>
                   <a:srgbClr val="182C29"/>
@@ -9393,6 +11927,7 @@
           </a:p>
           <a:p xmlns:a="http://schemas.openxmlformats.org/drawingml/2006/main">
             <a:pPr>
+              <a:buNone/>
               <a:defRPr sz="2250" b="0">
                 <a:solidFill>
                   <a:srgbClr val="182C29"/>
@@ -9450,6 +11985,7 @@
           <a:lstStyle xmlns:a="http://schemas.openxmlformats.org/drawingml/2006/main"/>
           <a:p xmlns:a="http://schemas.openxmlformats.org/drawingml/2006/main">
             <a:pPr>
+              <a:buNone/>
               <a:defRPr sz="1725" b="0">
                 <a:solidFill>
                   <a:srgbClr val="5E706B"/>
@@ -9536,6 +12072,7 @@
           <a:lstStyle xmlns:a="http://schemas.openxmlformats.org/drawingml/2006/main"/>
           <a:p xmlns:a="http://schemas.openxmlformats.org/drawingml/2006/main">
             <a:pPr>
+              <a:buNone/>
               <a:defRPr sz="3675" b="1">
                 <a:solidFill>
                   <a:srgbClr val="182C29"/>
@@ -9593,6 +12130,7 @@
           <a:lstStyle xmlns:a="http://schemas.openxmlformats.org/drawingml/2006/main"/>
           <a:p xmlns:a="http://schemas.openxmlformats.org/drawingml/2006/main">
             <a:pPr>
+              <a:buNone/>
               <a:defRPr sz="2100" b="0">
                 <a:solidFill>
                   <a:srgbClr val="5E706B"/>
@@ -9650,6 +12188,7 @@
           <a:lstStyle xmlns:a="http://schemas.openxmlformats.org/drawingml/2006/main"/>
           <a:p xmlns:a="http://schemas.openxmlformats.org/drawingml/2006/main">
             <a:pPr>
+              <a:buNone/>
               <a:defRPr sz="1350" b="0">
                 <a:solidFill>
                   <a:srgbClr val="5E706B"/>
@@ -9707,6 +12246,7 @@
           <a:lstStyle xmlns:a="http://schemas.openxmlformats.org/drawingml/2006/main"/>
           <a:p xmlns:a="http://schemas.openxmlformats.org/drawingml/2006/main">
             <a:pPr>
+              <a:buNone/>
               <a:defRPr sz="3150" b="1">
                 <a:solidFill>
                   <a:srgbClr val="156E58"/>
@@ -9764,6 +12304,7 @@
           <a:lstStyle xmlns:a="http://schemas.openxmlformats.org/drawingml/2006/main"/>
           <a:p xmlns:a="http://schemas.openxmlformats.org/drawingml/2006/main">
             <a:pPr>
+              <a:buNone/>
               <a:defRPr sz="2475" b="1">
                 <a:solidFill>
                   <a:srgbClr val="182C29"/>
@@ -9821,6 +12362,7 @@
           <a:lstStyle xmlns:a="http://schemas.openxmlformats.org/drawingml/2006/main"/>
           <a:p xmlns:a="http://schemas.openxmlformats.org/drawingml/2006/main">
             <a:pPr>
+              <a:buNone/>
               <a:defRPr sz="2325" b="0">
                 <a:solidFill>
                   <a:srgbClr val="182C29"/>
@@ -9844,6 +12386,7 @@
           </a:p>
           <a:p xmlns:a="http://schemas.openxmlformats.org/drawingml/2006/main">
             <a:pPr>
+              <a:buNone/>
               <a:defRPr sz="2325" b="0">
                 <a:solidFill>
                   <a:srgbClr val="182C29"/>
@@ -9867,6 +12410,7 @@
           </a:p>
           <a:p xmlns:a="http://schemas.openxmlformats.org/drawingml/2006/main">
             <a:pPr>
+              <a:buNone/>
               <a:defRPr sz="2325" b="0">
                 <a:solidFill>
                   <a:srgbClr val="182C29"/>
@@ -9924,6 +12468,7 @@
           <a:lstStyle xmlns:a="http://schemas.openxmlformats.org/drawingml/2006/main"/>
           <a:p xmlns:a="http://schemas.openxmlformats.org/drawingml/2006/main">
             <a:pPr>
+              <a:buNone/>
               <a:defRPr sz="3150" b="1">
                 <a:solidFill>
                   <a:srgbClr val="156E58"/>
@@ -9981,6 +12526,7 @@
           <a:lstStyle xmlns:a="http://schemas.openxmlformats.org/drawingml/2006/main"/>
           <a:p xmlns:a="http://schemas.openxmlformats.org/drawingml/2006/main">
             <a:pPr>
+              <a:buNone/>
               <a:defRPr sz="2475" b="1">
                 <a:solidFill>
                   <a:srgbClr val="182C29"/>
@@ -10038,6 +12584,7 @@
           <a:lstStyle xmlns:a="http://schemas.openxmlformats.org/drawingml/2006/main"/>
           <a:p xmlns:a="http://schemas.openxmlformats.org/drawingml/2006/main">
             <a:pPr>
+              <a:buNone/>
               <a:defRPr sz="2325" b="0">
                 <a:solidFill>
                   <a:srgbClr val="182C29"/>
@@ -10061,6 +12608,7 @@
           </a:p>
           <a:p xmlns:a="http://schemas.openxmlformats.org/drawingml/2006/main">
             <a:pPr>
+              <a:buNone/>
               <a:defRPr sz="2325" b="0">
                 <a:solidFill>
                   <a:srgbClr val="182C29"/>
@@ -10084,6 +12632,7 @@
           </a:p>
           <a:p xmlns:a="http://schemas.openxmlformats.org/drawingml/2006/main">
             <a:pPr>
+              <a:buNone/>
               <a:defRPr sz="2325" b="0">
                 <a:solidFill>
                   <a:srgbClr val="182C29"/>
@@ -10141,6 +12690,7 @@
           <a:lstStyle xmlns:a="http://schemas.openxmlformats.org/drawingml/2006/main"/>
           <a:p xmlns:a="http://schemas.openxmlformats.org/drawingml/2006/main">
             <a:pPr>
+              <a:buNone/>
               <a:defRPr sz="1950" b="0">
                 <a:solidFill>
                   <a:srgbClr val="5E706B"/>
@@ -10227,6 +12777,7 @@
           <a:lstStyle xmlns:a="http://schemas.openxmlformats.org/drawingml/2006/main"/>
           <a:p xmlns:a="http://schemas.openxmlformats.org/drawingml/2006/main">
             <a:pPr>
+              <a:buNone/>
               <a:defRPr sz="3675" b="1">
                 <a:solidFill>
                   <a:srgbClr val="182C29"/>
@@ -10284,6 +12835,7 @@
           <a:lstStyle xmlns:a="http://schemas.openxmlformats.org/drawingml/2006/main"/>
           <a:p xmlns:a="http://schemas.openxmlformats.org/drawingml/2006/main">
             <a:pPr>
+              <a:buNone/>
               <a:defRPr sz="2100" b="0">
                 <a:solidFill>
                   <a:srgbClr val="5E706B"/>
@@ -10341,6 +12893,7 @@
           <a:lstStyle xmlns:a="http://schemas.openxmlformats.org/drawingml/2006/main"/>
           <a:p xmlns:a="http://schemas.openxmlformats.org/drawingml/2006/main">
             <a:pPr>
+              <a:buNone/>
               <a:defRPr sz="1350" b="0">
                 <a:solidFill>
                   <a:srgbClr val="5E706B"/>
@@ -10400,6 +12953,7 @@
           <a:lstStyle xmlns:a="http://schemas.openxmlformats.org/drawingml/2006/main"/>
           <a:p xmlns:a="http://schemas.openxmlformats.org/drawingml/2006/main">
             <a:pPr algn="ctr">
+              <a:buNone/>
               <a:defRPr sz="2175" b="1">
                 <a:solidFill>
                   <a:srgbClr val="182C29"/>
@@ -10459,6 +13013,7 @@
           <a:lstStyle xmlns:a="http://schemas.openxmlformats.org/drawingml/2006/main"/>
           <a:p xmlns:a="http://schemas.openxmlformats.org/drawingml/2006/main">
             <a:pPr algn="ctr">
+              <a:buNone/>
               <a:defRPr sz="2175" b="1">
                 <a:solidFill>
                   <a:srgbClr val="182C29"/>
@@ -10484,7 +13039,7 @@
       </p:sp>
       <p:cxnSp>
         <p:nvCxnSpPr>
-          <p:cNvPr id="25" name=""/>
+          <p:cNvPr id="37" name=""/>
           <p:cNvCxnSpPr>
             <a:stCxn xmlns:a="http://schemas.openxmlformats.org/drawingml/2006/main" id="4" idx="3"/>
             <a:endCxn xmlns:a="http://schemas.openxmlformats.org/drawingml/2006/main" id="5" idx="1"/>
@@ -10543,6 +13098,7 @@
           <a:lstStyle xmlns:a="http://schemas.openxmlformats.org/drawingml/2006/main"/>
           <a:p xmlns:a="http://schemas.openxmlformats.org/drawingml/2006/main">
             <a:pPr algn="ctr">
+              <a:buNone/>
               <a:defRPr sz="2175" b="1">
                 <a:solidFill>
                   <a:srgbClr val="182C29"/>
@@ -10568,7 +13124,7 @@
       </p:sp>
       <p:cxnSp>
         <p:nvCxnSpPr>
-          <p:cNvPr id="27" name=""/>
+          <p:cNvPr id="39" name=""/>
           <p:cNvCxnSpPr>
             <a:stCxn xmlns:a="http://schemas.openxmlformats.org/drawingml/2006/main" id="5" idx="3"/>
             <a:endCxn xmlns:a="http://schemas.openxmlformats.org/drawingml/2006/main" id="7" idx="1"/>
@@ -10627,6 +13183,7 @@
           <a:lstStyle xmlns:a="http://schemas.openxmlformats.org/drawingml/2006/main"/>
           <a:p xmlns:a="http://schemas.openxmlformats.org/drawingml/2006/main">
             <a:pPr algn="ctr">
+              <a:buNone/>
               <a:defRPr sz="2175" b="1">
                 <a:solidFill>
                   <a:srgbClr val="182C29"/>
@@ -10652,7 +13209,7 @@
       </p:sp>
       <p:cxnSp>
         <p:nvCxnSpPr>
-          <p:cNvPr id="29" name=""/>
+          <p:cNvPr id="41" name=""/>
           <p:cNvCxnSpPr>
             <a:stCxn xmlns:a="http://schemas.openxmlformats.org/drawingml/2006/main" id="7" idx="3"/>
             <a:endCxn xmlns:a="http://schemas.openxmlformats.org/drawingml/2006/main" id="9" idx="1"/>
@@ -10711,6 +13268,7 @@
           <a:lstStyle xmlns:a="http://schemas.openxmlformats.org/drawingml/2006/main"/>
           <a:p xmlns:a="http://schemas.openxmlformats.org/drawingml/2006/main">
             <a:pPr algn="ctr">
+              <a:buNone/>
               <a:defRPr sz="2175" b="1">
                 <a:solidFill>
                   <a:srgbClr val="182C29"/>
@@ -10736,7 +13294,7 @@
       </p:sp>
       <p:cxnSp>
         <p:nvCxnSpPr>
-          <p:cNvPr id="31" name=""/>
+          <p:cNvPr id="43" name=""/>
           <p:cNvCxnSpPr>
             <a:stCxn xmlns:a="http://schemas.openxmlformats.org/drawingml/2006/main" id="9" idx="3"/>
             <a:endCxn xmlns:a="http://schemas.openxmlformats.org/drawingml/2006/main" id="11" idx="1"/>
@@ -10793,6 +13351,7 @@
           <a:lstStyle xmlns:a="http://schemas.openxmlformats.org/drawingml/2006/main"/>
           <a:p xmlns:a="http://schemas.openxmlformats.org/drawingml/2006/main">
             <a:pPr>
+              <a:buNone/>
               <a:defRPr sz="2475" b="1">
                 <a:solidFill>
                   <a:srgbClr val="156E58"/>
@@ -10850,6 +13409,7 @@
           <a:lstStyle xmlns:a="http://schemas.openxmlformats.org/drawingml/2006/main"/>
           <a:p xmlns:a="http://schemas.openxmlformats.org/drawingml/2006/main">
             <a:pPr>
+              <a:buNone/>
               <a:defRPr sz="2325" b="0">
                 <a:solidFill>
                   <a:srgbClr val="182C29"/>
@@ -10907,6 +13467,7 @@
           <a:lstStyle xmlns:a="http://schemas.openxmlformats.org/drawingml/2006/main"/>
           <a:p xmlns:a="http://schemas.openxmlformats.org/drawingml/2006/main">
             <a:pPr>
+              <a:buNone/>
               <a:defRPr sz="2475" b="1">
                 <a:solidFill>
                   <a:srgbClr val="156E58"/>
@@ -10964,6 +13525,7 @@
           <a:lstStyle xmlns:a="http://schemas.openxmlformats.org/drawingml/2006/main"/>
           <a:p xmlns:a="http://schemas.openxmlformats.org/drawingml/2006/main">
             <a:pPr>
+              <a:buNone/>
               <a:defRPr sz="2325" b="0">
                 <a:solidFill>
                   <a:srgbClr val="182C29"/>
@@ -11021,6 +13583,7 @@
           <a:lstStyle xmlns:a="http://schemas.openxmlformats.org/drawingml/2006/main"/>
           <a:p xmlns:a="http://schemas.openxmlformats.org/drawingml/2006/main">
             <a:pPr>
+              <a:buNone/>
               <a:defRPr sz="2475" b="1">
                 <a:solidFill>
                   <a:srgbClr val="156E58"/>
@@ -11078,6 +13641,7 @@
           <a:lstStyle xmlns:a="http://schemas.openxmlformats.org/drawingml/2006/main"/>
           <a:p xmlns:a="http://schemas.openxmlformats.org/drawingml/2006/main">
             <a:pPr>
+              <a:buNone/>
               <a:defRPr sz="2325" b="0">
                 <a:solidFill>
                   <a:srgbClr val="182C29"/>
@@ -11135,6 +13699,7 @@
           <a:lstStyle xmlns:a="http://schemas.openxmlformats.org/drawingml/2006/main"/>
           <a:p xmlns:a="http://schemas.openxmlformats.org/drawingml/2006/main">
             <a:pPr>
+              <a:buNone/>
               <a:defRPr sz="1725" b="0">
                 <a:solidFill>
                   <a:srgbClr val="5E706B"/>
@@ -11221,6 +13786,7 @@
           <a:lstStyle xmlns:a="http://schemas.openxmlformats.org/drawingml/2006/main"/>
           <a:p xmlns:a="http://schemas.openxmlformats.org/drawingml/2006/main">
             <a:pPr>
+              <a:buNone/>
               <a:defRPr sz="3675" b="1">
                 <a:solidFill>
                   <a:srgbClr val="182C29"/>
@@ -11278,6 +13844,7 @@
           <a:lstStyle xmlns:a="http://schemas.openxmlformats.org/drawingml/2006/main"/>
           <a:p xmlns:a="http://schemas.openxmlformats.org/drawingml/2006/main">
             <a:pPr>
+              <a:buNone/>
               <a:defRPr sz="2100" b="0">
                 <a:solidFill>
                   <a:srgbClr val="5E706B"/>
@@ -11335,6 +13902,7 @@
           <a:lstStyle xmlns:a="http://schemas.openxmlformats.org/drawingml/2006/main"/>
           <a:p xmlns:a="http://schemas.openxmlformats.org/drawingml/2006/main">
             <a:pPr>
+              <a:buNone/>
               <a:defRPr sz="1350" b="0">
                 <a:solidFill>
                   <a:srgbClr val="5E706B"/>
@@ -11396,6 +13964,7 @@
           <a:lstStyle xmlns:a="http://schemas.openxmlformats.org/drawingml/2006/main"/>
           <a:p xmlns:a="http://schemas.openxmlformats.org/drawingml/2006/main">
             <a:pPr>
+              <a:buNone/>
               <a:defRPr sz="2100">
                 <a:solidFill>
                   <a:srgbClr val="FFFFFF"/>
@@ -11419,6 +13988,7 @@
           </a:p>
           <a:p xmlns:a="http://schemas.openxmlformats.org/drawingml/2006/main">
             <a:pPr>
+              <a:buNone/>
               <a:defRPr sz="2100">
                 <a:solidFill>
                   <a:srgbClr val="FFFFFF"/>
@@ -11476,6 +14046,7 @@
           <a:lstStyle xmlns:a="http://schemas.openxmlformats.org/drawingml/2006/main"/>
           <a:p xmlns:a="http://schemas.openxmlformats.org/drawingml/2006/main">
             <a:pPr>
+              <a:buNone/>
               <a:defRPr sz="1800" b="1">
                 <a:solidFill>
                   <a:srgbClr val="156E58"/>
@@ -11537,6 +14108,7 @@
           <a:lstStyle xmlns:a="http://schemas.openxmlformats.org/drawingml/2006/main"/>
           <a:p xmlns:a="http://schemas.openxmlformats.org/drawingml/2006/main">
             <a:pPr>
+              <a:buNone/>
               <a:defRPr sz="2100">
                 <a:solidFill>
                   <a:srgbClr val="182C29"/>
@@ -11560,6 +14132,7 @@
           </a:p>
           <a:p xmlns:a="http://schemas.openxmlformats.org/drawingml/2006/main">
             <a:pPr>
+              <a:buNone/>
               <a:defRPr sz="2100">
                 <a:solidFill>
                   <a:srgbClr val="182C29"/>
@@ -11617,6 +14190,7 @@
           <a:lstStyle xmlns:a="http://schemas.openxmlformats.org/drawingml/2006/main"/>
           <a:p xmlns:a="http://schemas.openxmlformats.org/drawingml/2006/main">
             <a:pPr>
+              <a:buNone/>
               <a:defRPr sz="1800" b="1">
                 <a:solidFill>
                   <a:srgbClr val="156E58"/>
@@ -11678,6 +14252,7 @@
           <a:lstStyle xmlns:a="http://schemas.openxmlformats.org/drawingml/2006/main"/>
           <a:p xmlns:a="http://schemas.openxmlformats.org/drawingml/2006/main">
             <a:pPr>
+              <a:buNone/>
               <a:defRPr sz="2100">
                 <a:solidFill>
                   <a:srgbClr val="FFFFFF"/>
@@ -11701,6 +14276,7 @@
           </a:p>
           <a:p xmlns:a="http://schemas.openxmlformats.org/drawingml/2006/main">
             <a:pPr>
+              <a:buNone/>
               <a:defRPr sz="2100">
                 <a:solidFill>
                   <a:srgbClr val="FFFFFF"/>
@@ -11758,6 +14334,7 @@
           <a:lstStyle xmlns:a="http://schemas.openxmlformats.org/drawingml/2006/main"/>
           <a:p xmlns:a="http://schemas.openxmlformats.org/drawingml/2006/main">
             <a:pPr>
+              <a:buNone/>
               <a:defRPr sz="1800" b="1">
                 <a:solidFill>
                   <a:srgbClr val="156E58"/>
@@ -11819,6 +14396,7 @@
           <a:lstStyle xmlns:a="http://schemas.openxmlformats.org/drawingml/2006/main"/>
           <a:p xmlns:a="http://schemas.openxmlformats.org/drawingml/2006/main">
             <a:pPr>
+              <a:buNone/>
               <a:defRPr sz="2100">
                 <a:solidFill>
                   <a:srgbClr val="182C29"/>
@@ -11842,6 +14420,7 @@
           </a:p>
           <a:p xmlns:a="http://schemas.openxmlformats.org/drawingml/2006/main">
             <a:pPr>
+              <a:buNone/>
               <a:defRPr sz="2100">
                 <a:solidFill>
                   <a:srgbClr val="182C29"/>
@@ -11899,6 +14478,7 @@
           <a:lstStyle xmlns:a="http://schemas.openxmlformats.org/drawingml/2006/main"/>
           <a:p xmlns:a="http://schemas.openxmlformats.org/drawingml/2006/main">
             <a:pPr>
+              <a:buNone/>
               <a:defRPr sz="1800" b="1">
                 <a:solidFill>
                   <a:srgbClr val="156E58"/>
@@ -11956,6 +14536,7 @@
           <a:lstStyle xmlns:a="http://schemas.openxmlformats.org/drawingml/2006/main"/>
           <a:p xmlns:a="http://schemas.openxmlformats.org/drawingml/2006/main">
             <a:pPr>
+              <a:buNone/>
               <a:defRPr sz="2400" b="1">
                 <a:solidFill>
                   <a:srgbClr val="156E58"/>
@@ -11981,14 +14562,14 @@
       </p:sp>
       <p:pic>
         <p:nvPicPr>
-          <p:cNvPr id="28" name=""/>
+          <p:cNvPr id="30" name=""/>
           <p:cNvPicPr>
             <a:picLocks xmlns:a="http://schemas.openxmlformats.org/drawingml/2006/main" noChangeAspect="1"/>
           </p:cNvPicPr>
           <p:nvPr/>
         </p:nvPicPr>
         <p:blipFill>
-          <a:blip xmlns:r="http://schemas.openxmlformats.org/officeDocument/2006/relationships" xmlns:a="http://schemas.openxmlformats.org/drawingml/2006/main" r:embed="Rf18c41b441524723"/>
+          <a:blip xmlns:r="http://schemas.openxmlformats.org/officeDocument/2006/relationships" xmlns:a="http://schemas.openxmlformats.org/drawingml/2006/main" r:embed="Rfb0b81b56d264eff"/>
           <a:stretch xmlns:a="http://schemas.openxmlformats.org/drawingml/2006/main"/>
         </p:blipFill>
         <p:spPr>
@@ -12035,6 +14616,7 @@
           <a:lstStyle xmlns:a="http://schemas.openxmlformats.org/drawingml/2006/main"/>
           <a:p xmlns:a="http://schemas.openxmlformats.org/drawingml/2006/main">
             <a:pPr>
+              <a:buNone/>
               <a:defRPr sz="1725" b="0">
                 <a:solidFill>
                   <a:srgbClr val="5E706B"/>
@@ -12092,6 +14674,7 @@
           <a:lstStyle xmlns:a="http://schemas.openxmlformats.org/drawingml/2006/main"/>
           <a:p xmlns:a="http://schemas.openxmlformats.org/drawingml/2006/main">
             <a:pPr>
+              <a:buNone/>
               <a:defRPr sz="1500" b="0">
                 <a:solidFill>
                   <a:srgbClr val="5E706B"/>
@@ -12178,6 +14761,7 @@
           <a:lstStyle xmlns:a="http://schemas.openxmlformats.org/drawingml/2006/main"/>
           <a:p xmlns:a="http://schemas.openxmlformats.org/drawingml/2006/main">
             <a:pPr>
+              <a:buNone/>
               <a:defRPr sz="3675" b="1">
                 <a:solidFill>
                   <a:srgbClr val="182C29"/>
@@ -12235,6 +14819,7 @@
           <a:lstStyle xmlns:a="http://schemas.openxmlformats.org/drawingml/2006/main"/>
           <a:p xmlns:a="http://schemas.openxmlformats.org/drawingml/2006/main">
             <a:pPr>
+              <a:buNone/>
               <a:defRPr sz="2100" b="0">
                 <a:solidFill>
                   <a:srgbClr val="5E706B"/>
@@ -12292,6 +14877,7 @@
           <a:lstStyle xmlns:a="http://schemas.openxmlformats.org/drawingml/2006/main"/>
           <a:p xmlns:a="http://schemas.openxmlformats.org/drawingml/2006/main">
             <a:pPr>
+              <a:buNone/>
               <a:defRPr sz="1350" b="0">
                 <a:solidFill>
                   <a:srgbClr val="5E706B"/>
@@ -12351,6 +14937,7 @@
           <a:lstStyle xmlns:a="http://schemas.openxmlformats.org/drawingml/2006/main"/>
           <a:p xmlns:a="http://schemas.openxmlformats.org/drawingml/2006/main">
             <a:pPr algn="ctr">
+              <a:buNone/>
               <a:defRPr sz="2175" b="1">
                 <a:solidFill>
                   <a:srgbClr val="182C29"/>
@@ -12410,6 +14997,7 @@
           <a:lstStyle xmlns:a="http://schemas.openxmlformats.org/drawingml/2006/main"/>
           <a:p xmlns:a="http://schemas.openxmlformats.org/drawingml/2006/main">
             <a:pPr algn="ctr">
+              <a:buNone/>
               <a:defRPr sz="2175" b="1">
                 <a:solidFill>
                   <a:srgbClr val="182C29"/>
@@ -12435,7 +15023,7 @@
       </p:sp>
       <p:cxnSp>
         <p:nvCxnSpPr>
-          <p:cNvPr id="18" name=""/>
+          <p:cNvPr id="26" name=""/>
           <p:cNvCxnSpPr>
             <a:stCxn xmlns:a="http://schemas.openxmlformats.org/drawingml/2006/main" id="4" idx="3"/>
             <a:endCxn xmlns:a="http://schemas.openxmlformats.org/drawingml/2006/main" id="5" idx="1"/>
@@ -12494,6 +15082,7 @@
           <a:lstStyle xmlns:a="http://schemas.openxmlformats.org/drawingml/2006/main"/>
           <a:p xmlns:a="http://schemas.openxmlformats.org/drawingml/2006/main">
             <a:pPr algn="ctr">
+              <a:buNone/>
               <a:defRPr sz="2175" b="1">
                 <a:solidFill>
                   <a:srgbClr val="182C29"/>
@@ -12519,7 +15108,7 @@
       </p:sp>
       <p:cxnSp>
         <p:nvCxnSpPr>
-          <p:cNvPr id="20" name=""/>
+          <p:cNvPr id="28" name=""/>
           <p:cNvCxnSpPr>
             <a:stCxn xmlns:a="http://schemas.openxmlformats.org/drawingml/2006/main" id="5" idx="3"/>
             <a:endCxn xmlns:a="http://schemas.openxmlformats.org/drawingml/2006/main" id="7" idx="1"/>
@@ -12576,6 +15165,7 @@
           <a:lstStyle xmlns:a="http://schemas.openxmlformats.org/drawingml/2006/main"/>
           <a:p xmlns:a="http://schemas.openxmlformats.org/drawingml/2006/main">
             <a:pPr>
+              <a:buNone/>
               <a:defRPr sz="2250" b="0">
                 <a:solidFill>
                   <a:srgbClr val="182C29"/>
@@ -12599,6 +15189,7 @@
           </a:p>
           <a:p xmlns:a="http://schemas.openxmlformats.org/drawingml/2006/main">
             <a:pPr>
+              <a:buNone/>
               <a:defRPr sz="2250" b="0">
                 <a:solidFill>
                   <a:srgbClr val="182C29"/>
@@ -12656,6 +15247,7 @@
           <a:lstStyle xmlns:a="http://schemas.openxmlformats.org/drawingml/2006/main"/>
           <a:p xmlns:a="http://schemas.openxmlformats.org/drawingml/2006/main">
             <a:pPr>
+              <a:buNone/>
               <a:defRPr sz="2175" b="0">
                 <a:solidFill>
                   <a:srgbClr val="182C29"/>
@@ -12679,6 +15271,7 @@
           </a:p>
           <a:p xmlns:a="http://schemas.openxmlformats.org/drawingml/2006/main">
             <a:pPr>
+              <a:buNone/>
               <a:defRPr sz="2175" b="0">
                 <a:solidFill>
                   <a:srgbClr val="182C29"/>
@@ -12736,6 +15329,7 @@
           <a:lstStyle xmlns:a="http://schemas.openxmlformats.org/drawingml/2006/main"/>
           <a:p xmlns:a="http://schemas.openxmlformats.org/drawingml/2006/main">
             <a:pPr>
+              <a:buNone/>
               <a:defRPr sz="2100" b="0">
                 <a:solidFill>
                   <a:srgbClr val="182C29"/>
@@ -12759,6 +15353,7 @@
           </a:p>
           <a:p xmlns:a="http://schemas.openxmlformats.org/drawingml/2006/main">
             <a:pPr>
+              <a:buNone/>
               <a:defRPr sz="2100" b="0">
                 <a:solidFill>
                   <a:srgbClr val="182C29"/>
@@ -12816,6 +15411,7 @@
           <a:lstStyle xmlns:a="http://schemas.openxmlformats.org/drawingml/2006/main"/>
           <a:p xmlns:a="http://schemas.openxmlformats.org/drawingml/2006/main">
             <a:pPr>
+              <a:buNone/>
               <a:defRPr sz="2250" b="0">
                 <a:solidFill>
                   <a:srgbClr val="182C29"/>
@@ -12839,6 +15435,7 @@
           </a:p>
           <a:p xmlns:a="http://schemas.openxmlformats.org/drawingml/2006/main">
             <a:pPr>
+              <a:buNone/>
               <a:defRPr sz="2250" b="0">
                 <a:solidFill>
                   <a:srgbClr val="182C29"/>

</xml_diff>

<commit_message>
docs: explain HSCodeComp and link the source benchmark
</commit_message>
<xml_diff>
--- a/portfolio/crossborder-portfolio.pptx
+++ b/portfolio/crossborder-portfolio.pptx
@@ -2,30 +2,30 @@
 <file path=ppt/presentation.xml><?xml version="1.0" encoding="utf-8"?>
 <p:presentation xmlns:p="http://schemas.openxmlformats.org/presentationml/2006/main">
   <p:sldMasterIdLst>
-    <p:sldMasterId xmlns:r="http://schemas.openxmlformats.org/officeDocument/2006/relationships" id="2147483648" r:id="R3157283dd8794a62"/>
+    <p:sldMasterId xmlns:r="http://schemas.openxmlformats.org/officeDocument/2006/relationships" id="2147483648" r:id="Rfc73e56126214a4d"/>
   </p:sldMasterIdLst>
   <p:notesMasterIdLst>
-    <p:notesMasterId xmlns:r="http://schemas.openxmlformats.org/officeDocument/2006/relationships" r:id="R77263c22734d4965"/>
+    <p:notesMasterId xmlns:r="http://schemas.openxmlformats.org/officeDocument/2006/relationships" r:id="R6620ae9930944070"/>
   </p:notesMasterIdLst>
   <p:sldIdLst>
-    <p:sldId xmlns:r="http://schemas.openxmlformats.org/officeDocument/2006/relationships" id="256" r:id="R862a2ca4f3004e36"/>
-    <p:sldId xmlns:r="http://schemas.openxmlformats.org/officeDocument/2006/relationships" id="257" r:id="R54971af92ee74dff"/>
-    <p:sldId xmlns:r="http://schemas.openxmlformats.org/officeDocument/2006/relationships" id="258" r:id="Ref203dc51db1464d"/>
-    <p:sldId xmlns:r="http://schemas.openxmlformats.org/officeDocument/2006/relationships" id="259" r:id="Rc1e2cf908d0144af"/>
-    <p:sldId xmlns:r="http://schemas.openxmlformats.org/officeDocument/2006/relationships" id="260" r:id="R59d81729e3b84d1b"/>
-    <p:sldId xmlns:r="http://schemas.openxmlformats.org/officeDocument/2006/relationships" id="261" r:id="Reb139b5876264df3"/>
-    <p:sldId xmlns:r="http://schemas.openxmlformats.org/officeDocument/2006/relationships" id="262" r:id="Raf99b9311bba41aa"/>
-    <p:sldId xmlns:r="http://schemas.openxmlformats.org/officeDocument/2006/relationships" id="263" r:id="R42f678bd30394e8f"/>
-    <p:sldId xmlns:r="http://schemas.openxmlformats.org/officeDocument/2006/relationships" id="264" r:id="R28c9c9e9ef8e4171"/>
-    <p:sldId xmlns:r="http://schemas.openxmlformats.org/officeDocument/2006/relationships" id="265" r:id="R73329b35ee9141f3"/>
-    <p:sldId xmlns:r="http://schemas.openxmlformats.org/officeDocument/2006/relationships" id="266" r:id="R74b38976f44548dc"/>
-    <p:sldId xmlns:r="http://schemas.openxmlformats.org/officeDocument/2006/relationships" id="267" r:id="Rb4398cbde8fe4d59"/>
-    <p:sldId xmlns:r="http://schemas.openxmlformats.org/officeDocument/2006/relationships" id="268" r:id="Ra3108d3f84084d8d"/>
-    <p:sldId xmlns:r="http://schemas.openxmlformats.org/officeDocument/2006/relationships" id="269" r:id="Ra86c9de4263f4b6e"/>
-    <p:sldId xmlns:r="http://schemas.openxmlformats.org/officeDocument/2006/relationships" id="270" r:id="R7dd9ca1ed5b043f4"/>
-    <p:sldId xmlns:r="http://schemas.openxmlformats.org/officeDocument/2006/relationships" id="271" r:id="R2fedfa829ac94987"/>
-    <p:sldId xmlns:r="http://schemas.openxmlformats.org/officeDocument/2006/relationships" id="272" r:id="Rce8bd3a6ae90499f"/>
-    <p:sldId xmlns:r="http://schemas.openxmlformats.org/officeDocument/2006/relationships" id="273" r:id="Rb603702e941f42c8"/>
+    <p:sldId xmlns:r="http://schemas.openxmlformats.org/officeDocument/2006/relationships" id="256" r:id="R4620abbc58554d17"/>
+    <p:sldId xmlns:r="http://schemas.openxmlformats.org/officeDocument/2006/relationships" id="257" r:id="R2ab673175a354639"/>
+    <p:sldId xmlns:r="http://schemas.openxmlformats.org/officeDocument/2006/relationships" id="258" r:id="R8ca2ada2006344a6"/>
+    <p:sldId xmlns:r="http://schemas.openxmlformats.org/officeDocument/2006/relationships" id="259" r:id="R71d6a37f70814a9a"/>
+    <p:sldId xmlns:r="http://schemas.openxmlformats.org/officeDocument/2006/relationships" id="260" r:id="R797e253fc39e47b8"/>
+    <p:sldId xmlns:r="http://schemas.openxmlformats.org/officeDocument/2006/relationships" id="261" r:id="Raafd823886724e21"/>
+    <p:sldId xmlns:r="http://schemas.openxmlformats.org/officeDocument/2006/relationships" id="262" r:id="Reda0ddb6f15345fa"/>
+    <p:sldId xmlns:r="http://schemas.openxmlformats.org/officeDocument/2006/relationships" id="263" r:id="Rd82faf79885e4808"/>
+    <p:sldId xmlns:r="http://schemas.openxmlformats.org/officeDocument/2006/relationships" id="264" r:id="R14b781f27b6a4565"/>
+    <p:sldId xmlns:r="http://schemas.openxmlformats.org/officeDocument/2006/relationships" id="265" r:id="R26ff4dc103e84640"/>
+    <p:sldId xmlns:r="http://schemas.openxmlformats.org/officeDocument/2006/relationships" id="266" r:id="R4772e337f96f45e0"/>
+    <p:sldId xmlns:r="http://schemas.openxmlformats.org/officeDocument/2006/relationships" id="267" r:id="Ra2fb7ba48b654043"/>
+    <p:sldId xmlns:r="http://schemas.openxmlformats.org/officeDocument/2006/relationships" id="268" r:id="Rd523a707c0284741"/>
+    <p:sldId xmlns:r="http://schemas.openxmlformats.org/officeDocument/2006/relationships" id="269" r:id="R5c6686d4688c4b21"/>
+    <p:sldId xmlns:r="http://schemas.openxmlformats.org/officeDocument/2006/relationships" id="270" r:id="R904f62015ba6407d"/>
+    <p:sldId xmlns:r="http://schemas.openxmlformats.org/officeDocument/2006/relationships" id="271" r:id="R81acc5ce41114022"/>
+    <p:sldId xmlns:r="http://schemas.openxmlformats.org/officeDocument/2006/relationships" id="272" r:id="Rd6d16cc6f8014e6f"/>
+    <p:sldId xmlns:r="http://schemas.openxmlformats.org/officeDocument/2006/relationships" id="273" r:id="Rd18ecd584ff941d3"/>
   </p:sldIdLst>
   <p:sldSz cx="15240000" cy="8572500"/>
   <p:notesSz cx="6858000" cy="9144000"/>
@@ -949,7 +949,7 @@
           <a:lstStyle xmlns:a="http://schemas.openxmlformats.org/drawingml/2006/main"/>
           <a:p xmlns:a="http://schemas.openxmlformats.org/drawingml/2006/main">
             <a:r>
-              <a:t>https://github.com/y00nZZang/product-catalog/blob/main/docs/jev-experiment-2026-10-06.md ; https://github.com/y00nZZang/product-catalog/blob/main/notebooks/two-datasets-results-2026-10-06.json ; https://docs.typesafe.ai/primitives/choice ; https://huggingface.co/datasets/ATH-MaaS/HSCodeComp . 실험은 운영 서비스 변경이나 전체 URL 분석시간 비교가 아니다.</a:t>
+              <a:t>HSCodeComp: 실제 전자상거래 상품632개,32개 대분류에 전문가가 미국 기준10자리 코드를 주석한 공개 벤치마크. 본 실험은94개 표본의 앞6자리HS6와 비교. https://huggingface.co/datasets/ATH-MaaS/HSCodeComp ; https://arxiv.org/abs/2510.19631 ; https://github.com/y00nZZang/product-catalog/blob/main/docs/jev-experiment-2026-10-06.md . 공식 한국 HSK 결정문이나 사람의 현지 재검토로 간주하지 않는다.</a:t>
             </a:r>
           </a:p>
         </p:txBody>
@@ -1717,7 +1717,7 @@
   </p:cSld>
   <p:clrMap bg1="lt1" tx1="dk1" bg2="lt2" tx2="dk2" accent1="accent1" accent2="accent2" accent3="accent3" accent4="accent4" accent5="accent5" accent6="accent6" hlink="hlink" folHlink="folHlink"/>
   <p:sldLayoutIdLst>
-    <p:sldLayoutId xmlns:r="http://schemas.openxmlformats.org/officeDocument/2006/relationships" id="2147483649" r:id="R9b4a47241f8b4d6b"/>
+    <p:sldLayoutId xmlns:r="http://schemas.openxmlformats.org/officeDocument/2006/relationships" id="2147483649" r:id="R55975cbe5f7e467a"/>
   </p:sldLayoutIdLst>
   <p:txStyles>
     <p:titleStyle>
@@ -3134,7 +3134,7 @@
           <p:nvPr/>
         </p:nvPicPr>
         <p:blipFill>
-          <a:blip xmlns:r="http://schemas.openxmlformats.org/officeDocument/2006/relationships" xmlns:a="http://schemas.openxmlformats.org/drawingml/2006/main" r:embed="Ra655bc335cb84b21"/>
+          <a:blip xmlns:r="http://schemas.openxmlformats.org/officeDocument/2006/relationships" xmlns:a="http://schemas.openxmlformats.org/drawingml/2006/main" r:embed="R9cf8175e2ec14e4d"/>
           <a:stretch xmlns:a="http://schemas.openxmlformats.org/drawingml/2006/main"/>
         </p:blipFill>
         <p:spPr>
@@ -3776,7 +3776,7 @@
       </p:sp>
       <p:cxnSp>
         <p:nvCxnSpPr>
-          <p:cNvPr id="27" name=""/>
+          <p:cNvPr id="35" name=""/>
           <p:cNvCxnSpPr>
             <a:stCxn xmlns:a="http://schemas.openxmlformats.org/drawingml/2006/main" id="4" idx="3"/>
             <a:endCxn xmlns:a="http://schemas.openxmlformats.org/drawingml/2006/main" id="5" idx="1"/>
@@ -3861,7 +3861,7 @@
       </p:sp>
       <p:cxnSp>
         <p:nvCxnSpPr>
-          <p:cNvPr id="29" name=""/>
+          <p:cNvPr id="37" name=""/>
           <p:cNvCxnSpPr>
             <a:stCxn xmlns:a="http://schemas.openxmlformats.org/drawingml/2006/main" id="5" idx="3"/>
             <a:endCxn xmlns:a="http://schemas.openxmlformats.org/drawingml/2006/main" id="7" idx="1"/>
@@ -6671,7 +6671,7 @@
       </p:sp>
       <p:cxnSp>
         <p:nvCxnSpPr>
-          <p:cNvPr id="27" name=""/>
+          <p:cNvPr id="36" name=""/>
           <p:cNvCxnSpPr>
             <a:stCxn xmlns:a="http://schemas.openxmlformats.org/drawingml/2006/main" id="5" idx="3"/>
             <a:endCxn xmlns:a="http://schemas.openxmlformats.org/drawingml/2006/main" id="6" idx="1"/>
@@ -6756,7 +6756,7 @@
       </p:sp>
       <p:cxnSp>
         <p:nvCxnSpPr>
-          <p:cNvPr id="29" name=""/>
+          <p:cNvPr id="38" name=""/>
           <p:cNvCxnSpPr>
             <a:stCxn xmlns:a="http://schemas.openxmlformats.org/drawingml/2006/main" id="6" idx="3"/>
             <a:endCxn xmlns:a="http://schemas.openxmlformats.org/drawingml/2006/main" id="8" idx="1"/>
@@ -7006,6 +7006,7 @@
           <a:lstStyle xmlns:a="http://schemas.openxmlformats.org/drawingml/2006/main"/>
           <a:p xmlns:a="http://schemas.openxmlformats.org/drawingml/2006/main">
             <a:pPr>
+              <a:buNone/>
               <a:defRPr sz="3675" b="1">
                 <a:solidFill>
                   <a:srgbClr val="182C29"/>
@@ -7063,6 +7064,7 @@
           <a:lstStyle xmlns:a="http://schemas.openxmlformats.org/drawingml/2006/main"/>
           <a:p xmlns:a="http://schemas.openxmlformats.org/drawingml/2006/main">
             <a:pPr>
+              <a:buNone/>
               <a:defRPr sz="2100" b="0">
                 <a:solidFill>
                   <a:srgbClr val="5E706B"/>
@@ -7120,6 +7122,7 @@
           <a:lstStyle xmlns:a="http://schemas.openxmlformats.org/drawingml/2006/main"/>
           <a:p xmlns:a="http://schemas.openxmlformats.org/drawingml/2006/main">
             <a:pPr>
+              <a:buNone/>
               <a:defRPr sz="1350" b="0">
                 <a:solidFill>
                   <a:srgbClr val="5E706B"/>
@@ -7177,55 +7180,57 @@
           <a:lstStyle xmlns:a="http://schemas.openxmlformats.org/drawingml/2006/main"/>
           <a:p xmlns:a="http://schemas.openxmlformats.org/drawingml/2006/main">
             <a:pPr>
-              <a:defRPr sz="2475" b="0">
-                <a:solidFill>
-                  <a:srgbClr val="182C29"/>
-                </a:solidFill>
-                <a:latin typeface="Apple SD Gothic Neo"/>
-                <a:ea typeface="Apple SD Gothic Neo"/>
-                <a:cs typeface="Apple SD Gothic Neo"/>
-              </a:defRPr>
-            </a:pPr>
-            <a:r>
-              <a:rPr sz="2475" b="0">
-                <a:solidFill>
-                  <a:srgbClr val="182C29"/>
-                </a:solidFill>
-                <a:latin typeface="Apple SD Gothic Neo"/>
-                <a:ea typeface="Apple SD Gothic Neo"/>
-                <a:cs typeface="Apple SD Gothic Neo"/>
-              </a:rPr>
-              <a:t>문장을 생성하는 LLM과, 정해진 후보·확률을 반환하는 Jev를 비교했습니다.</a:t>
-            </a:r>
-          </a:p>
-          <a:p xmlns:a="http://schemas.openxmlformats.org/drawingml/2006/main">
-            <a:pPr>
-              <a:defRPr sz="2475" b="0">
-                <a:solidFill>
-                  <a:srgbClr val="182C29"/>
-                </a:solidFill>
-                <a:latin typeface="Apple SD Gothic Neo"/>
-                <a:ea typeface="Apple SD Gothic Neo"/>
-                <a:cs typeface="Apple SD Gothic Neo"/>
-              </a:defRPr>
-            </a:pPr>
-            <a:r>
-              <a:rPr sz="2475" b="0">
-                <a:solidFill>
-                  <a:srgbClr val="182C29"/>
-                </a:solidFill>
-                <a:latin typeface="Apple SD Gothic Neo"/>
-                <a:ea typeface="Apple SD Gothic Neo"/>
-                <a:cs typeface="Apple SD Gothic Neo"/>
-              </a:rPr>
-              <a:t>상품 입력과 공식 HS 목록을 동일하게 제공해 2→4→6자리 경로를 선택했습니다.</a:t>
+              <a:buNone/>
+              <a:defRPr sz="2250" b="0">
+                <a:solidFill>
+                  <a:srgbClr val="182C29"/>
+                </a:solidFill>
+                <a:latin typeface="Apple SD Gothic Neo"/>
+                <a:ea typeface="Apple SD Gothic Neo"/>
+                <a:cs typeface="Apple SD Gothic Neo"/>
+              </a:defRPr>
+            </a:pPr>
+            <a:r>
+              <a:rPr sz="2250" b="0">
+                <a:solidFill>
+                  <a:srgbClr val="182C29"/>
+                </a:solidFill>
+                <a:latin typeface="Apple SD Gothic Neo"/>
+                <a:ea typeface="Apple SD Gothic Neo"/>
+                <a:cs typeface="Apple SD Gothic Neo"/>
+              </a:rPr>
+              <a:t>HSCodeComp는 실제 전자상거래 상품632개에 전문가가 HS 코드를 붙인 공개 평가셋입니다.</a:t>
+            </a:r>
+          </a:p>
+          <a:p xmlns:a="http://schemas.openxmlformats.org/drawingml/2006/main">
+            <a:pPr>
+              <a:buNone/>
+              <a:defRPr sz="2250" b="0">
+                <a:solidFill>
+                  <a:srgbClr val="182C29"/>
+                </a:solidFill>
+                <a:latin typeface="Apple SD Gothic Neo"/>
+                <a:ea typeface="Apple SD Gothic Neo"/>
+                <a:cs typeface="Apple SD Gothic Neo"/>
+              </a:defRPr>
+            </a:pPr>
+            <a:r>
+              <a:rPr sz="2250" b="0">
+                <a:solidFill>
+                  <a:srgbClr val="182C29"/>
+                </a:solidFill>
+                <a:latin typeface="Apple SD Gothic Neo"/>
+                <a:ea typeface="Apple SD Gothic Neo"/>
+                <a:cs typeface="Apple SD Gothic Neo"/>
+              </a:rPr>
+              <a:t>상품명·속성·카테고리를 제공하며, 이번에는94개 표본의 HS6 정답과 비교했습니다.</a:t>
             </a:r>
           </a:p>
         </p:txBody>
       </p:sp>
       <p:graphicFrame>
         <p:nvGraphicFramePr>
-          <p:cNvPr id="12" name=""/>
+          <p:cNvPr id="14" name=""/>
           <p:cNvGraphicFramePr/>
           <p:nvPr/>
         </p:nvGraphicFramePr>
@@ -7484,8 +7489,8 @@
         </p:nvSpPr>
         <p:spPr>
           <a:xfrm xmlns:a="http://schemas.openxmlformats.org/drawingml/2006/main">
-            <a:off x="819150" y="6810375"/>
-            <a:ext cx="13525500" cy="571500"/>
+            <a:off x="819150" y="6734175"/>
+            <a:ext cx="13525500" cy="685800"/>
           </a:xfrm>
           <a:prstGeom xmlns:a="http://schemas.openxmlformats.org/drawingml/2006/main" prst="rect">
             <a:avLst/>
@@ -7502,25 +7507,50 @@
           <a:lstStyle xmlns:a="http://schemas.openxmlformats.org/drawingml/2006/main"/>
           <a:p xmlns:a="http://schemas.openxmlformats.org/drawingml/2006/main">
             <a:pPr>
-              <a:defRPr sz="2025" b="0">
-                <a:solidFill>
-                  <a:srgbClr val="182C29"/>
-                </a:solidFill>
-                <a:latin typeface="Apple SD Gothic Neo"/>
-                <a:ea typeface="Apple SD Gothic Neo"/>
-                <a:cs typeface="Apple SD Gothic Neo"/>
-              </a:defRPr>
-            </a:pPr>
-            <a:r>
-              <a:rPr sz="2025" b="0">
-                <a:solidFill>
-                  <a:srgbClr val="182C29"/>
-                </a:solidFill>
-                <a:latin typeface="Apple SD Gothic Neo"/>
-                <a:ea typeface="Apple SD Gothic Neo"/>
-                <a:cs typeface="Apple SD Gothic Neo"/>
-              </a:rPr>
-              <a:t>비교: Jev 1.13 ↔ GPT-6 Luna low. 심사자는 기존 예측과 공급사 이름을 보지 않았습니다.</a:t>
+              <a:buNone/>
+              <a:defRPr sz="1875" b="0">
+                <a:solidFill>
+                  <a:srgbClr val="5E706B"/>
+                </a:solidFill>
+                <a:latin typeface="Apple SD Gothic Neo"/>
+                <a:ea typeface="Apple SD Gothic Neo"/>
+                <a:cs typeface="Apple SD Gothic Neo"/>
+              </a:defRPr>
+            </a:pPr>
+            <a:r>
+              <a:rPr sz="1875" b="0">
+                <a:solidFill>
+                  <a:srgbClr val="5E706B"/>
+                </a:solidFill>
+                <a:latin typeface="Apple SD Gothic Neo"/>
+                <a:ea typeface="Apple SD Gothic Neo"/>
+                <a:cs typeface="Apple SD Gothic Neo"/>
+              </a:rPr>
+              <a:t>비교: Jev1.13 ↔ GPT-6 Luna low. 심사자는 기존 예측·공급사 이름을 보지 않았습니다.</a:t>
+            </a:r>
+          </a:p>
+          <a:p xmlns:a="http://schemas.openxmlformats.org/drawingml/2006/main">
+            <a:pPr>
+              <a:buNone/>
+              <a:defRPr sz="1875" b="0">
+                <a:solidFill>
+                  <a:srgbClr val="5E706B"/>
+                </a:solidFill>
+                <a:latin typeface="Apple SD Gothic Neo"/>
+                <a:ea typeface="Apple SD Gothic Neo"/>
+                <a:cs typeface="Apple SD Gothic Neo"/>
+              </a:defRPr>
+            </a:pPr>
+            <a:r>
+              <a:rPr sz="1875" b="0">
+                <a:solidFill>
+                  <a:srgbClr val="5E706B"/>
+                </a:solidFill>
+                <a:latin typeface="Apple SD Gothic Neo"/>
+                <a:ea typeface="Apple SD Gothic Neo"/>
+                <a:cs typeface="Apple SD Gothic Neo"/>
+              </a:rPr>
+              <a:t>텍스트만 사용한 단일 경로 비교이며 웹 검색·이미지 분석을 제외했습니다.</a:t>
             </a:r>
           </a:p>
         </p:txBody>
@@ -7559,9 +7589,10 @@
           <a:lstStyle xmlns:a="http://schemas.openxmlformats.org/drawingml/2006/main"/>
           <a:p xmlns:a="http://schemas.openxmlformats.org/drawingml/2006/main">
             <a:pPr>
+              <a:buNone/>
               <a:defRPr sz="1725" b="0">
                 <a:solidFill>
-                  <a:srgbClr val="5E706B"/>
+                  <a:srgbClr val="156E58"/>
                 </a:solidFill>
                 <a:latin typeface="Apple SD Gothic Neo"/>
                 <a:ea typeface="Apple SD Gothic Neo"/>
@@ -7571,13 +7602,25 @@
             <a:r>
               <a:rPr sz="1725" b="0">
                 <a:solidFill>
-                  <a:srgbClr val="5E706B"/>
-                </a:solidFill>
-                <a:latin typeface="Apple SD Gothic Neo"/>
-                <a:ea typeface="Apple SD Gothic Neo"/>
-                <a:cs typeface="Apple SD Gothic Neo"/>
-              </a:rPr>
-              <a:t>텍스트만 사용한 단일 경로 실험입니다. 웹 검색·이미지 분석·정답으로 후보 축소는 하지 않았습니다.</a:t>
+                  <a:srgbClr val="156E58"/>
+                </a:solidFill>
+                <a:latin typeface="Apple SD Gothic Neo"/>
+                <a:ea typeface="Apple SD Gothic Neo"/>
+                <a:cs typeface="Apple SD Gothic Neo"/>
+              </a:rPr>
+              <a:t>데이터셋 원본: </a:t>
+            </a:r>
+            <a:r>
+              <a:rPr sz="1725" b="0">
+                <a:solidFill>
+                  <a:srgbClr val="156E58"/>
+                </a:solidFill>
+                <a:latin typeface="Apple SD Gothic Neo"/>
+                <a:ea typeface="Apple SD Gothic Neo"/>
+                <a:cs typeface="Apple SD Gothic Neo"/>
+                <a:hlinkClick xmlns:r="http://schemas.openxmlformats.org/officeDocument/2006/relationships" r:id="Rafd9e5ae71504e74"/>
+              </a:rPr>
+              <a:t>huggingface.co/datasets/ATH-MaaS/HSCodeComp</a:t>
             </a:r>
           </a:p>
         </p:txBody>
@@ -7645,6 +7688,7 @@
           <a:lstStyle xmlns:a="http://schemas.openxmlformats.org/drawingml/2006/main"/>
           <a:p xmlns:a="http://schemas.openxmlformats.org/drawingml/2006/main">
             <a:pPr>
+              <a:buNone/>
               <a:defRPr sz="3675" b="1">
                 <a:solidFill>
                   <a:srgbClr val="182C29"/>
@@ -7702,6 +7746,7 @@
           <a:lstStyle xmlns:a="http://schemas.openxmlformats.org/drawingml/2006/main"/>
           <a:p xmlns:a="http://schemas.openxmlformats.org/drawingml/2006/main">
             <a:pPr>
+              <a:buNone/>
               <a:defRPr sz="2100" b="0">
                 <a:solidFill>
                   <a:srgbClr val="5E706B"/>
@@ -7759,6 +7804,7 @@
           <a:lstStyle xmlns:a="http://schemas.openxmlformats.org/drawingml/2006/main"/>
           <a:p xmlns:a="http://schemas.openxmlformats.org/drawingml/2006/main">
             <a:pPr>
+              <a:buNone/>
               <a:defRPr sz="1350" b="0">
                 <a:solidFill>
                   <a:srgbClr val="5E706B"/>
@@ -7784,7 +7830,7 @@
       </p:sp>
       <p:graphicFrame>
         <p:nvGraphicFramePr>
-          <p:cNvPr id="15" name="Chart"/>
+          <p:cNvPr id="17" name="Chart"/>
           <p:cNvGraphicFramePr/>
           <p:nvPr/>
         </p:nvGraphicFramePr>
@@ -7794,7 +7840,7 @@
         </p:xfrm>
         <a:graphic xmlns:a="http://schemas.openxmlformats.org/drawingml/2006/main">
           <a:graphicData uri="http://schemas.openxmlformats.org/drawingml/2006/chart">
-            <c:chart xmlns:r="http://schemas.openxmlformats.org/officeDocument/2006/relationships" xmlns:c="http://schemas.openxmlformats.org/drawingml/2006/chart" r:id="Rf3f219ec14d3420b"/>
+            <c:chart xmlns:r="http://schemas.openxmlformats.org/officeDocument/2006/relationships" xmlns:c="http://schemas.openxmlformats.org/drawingml/2006/chart" r:id="R8867b879a4614beb"/>
           </a:graphicData>
         </a:graphic>
       </p:graphicFrame>
@@ -7832,6 +7878,7 @@
           <a:lstStyle xmlns:a="http://schemas.openxmlformats.org/drawingml/2006/main"/>
           <a:p xmlns:a="http://schemas.openxmlformats.org/drawingml/2006/main">
             <a:pPr>
+              <a:buNone/>
               <a:defRPr sz="2400" b="1">
                 <a:solidFill>
                   <a:srgbClr val="156E58"/>
@@ -7889,6 +7936,7 @@
           <a:lstStyle xmlns:a="http://schemas.openxmlformats.org/drawingml/2006/main"/>
           <a:p xmlns:a="http://schemas.openxmlformats.org/drawingml/2006/main">
             <a:pPr>
+              <a:buNone/>
               <a:defRPr sz="3150" b="1">
                 <a:solidFill>
                   <a:srgbClr val="182C29"/>
@@ -7946,6 +7994,7 @@
           <a:lstStyle xmlns:a="http://schemas.openxmlformats.org/drawingml/2006/main"/>
           <a:p xmlns:a="http://schemas.openxmlformats.org/drawingml/2006/main">
             <a:pPr>
+              <a:buNone/>
               <a:defRPr sz="2100" b="0">
                 <a:solidFill>
                   <a:srgbClr val="182C29"/>
@@ -8003,6 +8052,7 @@
           <a:lstStyle xmlns:a="http://schemas.openxmlformats.org/drawingml/2006/main"/>
           <a:p xmlns:a="http://schemas.openxmlformats.org/drawingml/2006/main">
             <a:pPr>
+              <a:buNone/>
               <a:defRPr sz="2400" b="1">
                 <a:solidFill>
                   <a:srgbClr val="156E58"/>
@@ -8060,6 +8110,7 @@
           <a:lstStyle xmlns:a="http://schemas.openxmlformats.org/drawingml/2006/main"/>
           <a:p xmlns:a="http://schemas.openxmlformats.org/drawingml/2006/main">
             <a:pPr>
+              <a:buNone/>
               <a:defRPr sz="3150" b="1">
                 <a:solidFill>
                   <a:srgbClr val="182C29"/>
@@ -8117,6 +8168,7 @@
           <a:lstStyle xmlns:a="http://schemas.openxmlformats.org/drawingml/2006/main"/>
           <a:p xmlns:a="http://schemas.openxmlformats.org/drawingml/2006/main">
             <a:pPr>
+              <a:buNone/>
               <a:defRPr sz="2100" b="0">
                 <a:solidFill>
                   <a:srgbClr val="182C29"/>
@@ -8174,6 +8226,7 @@
           <a:lstStyle xmlns:a="http://schemas.openxmlformats.org/drawingml/2006/main"/>
           <a:p xmlns:a="http://schemas.openxmlformats.org/drawingml/2006/main">
             <a:pPr>
+              <a:buNone/>
               <a:defRPr sz="1875" b="0">
                 <a:solidFill>
                   <a:srgbClr val="5E706B"/>
@@ -8260,6 +8313,7 @@
           <a:lstStyle xmlns:a="http://schemas.openxmlformats.org/drawingml/2006/main"/>
           <a:p xmlns:a="http://schemas.openxmlformats.org/drawingml/2006/main">
             <a:pPr>
+              <a:buNone/>
               <a:defRPr sz="3675" b="1">
                 <a:solidFill>
                   <a:srgbClr val="182C29"/>
@@ -8317,6 +8371,7 @@
           <a:lstStyle xmlns:a="http://schemas.openxmlformats.org/drawingml/2006/main"/>
           <a:p xmlns:a="http://schemas.openxmlformats.org/drawingml/2006/main">
             <a:pPr>
+              <a:buNone/>
               <a:defRPr sz="2100" b="0">
                 <a:solidFill>
                   <a:srgbClr val="5E706B"/>
@@ -8374,6 +8429,7 @@
           <a:lstStyle xmlns:a="http://schemas.openxmlformats.org/drawingml/2006/main"/>
           <a:p xmlns:a="http://schemas.openxmlformats.org/drawingml/2006/main">
             <a:pPr>
+              <a:buNone/>
               <a:defRPr sz="1350" b="0">
                 <a:solidFill>
                   <a:srgbClr val="5E706B"/>
@@ -8399,7 +8455,7 @@
       </p:sp>
       <p:graphicFrame>
         <p:nvGraphicFramePr>
-          <p:cNvPr id="11" name=""/>
+          <p:cNvPr id="13" name=""/>
           <p:cNvGraphicFramePr/>
           <p:nvPr/>
         </p:nvGraphicFramePr>
@@ -8750,6 +8806,7 @@
           <a:lstStyle xmlns:a="http://schemas.openxmlformats.org/drawingml/2006/main"/>
           <a:p xmlns:a="http://schemas.openxmlformats.org/drawingml/2006/main">
             <a:pPr>
+              <a:buNone/>
               <a:defRPr sz="2025" b="0">
                 <a:solidFill>
                   <a:srgbClr val="5E706B"/>
@@ -8807,6 +8864,7 @@
           <a:lstStyle xmlns:a="http://schemas.openxmlformats.org/drawingml/2006/main"/>
           <a:p xmlns:a="http://schemas.openxmlformats.org/drawingml/2006/main">
             <a:pPr>
+              <a:buNone/>
               <a:defRPr sz="2250" b="1">
                 <a:solidFill>
                   <a:srgbClr val="156E58"/>
@@ -8864,6 +8922,7 @@
           <a:lstStyle xmlns:a="http://schemas.openxmlformats.org/drawingml/2006/main"/>
           <a:p xmlns:a="http://schemas.openxmlformats.org/drawingml/2006/main">
             <a:pPr>
+              <a:buNone/>
               <a:defRPr sz="1725" b="0">
                 <a:solidFill>
                   <a:srgbClr val="5E706B"/>
@@ -10234,7 +10293,7 @@
           <p:nvPr/>
         </p:nvPicPr>
         <p:blipFill>
-          <a:blip xmlns:r="http://schemas.openxmlformats.org/officeDocument/2006/relationships" xmlns:a="http://schemas.openxmlformats.org/drawingml/2006/main" r:embed="R5dd6ef231bbc4553"/>
+          <a:blip xmlns:r="http://schemas.openxmlformats.org/officeDocument/2006/relationships" xmlns:a="http://schemas.openxmlformats.org/drawingml/2006/main" r:embed="R222b191908ff469c"/>
           <a:stretch xmlns:a="http://schemas.openxmlformats.org/drawingml/2006/main"/>
         </p:blipFill>
         <p:spPr>
@@ -13039,7 +13098,7 @@
       </p:sp>
       <p:cxnSp>
         <p:nvCxnSpPr>
-          <p:cNvPr id="37" name=""/>
+          <p:cNvPr id="49" name=""/>
           <p:cNvCxnSpPr>
             <a:stCxn xmlns:a="http://schemas.openxmlformats.org/drawingml/2006/main" id="4" idx="3"/>
             <a:endCxn xmlns:a="http://schemas.openxmlformats.org/drawingml/2006/main" id="5" idx="1"/>
@@ -13124,7 +13183,7 @@
       </p:sp>
       <p:cxnSp>
         <p:nvCxnSpPr>
-          <p:cNvPr id="39" name=""/>
+          <p:cNvPr id="51" name=""/>
           <p:cNvCxnSpPr>
             <a:stCxn xmlns:a="http://schemas.openxmlformats.org/drawingml/2006/main" id="5" idx="3"/>
             <a:endCxn xmlns:a="http://schemas.openxmlformats.org/drawingml/2006/main" id="7" idx="1"/>
@@ -13209,7 +13268,7 @@
       </p:sp>
       <p:cxnSp>
         <p:nvCxnSpPr>
-          <p:cNvPr id="41" name=""/>
+          <p:cNvPr id="53" name=""/>
           <p:cNvCxnSpPr>
             <a:stCxn xmlns:a="http://schemas.openxmlformats.org/drawingml/2006/main" id="7" idx="3"/>
             <a:endCxn xmlns:a="http://schemas.openxmlformats.org/drawingml/2006/main" id="9" idx="1"/>
@@ -13294,7 +13353,7 @@
       </p:sp>
       <p:cxnSp>
         <p:nvCxnSpPr>
-          <p:cNvPr id="43" name=""/>
+          <p:cNvPr id="55" name=""/>
           <p:cNvCxnSpPr>
             <a:stCxn xmlns:a="http://schemas.openxmlformats.org/drawingml/2006/main" id="9" idx="3"/>
             <a:endCxn xmlns:a="http://schemas.openxmlformats.org/drawingml/2006/main" id="11" idx="1"/>
@@ -14569,7 +14628,7 @@
           <p:nvPr/>
         </p:nvPicPr>
         <p:blipFill>
-          <a:blip xmlns:r="http://schemas.openxmlformats.org/officeDocument/2006/relationships" xmlns:a="http://schemas.openxmlformats.org/drawingml/2006/main" r:embed="Rfb0b81b56d264eff"/>
+          <a:blip xmlns:r="http://schemas.openxmlformats.org/officeDocument/2006/relationships" xmlns:a="http://schemas.openxmlformats.org/drawingml/2006/main" r:embed="R24eaa77ad35f4beb"/>
           <a:stretch xmlns:a="http://schemas.openxmlformats.org/drawingml/2006/main"/>
         </p:blipFill>
         <p:spPr>
@@ -15023,7 +15082,7 @@
       </p:sp>
       <p:cxnSp>
         <p:nvCxnSpPr>
-          <p:cNvPr id="26" name=""/>
+          <p:cNvPr id="34" name=""/>
           <p:cNvCxnSpPr>
             <a:stCxn xmlns:a="http://schemas.openxmlformats.org/drawingml/2006/main" id="4" idx="3"/>
             <a:endCxn xmlns:a="http://schemas.openxmlformats.org/drawingml/2006/main" id="5" idx="1"/>
@@ -15108,7 +15167,7 @@
       </p:sp>
       <p:cxnSp>
         <p:nvCxnSpPr>
-          <p:cNvPr id="28" name=""/>
+          <p:cNvPr id="36" name=""/>
           <p:cNvCxnSpPr>
             <a:stCxn xmlns:a="http://schemas.openxmlformats.org/drawingml/2006/main" id="5" idx="3"/>
             <a:endCxn xmlns:a="http://schemas.openxmlformats.org/drawingml/2006/main" id="7" idx="1"/>

</xml_diff>

<commit_message>
Document service-scoped Jev benchmark and revise portfolio appendix
</commit_message>
<xml_diff>
--- a/portfolio/crossborder-portfolio.pptx
+++ b/portfolio/crossborder-portfolio.pptx
@@ -2,30 +2,30 @@
 <file path=ppt/presentation.xml><?xml version="1.0" encoding="utf-8"?>
 <p:presentation xmlns:p="http://schemas.openxmlformats.org/presentationml/2006/main">
   <p:sldMasterIdLst>
-    <p:sldMasterId xmlns:r="http://schemas.openxmlformats.org/officeDocument/2006/relationships" id="2147483648" r:id="Rfc73e56126214a4d"/>
+    <p:sldMasterId xmlns:r="http://schemas.openxmlformats.org/officeDocument/2006/relationships" id="2147483648" r:id="Ra56d68c42fbb43a4"/>
   </p:sldMasterIdLst>
   <p:notesMasterIdLst>
-    <p:notesMasterId xmlns:r="http://schemas.openxmlformats.org/officeDocument/2006/relationships" r:id="R6620ae9930944070"/>
+    <p:notesMasterId xmlns:r="http://schemas.openxmlformats.org/officeDocument/2006/relationships" r:id="R58e65546b5ec41dc"/>
   </p:notesMasterIdLst>
   <p:sldIdLst>
-    <p:sldId xmlns:r="http://schemas.openxmlformats.org/officeDocument/2006/relationships" id="256" r:id="R4620abbc58554d17"/>
-    <p:sldId xmlns:r="http://schemas.openxmlformats.org/officeDocument/2006/relationships" id="257" r:id="R2ab673175a354639"/>
-    <p:sldId xmlns:r="http://schemas.openxmlformats.org/officeDocument/2006/relationships" id="258" r:id="R8ca2ada2006344a6"/>
-    <p:sldId xmlns:r="http://schemas.openxmlformats.org/officeDocument/2006/relationships" id="259" r:id="R71d6a37f70814a9a"/>
-    <p:sldId xmlns:r="http://schemas.openxmlformats.org/officeDocument/2006/relationships" id="260" r:id="R797e253fc39e47b8"/>
-    <p:sldId xmlns:r="http://schemas.openxmlformats.org/officeDocument/2006/relationships" id="261" r:id="Raafd823886724e21"/>
-    <p:sldId xmlns:r="http://schemas.openxmlformats.org/officeDocument/2006/relationships" id="262" r:id="Reda0ddb6f15345fa"/>
-    <p:sldId xmlns:r="http://schemas.openxmlformats.org/officeDocument/2006/relationships" id="263" r:id="Rd82faf79885e4808"/>
-    <p:sldId xmlns:r="http://schemas.openxmlformats.org/officeDocument/2006/relationships" id="264" r:id="R14b781f27b6a4565"/>
-    <p:sldId xmlns:r="http://schemas.openxmlformats.org/officeDocument/2006/relationships" id="265" r:id="R26ff4dc103e84640"/>
-    <p:sldId xmlns:r="http://schemas.openxmlformats.org/officeDocument/2006/relationships" id="266" r:id="R4772e337f96f45e0"/>
-    <p:sldId xmlns:r="http://schemas.openxmlformats.org/officeDocument/2006/relationships" id="267" r:id="Ra2fb7ba48b654043"/>
-    <p:sldId xmlns:r="http://schemas.openxmlformats.org/officeDocument/2006/relationships" id="268" r:id="Rd523a707c0284741"/>
-    <p:sldId xmlns:r="http://schemas.openxmlformats.org/officeDocument/2006/relationships" id="269" r:id="R5c6686d4688c4b21"/>
-    <p:sldId xmlns:r="http://schemas.openxmlformats.org/officeDocument/2006/relationships" id="270" r:id="R904f62015ba6407d"/>
-    <p:sldId xmlns:r="http://schemas.openxmlformats.org/officeDocument/2006/relationships" id="271" r:id="R81acc5ce41114022"/>
-    <p:sldId xmlns:r="http://schemas.openxmlformats.org/officeDocument/2006/relationships" id="272" r:id="Rd6d16cc6f8014e6f"/>
-    <p:sldId xmlns:r="http://schemas.openxmlformats.org/officeDocument/2006/relationships" id="273" r:id="Rd18ecd584ff941d3"/>
+    <p:sldId xmlns:r="http://schemas.openxmlformats.org/officeDocument/2006/relationships" id="256" r:id="Ra4f0161fb4fd45e3"/>
+    <p:sldId xmlns:r="http://schemas.openxmlformats.org/officeDocument/2006/relationships" id="257" r:id="R93324130f41847b2"/>
+    <p:sldId xmlns:r="http://schemas.openxmlformats.org/officeDocument/2006/relationships" id="258" r:id="Raa59b28199364315"/>
+    <p:sldId xmlns:r="http://schemas.openxmlformats.org/officeDocument/2006/relationships" id="259" r:id="R8b357fa08a984173"/>
+    <p:sldId xmlns:r="http://schemas.openxmlformats.org/officeDocument/2006/relationships" id="260" r:id="R54383c14146d4815"/>
+    <p:sldId xmlns:r="http://schemas.openxmlformats.org/officeDocument/2006/relationships" id="261" r:id="R717176e21e0946bb"/>
+    <p:sldId xmlns:r="http://schemas.openxmlformats.org/officeDocument/2006/relationships" id="262" r:id="R0503203391ae4767"/>
+    <p:sldId xmlns:r="http://schemas.openxmlformats.org/officeDocument/2006/relationships" id="263" r:id="Rcb5688d1376243b7"/>
+    <p:sldId xmlns:r="http://schemas.openxmlformats.org/officeDocument/2006/relationships" id="264" r:id="R4953180543214287"/>
+    <p:sldId xmlns:r="http://schemas.openxmlformats.org/officeDocument/2006/relationships" id="265" r:id="Rd6bd13580fc54007"/>
+    <p:sldId xmlns:r="http://schemas.openxmlformats.org/officeDocument/2006/relationships" id="266" r:id="R047d32cdd79c4b7a"/>
+    <p:sldId xmlns:r="http://schemas.openxmlformats.org/officeDocument/2006/relationships" id="267" r:id="R52b493f1e3b54f86"/>
+    <p:sldId xmlns:r="http://schemas.openxmlformats.org/officeDocument/2006/relationships" id="268" r:id="Rf5024eb4406c4c88"/>
+    <p:sldId xmlns:r="http://schemas.openxmlformats.org/officeDocument/2006/relationships" id="269" r:id="R25e688f042b142e9"/>
+    <p:sldId xmlns:r="http://schemas.openxmlformats.org/officeDocument/2006/relationships" id="270" r:id="R0bf3e0af4376485f"/>
+    <p:sldId xmlns:r="http://schemas.openxmlformats.org/officeDocument/2006/relationships" id="271" r:id="Rddfa3c180f964570"/>
+    <p:sldId xmlns:r="http://schemas.openxmlformats.org/officeDocument/2006/relationships" id="272" r:id="R4268af0c7dd643d0"/>
+    <p:sldId xmlns:r="http://schemas.openxmlformats.org/officeDocument/2006/relationships" id="273" r:id="R0f43f7c3c6cd44e1"/>
   </p:sldIdLst>
   <p:sldSz cx="15240000" cy="8572500"/>
   <p:notesSz cx="6858000" cy="9144000"/>
@@ -949,7 +949,7 @@
           <a:lstStyle xmlns:a="http://schemas.openxmlformats.org/drawingml/2006/main"/>
           <a:p xmlns:a="http://schemas.openxmlformats.org/drawingml/2006/main">
             <a:r>
-              <a:t>HSCodeComp: 실제 전자상거래 상품632개,32개 대분류에 전문가가 미국 기준10자리 코드를 주석한 공개 벤치마크. 본 실험은94개 표본의 앞6자리HS6와 비교. https://huggingface.co/datasets/ATH-MaaS/HSCodeComp ; https://arxiv.org/abs/2510.19631 ; https://github.com/y00nZZang/product-catalog/blob/main/docs/jev-experiment-2026-10-06.md . 공식 한국 HSK 결정문이나 사람의 현지 재검토로 간주하지 않는다.</a:t>
+              <a:t>https://github.com/y00nZZang/product-catalog/blob/main/docs/service-scope-jev-experiment-2026-10-07.md ; https://huggingface.co/datasets/ATH-MaaS/HSCodeComp ; https://docs.typesafe.ai/primitives/choice . 서비스 범위는 연구 초안으로 사조의 검증된 정책이 아니다. 기존 단일 경로 Jev와 Luna만 비교. 정답/보류/실패는 공개 레포에서 확인.</a:t>
             </a:r>
           </a:p>
         </p:txBody>
@@ -1019,7 +1019,7 @@
           <a:lstStyle xmlns:a="http://schemas.openxmlformats.org/drawingml/2006/main"/>
           <a:p xmlns:a="http://schemas.openxmlformats.org/drawingml/2006/main">
             <a:r>
-              <a:t>https://github.com/y00nZZang/product-catalog/blob/main/docs/jev-experiment-2026-10-06.md . HF94개: Jev0.6747679375초/Luna4.296453624초, 비용0.023445996/0.0544944USD. Mercari30개:0.6689978755/3.79168373초, 비용0.00719754/0.01560205USD. 시간은 각 순차 HTTP+파싱+검증 시간 합의 중앙값. 공급사2개 동시 실행, 단계는 순차. 수집·포장·세금 계산·큐 대기시간 제외. 비용은 usage기반 추정, 청구서 확정액 아님.</a:t>
+              <a:t>https://github.com/y00nZZang/product-catalog/blob/main/docs/service-scope-jev-experiment-2026-10-07.md ; https://github.com/y00nZZang/product-catalog/blob/main/notebooks/service-scope-results-2026-10-07.json . 새로운93개 단일 경로 계층 탐색. Jev중앙0.6449865829199553초/Luna4.510487750987522초(반올림값, 상세JSON참조). 비용0.022579830000000002/0.052664375USD. 시간은 순차 HTTP+파싱+검증 합. 두 제공자는 같은 상품에서 동시 실행. 수집·큐·배송·세금 단계 제외. 비용usage기반 추정으로 실제 청구서 확정 아님. 품질/답변률/실패는 공개 레포에 별도기록, 비용이 판단품질을 의미하지 않는다.</a:t>
             </a:r>
           </a:p>
         </p:txBody>
@@ -1089,7 +1089,7 @@
           <a:lstStyle xmlns:a="http://schemas.openxmlformats.org/drawingml/2006/main"/>
           <a:p xmlns:a="http://schemas.openxmlformats.org/drawingml/2006/main">
             <a:r>
-              <a:t>https://github.com/y00nZZang/product-catalog/blob/main/docs/jev-experiment-2026-10-06.md ; https://github.com/y00nZZang/product-catalog/blob/main/notebooks/two-datasets-results-2026-10-06.json . HF94개: Jev28/94(29.8%), Luna36/94(38.3%), 보류 포함. 답변 사례만:28/81(34.6%),36/65(55.4%). 독립 Sol이HS6를 선택한Mercari25개에서Jev21/25(84%),Luna19/25(76%). 보류 포함30개 전체판단은Jev21/30(70%),Luna23/30(76.7%). Sol은정답/사람검토아님, 공유모델군편향가능. 운영도입하지않았으며 제안은 실험 결과에 대한 해석이다.</a:t>
+              <a:t>https://github.com/y00nZZang/product-catalog/blob/main/docs/service-scope-jev-experiment-2026-10-07.md ; https://github.com/y00nZZang/product-catalog/blob/main/notebooks/service-scope-failures-2026-10-07.json . 판단 품질의 동일성을 입증한 실험이 아니다. 후보 판단 단계 적용은 제안이며 서비스운영도입 아님. 과거전체94개, 범위안78개, 새93개를 레포에 구분 보존. 신규모델·복수경로·혼합방법은 후속실험에서 제외.</a:t>
             </a:r>
           </a:p>
         </p:txBody>
@@ -1717,7 +1717,7 @@
   </p:cSld>
   <p:clrMap bg1="lt1" tx1="dk1" bg2="lt2" tx2="dk2" accent1="accent1" accent2="accent2" accent3="accent3" accent4="accent4" accent5="accent5" accent6="accent6" hlink="hlink" folHlink="folHlink"/>
   <p:sldLayoutIdLst>
-    <p:sldLayoutId xmlns:r="http://schemas.openxmlformats.org/officeDocument/2006/relationships" id="2147483649" r:id="R55975cbe5f7e467a"/>
+    <p:sldLayoutId xmlns:r="http://schemas.openxmlformats.org/officeDocument/2006/relationships" id="2147483649" r:id="Rfe025f4721fd4067"/>
   </p:sldLayoutIdLst>
   <p:txStyles>
     <p:titleStyle>
@@ -2266,29 +2266,23 @@
           </c:spPr>
           <c:cat>
             <c:strRef>
-              <c:f>'Chart Data'!$A$2:$A$3</c:f>
+              <c:f>'Chart Data'!$A$2:$A$2</c:f>
               <c:strCache>
-                <c:ptCount val="2"/>
+                <c:ptCount val="1"/>
                 <c:pt idx="0">
-                  <c:v>HF 표본94개</c:v>
-                </c:pt>
-                <c:pt idx="1">
-                  <c:v>메루카리30개</c:v>
+                  <c:v>새 서비스 범위93개</c:v>
                 </c:pt>
               </c:strCache>
             </c:strRef>
           </c:cat>
           <c:val>
             <c:numRef>
-              <c:f>'Chart Data'!$B$2:$B$3</c:f>
+              <c:f>'Chart Data'!$B$2:$B$2</c:f>
               <c:numCache>
                 <c:formatCode>General</c:formatCode>
-                <c:ptCount val="2"/>
+                <c:ptCount val="1"/>
                 <c:pt idx="0">
-                  <c:v>0.675</c:v>
-                </c:pt>
-                <c:pt idx="1">
-                  <c:v>0.669</c:v>
+                  <c:v>0.645</c:v>
                 </c:pt>
               </c:numCache>
             </c:numRef>
@@ -2307,29 +2301,23 @@
           </c:spPr>
           <c:cat>
             <c:strRef>
-              <c:f>'Chart Data'!$C$2:$C$3</c:f>
+              <c:f>'Chart Data'!$C$2:$C$2</c:f>
               <c:strCache>
-                <c:ptCount val="2"/>
+                <c:ptCount val="1"/>
                 <c:pt idx="0">
-                  <c:v>HF 표본94개</c:v>
-                </c:pt>
-                <c:pt idx="1">
-                  <c:v>메루카리30개</c:v>
+                  <c:v>새 서비스 범위93개</c:v>
                 </c:pt>
               </c:strCache>
             </c:strRef>
           </c:cat>
           <c:val>
             <c:numRef>
-              <c:f>'Chart Data'!$D$2:$D$3</c:f>
+              <c:f>'Chart Data'!$D$2:$D$2</c:f>
               <c:numCache>
                 <c:formatCode>General</c:formatCode>
-                <c:ptCount val="2"/>
+                <c:ptCount val="1"/>
                 <c:pt idx="0">
-                  <c:v>4.296</c:v>
-                </c:pt>
-                <c:pt idx="1">
-                  <c:v>3.792</c:v>
+                  <c:v>4.51</c:v>
                 </c:pt>
               </c:numCache>
             </c:numRef>
@@ -2361,7 +2349,7 @@
           <c:showBubbleSize val="0"/>
           <c:showLeaderLines val="0"/>
         </c:dLbls>
-        <c:gapWidth val="90"/>
+        <c:gapWidth val="110"/>
         <c:axId val="48650112"/>
         <c:axId val="48672768"/>
       </c:barChart>
@@ -3134,7 +3122,7 @@
           <p:nvPr/>
         </p:nvPicPr>
         <p:blipFill>
-          <a:blip xmlns:r="http://schemas.openxmlformats.org/officeDocument/2006/relationships" xmlns:a="http://schemas.openxmlformats.org/drawingml/2006/main" r:embed="R9cf8175e2ec14e4d"/>
+          <a:blip xmlns:r="http://schemas.openxmlformats.org/officeDocument/2006/relationships" xmlns:a="http://schemas.openxmlformats.org/drawingml/2006/main" r:embed="R28a6c3b97fa147f7"/>
           <a:stretch xmlns:a="http://schemas.openxmlformats.org/drawingml/2006/main"/>
         </p:blipFill>
         <p:spPr>
@@ -3776,7 +3764,7 @@
       </p:sp>
       <p:cxnSp>
         <p:nvCxnSpPr>
-          <p:cNvPr id="35" name=""/>
+          <p:cNvPr id="27" name=""/>
           <p:cNvCxnSpPr>
             <a:stCxn xmlns:a="http://schemas.openxmlformats.org/drawingml/2006/main" id="4" idx="3"/>
             <a:endCxn xmlns:a="http://schemas.openxmlformats.org/drawingml/2006/main" id="5" idx="1"/>
@@ -3861,7 +3849,7 @@
       </p:sp>
       <p:cxnSp>
         <p:nvCxnSpPr>
-          <p:cNvPr id="37" name=""/>
+          <p:cNvPr id="29" name=""/>
           <p:cNvCxnSpPr>
             <a:stCxn xmlns:a="http://schemas.openxmlformats.org/drawingml/2006/main" id="5" idx="3"/>
             <a:endCxn xmlns:a="http://schemas.openxmlformats.org/drawingml/2006/main" id="7" idx="1"/>
@@ -6671,7 +6659,7 @@
       </p:sp>
       <p:cxnSp>
         <p:nvCxnSpPr>
-          <p:cNvPr id="36" name=""/>
+          <p:cNvPr id="27" name=""/>
           <p:cNvCxnSpPr>
             <a:stCxn xmlns:a="http://schemas.openxmlformats.org/drawingml/2006/main" id="5" idx="3"/>
             <a:endCxn xmlns:a="http://schemas.openxmlformats.org/drawingml/2006/main" id="6" idx="1"/>
@@ -6756,7 +6744,7 @@
       </p:sp>
       <p:cxnSp>
         <p:nvCxnSpPr>
-          <p:cNvPr id="38" name=""/>
+          <p:cNvPr id="29" name=""/>
           <p:cNvCxnSpPr>
             <a:stCxn xmlns:a="http://schemas.openxmlformats.org/drawingml/2006/main" id="6" idx="3"/>
             <a:endCxn xmlns:a="http://schemas.openxmlformats.org/drawingml/2006/main" id="8" idx="1"/>
@@ -6977,7 +6965,7 @@
           <p:cNvPr id="8" name="">
             <a:extLst xmlns:a="http://schemas.openxmlformats.org/drawingml/2006/main">
               <a:ext uri="{FF2B5EF4-FFF2-40B4-BE49-F238E27FC236}">
-                <a16:creationId xmlns:a16="http://schemas.microsoft.com/office/drawing/2014/main" id="{32208E57-18E6-46B5-8C98-0B617BA6AF3E}"/>
+                <a16:creationId xmlns:a16="http://schemas.microsoft.com/office/drawing/2014/main" id="{257E9C89-36F8-44F5-9A6D-3FA9FE32B6EE}"/>
               </a:ext>
             </a:extLst>
           </p:cNvPr>
@@ -7006,7 +6994,6 @@
           <a:lstStyle xmlns:a="http://schemas.openxmlformats.org/drawingml/2006/main"/>
           <a:p xmlns:a="http://schemas.openxmlformats.org/drawingml/2006/main">
             <a:pPr>
-              <a:buNone/>
               <a:defRPr sz="3675" b="1">
                 <a:solidFill>
                   <a:srgbClr val="182C29"/>
@@ -7035,7 +7022,7 @@
           <p:cNvPr id="2" name="">
             <a:extLst xmlns:a="http://schemas.openxmlformats.org/drawingml/2006/main">
               <a:ext uri="{FF2B5EF4-FFF2-40B4-BE49-F238E27FC236}">
-                <a16:creationId xmlns:a16="http://schemas.microsoft.com/office/drawing/2014/main" id="{EF7A26ED-E82B-4BBB-8FAA-EE00C720382B}"/>
+                <a16:creationId xmlns:a16="http://schemas.microsoft.com/office/drawing/2014/main" id="{CC463259-6DB3-4276-946A-81F3A6C6913F}"/>
               </a:ext>
             </a:extLst>
           </p:cNvPr>
@@ -7064,7 +7051,6 @@
           <a:lstStyle xmlns:a="http://schemas.openxmlformats.org/drawingml/2006/main"/>
           <a:p xmlns:a="http://schemas.openxmlformats.org/drawingml/2006/main">
             <a:pPr>
-              <a:buNone/>
               <a:defRPr sz="2100" b="0">
                 <a:solidFill>
                   <a:srgbClr val="5E706B"/>
@@ -7083,7 +7069,7 @@
                 <a:ea typeface="Apple SD Gothic Neo"/>
                 <a:cs typeface="Apple SD Gothic Neo"/>
               </a:rPr>
-              <a:t>관세 후보 선택의 처리시간과 품질을 따로 측정했습니다.</a:t>
+              <a:t>가정용·취미 상품의 HS 후보 선택시간과 비용을 비교했습니다.</a:t>
             </a:r>
           </a:p>
         </p:txBody>
@@ -7093,7 +7079,7 @@
           <p:cNvPr id="3" name="">
             <a:extLst xmlns:a="http://schemas.openxmlformats.org/drawingml/2006/main">
               <a:ext uri="{FF2B5EF4-FFF2-40B4-BE49-F238E27FC236}">
-                <a16:creationId xmlns:a16="http://schemas.microsoft.com/office/drawing/2014/main" id="{C57488CA-0878-4414-A0DC-BE367E4438A7}"/>
+                <a16:creationId xmlns:a16="http://schemas.microsoft.com/office/drawing/2014/main" id="{43BC3CF6-1C90-41B1-B0A3-F0B83D628E76}"/>
               </a:ext>
             </a:extLst>
           </p:cNvPr>
@@ -7122,7 +7108,6 @@
           <a:lstStyle xmlns:a="http://schemas.openxmlformats.org/drawingml/2006/main"/>
           <a:p xmlns:a="http://schemas.openxmlformats.org/drawingml/2006/main">
             <a:pPr>
-              <a:buNone/>
               <a:defRPr sz="1350" b="0">
                 <a:solidFill>
                   <a:srgbClr val="5E706B"/>
@@ -7141,7 +7126,7 @@
                 <a:ea typeface="Apple SD Gothic Neo"/>
                 <a:cs typeface="Apple SD Gothic Neo"/>
               </a:rPr>
-              <a:t>16   윤장한 · 직구 조사와 도구 구현 · 부록 · 2026.10.06</a:t>
+              <a:t>16   윤장한 · 직구 조사와 도구 구현 · 부록 · 2026.10.07</a:t>
             </a:r>
           </a:p>
         </p:txBody>
@@ -7151,7 +7136,7 @@
           <p:cNvPr id="4" name="">
             <a:extLst xmlns:a="http://schemas.openxmlformats.org/drawingml/2006/main">
               <a:ext uri="{FF2B5EF4-FFF2-40B4-BE49-F238E27FC236}">
-                <a16:creationId xmlns:a16="http://schemas.microsoft.com/office/drawing/2014/main" id="{C3F5F128-AC86-473A-B614-3C28D06784FF}"/>
+                <a16:creationId xmlns:a16="http://schemas.microsoft.com/office/drawing/2014/main" id="{184A043A-B990-499F-B282-A1D59D3ED6A8}"/>
               </a:ext>
             </a:extLst>
           </p:cNvPr>
@@ -7180,7 +7165,6 @@
           <a:lstStyle xmlns:a="http://schemas.openxmlformats.org/drawingml/2006/main"/>
           <a:p xmlns:a="http://schemas.openxmlformats.org/drawingml/2006/main">
             <a:pPr>
-              <a:buNone/>
               <a:defRPr sz="2250" b="0">
                 <a:solidFill>
                   <a:srgbClr val="182C29"/>
@@ -7204,7 +7188,6 @@
           </a:p>
           <a:p xmlns:a="http://schemas.openxmlformats.org/drawingml/2006/main">
             <a:pPr>
-              <a:buNone/>
               <a:defRPr sz="2250" b="0">
                 <a:solidFill>
                   <a:srgbClr val="182C29"/>
@@ -7223,14 +7206,14 @@
                 <a:ea typeface="Apple SD Gothic Neo"/>
                 <a:cs typeface="Apple SD Gothic Neo"/>
               </a:rPr>
-              <a:t>상품명·속성·카테고리를 제공하며, 이번에는94개 표본의 HS6 정답과 비교했습니다.</a:t>
+              <a:t>가정용·취미 범위에서 이전 실험과 겹치지 않는 새 상품93개를 평가했습니다.</a:t>
             </a:r>
           </a:p>
         </p:txBody>
       </p:sp>
       <p:graphicFrame>
         <p:nvGraphicFramePr>
-          <p:cNvPr id="14" name=""/>
+          <p:cNvPr id="12" name=""/>
           <p:cNvGraphicFramePr/>
           <p:nvPr/>
         </p:nvGraphicFramePr>
@@ -7243,11 +7226,11 @@
             <a:tbl>
               <a:tblPr/>
               <a:tblGrid>
-                <a:gridCol w="3048000"/>
-                <a:gridCol w="4238625"/>
-                <a:gridCol w="6315075"/>
+                <a:gridCol w="2667000"/>
+                <a:gridCol w="5143500"/>
+                <a:gridCol w="5791200"/>
               </a:tblGrid>
-              <a:tr h="755650">
+              <a:tr h="566738">
                 <a:tc>
                   <a:txBody>
                     <a:bodyPr/>
@@ -7262,7 +7245,7 @@
                           <a:ea typeface="Apple SD Gothic Neo"/>
                           <a:cs typeface="Apple SD Gothic Neo"/>
                         </a:rPr>
-                        <a:t>데이터</a:t>
+                        <a:t>구분</a:t>
                       </a:r>
                     </a:p>
                   </a:txBody>
@@ -7286,7 +7269,7 @@
                           <a:ea typeface="Apple SD Gothic Neo"/>
                           <a:cs typeface="Apple SD Gothic Neo"/>
                         </a:rPr>
-                        <a:t>실행 범위</a:t>
+                        <a:t>실험 조건</a:t>
                       </a:r>
                     </a:p>
                   </a:txBody>
@@ -7310,7 +7293,7 @@
                           <a:ea typeface="Apple SD Gothic Neo"/>
                           <a:cs typeface="Apple SD Gothic Neo"/>
                         </a:rPr>
-                        <a:t>품질 평가 기준</a:t>
+                        <a:t>선별·평가 원칙</a:t>
                       </a:r>
                     </a:p>
                   </a:txBody>
@@ -7321,7 +7304,7 @@
                   </a:tcPr>
                 </a:tc>
               </a:tr>
-              <a:tr h="755650">
+              <a:tr h="566738">
                 <a:tc>
                   <a:txBody>
                     <a:bodyPr/>
@@ -7336,7 +7319,7 @@
                           <a:ea typeface="Apple SD Gothic Neo"/>
                           <a:cs typeface="Apple SD Gothic Neo"/>
                         </a:rPr>
-                        <a:t>HSCodeComp</a:t>
+                        <a:t>대상</a:t>
                       </a:r>
                     </a:p>
                   </a:txBody>
@@ -7360,7 +7343,7 @@
                           <a:ea typeface="Apple SD Gothic Neo"/>
                           <a:cs typeface="Apple SD Gothic Neo"/>
                         </a:rPr>
-                        <a:t>94개 층화 표본 / 전체632개</a:t>
+                        <a:t>생활·주방 / 의류 / 취미 / 전자기기</a:t>
                       </a:r>
                     </a:p>
                   </a:txBody>
@@ -7384,7 +7367,7 @@
                           <a:ea typeface="Apple SD Gothic Neo"/>
                           <a:cs typeface="Apple SD Gothic Neo"/>
                         </a:rPr>
-                        <a:t>공개 전문가 라벨과 HS6 일치</a:t>
+                        <a:t>상품 용도를 기준으로 선별</a:t>
                       </a:r>
                     </a:p>
                   </a:txBody>
@@ -7395,7 +7378,7 @@
                   </a:tcPr>
                 </a:tc>
               </a:tr>
-              <a:tr h="755650">
+              <a:tr h="566738">
                 <a:tc>
                   <a:txBody>
                     <a:bodyPr/>
@@ -7410,7 +7393,7 @@
                           <a:ea typeface="Apple SD Gothic Neo"/>
                           <a:cs typeface="Apple SD Gothic Neo"/>
                         </a:rPr>
-                        <a:t>메루카리</a:t>
+                        <a:t>비교</a:t>
                       </a:r>
                     </a:p>
                   </a:txBody>
@@ -7434,7 +7417,7 @@
                           <a:ea typeface="Apple SD Gothic Neo"/>
                           <a:cs typeface="Apple SD Gothic Neo"/>
                         </a:rPr>
-                        <a:t>실제 판매글30개 전체</a:t>
+                        <a:t>Jev1.13 ↔ GPT-6 Luna low</a:t>
                       </a:r>
                     </a:p>
                   </a:txBody>
@@ -7458,7 +7441,7 @@
                           <a:ea typeface="Apple SD Gothic Neo"/>
                           <a:cs typeface="Apple SD Gothic Neo"/>
                         </a:rPr>
-                        <a:t>독립 GPT-6 Sol 심사 결과와 일치</a:t>
+                        <a:t>동일한 상품명·속성·HS 목록</a:t>
                       </a:r>
                     </a:p>
                   </a:txBody>
@@ -7469,6 +7452,80 @@
                   </a:tcPr>
                 </a:tc>
               </a:tr>
+              <a:tr h="566738">
+                <a:tc>
+                  <a:txBody>
+                    <a:bodyPr/>
+                    <a:lstStyle/>
+                    <a:p>
+                      <a:r>
+                        <a:rPr sz="2175" b="0">
+                          <a:solidFill>
+                            <a:srgbClr val="182C29"/>
+                          </a:solidFill>
+                          <a:latin typeface="Apple SD Gothic Neo"/>
+                          <a:ea typeface="Apple SD Gothic Neo"/>
+                          <a:cs typeface="Apple SD Gothic Neo"/>
+                        </a:rPr>
+                        <a:t>방식</a:t>
+                      </a:r>
+                    </a:p>
+                  </a:txBody>
+                  <a:tcPr marL="91440" marR="91440" marT="45720" marB="45720">
+                    <a:solidFill>
+                      <a:srgbClr val="FFFFFF"/>
+                    </a:solidFill>
+                  </a:tcPr>
+                </a:tc>
+                <a:tc>
+                  <a:txBody>
+                    <a:bodyPr/>
+                    <a:lstStyle/>
+                    <a:p>
+                      <a:r>
+                        <a:rPr sz="2175" b="0">
+                          <a:solidFill>
+                            <a:srgbClr val="182C29"/>
+                          </a:solidFill>
+                          <a:latin typeface="Apple SD Gothic Neo"/>
+                          <a:ea typeface="Apple SD Gothic Neo"/>
+                          <a:cs typeface="Apple SD Gothic Neo"/>
+                        </a:rPr>
+                        <a:t>단일 경로 HS2 → HS4 → HS6</a:t>
+                      </a:r>
+                    </a:p>
+                  </a:txBody>
+                  <a:tcPr marL="91440" marR="91440" marT="45720" marB="45720">
+                    <a:solidFill>
+                      <a:srgbClr val="FFFFFF"/>
+                    </a:solidFill>
+                  </a:tcPr>
+                </a:tc>
+                <a:tc>
+                  <a:txBody>
+                    <a:bodyPr/>
+                    <a:lstStyle/>
+                    <a:p>
+                      <a:r>
+                        <a:rPr sz="2175" b="0">
+                          <a:solidFill>
+                            <a:srgbClr val="182C29"/>
+                          </a:solidFill>
+                          <a:latin typeface="Apple SD Gothic Neo"/>
+                          <a:ea typeface="Apple SD Gothic Neo"/>
+                          <a:cs typeface="Apple SD Gothic Neo"/>
+                        </a:rPr>
+                        <a:t>정보 부족·복합 재질·세트 유지</a:t>
+                      </a:r>
+                    </a:p>
+                  </a:txBody>
+                  <a:tcPr marL="91440" marR="91440" marT="45720" marB="45720">
+                    <a:solidFill>
+                      <a:srgbClr val="FFFFFF"/>
+                    </a:solidFill>
+                  </a:tcPr>
+                </a:tc>
+              </a:tr>
             </a:tbl>
           </a:graphicData>
         </a:graphic>
@@ -7478,7 +7535,7 @@
           <p:cNvPr id="6" name="">
             <a:extLst xmlns:a="http://schemas.openxmlformats.org/drawingml/2006/main">
               <a:ext uri="{FF2B5EF4-FFF2-40B4-BE49-F238E27FC236}">
-                <a16:creationId xmlns:a16="http://schemas.microsoft.com/office/drawing/2014/main" id="{FFEE9D22-BAD4-4A19-979B-E83025455E69}"/>
+                <a16:creationId xmlns:a16="http://schemas.microsoft.com/office/drawing/2014/main" id="{E44A524F-98D4-4099-9EF4-56CADF8D8408}"/>
               </a:ext>
             </a:extLst>
           </p:cNvPr>
@@ -7489,8 +7546,8 @@
         </p:nvSpPr>
         <p:spPr>
           <a:xfrm xmlns:a="http://schemas.openxmlformats.org/drawingml/2006/main">
-            <a:off x="819150" y="6734175"/>
-            <a:ext cx="13525500" cy="685800"/>
+            <a:off x="819150" y="6829425"/>
+            <a:ext cx="13525500" cy="428625"/>
           </a:xfrm>
           <a:prstGeom xmlns:a="http://schemas.openxmlformats.org/drawingml/2006/main" prst="rect">
             <a:avLst/>
@@ -7507,10 +7564,9 @@
           <a:lstStyle xmlns:a="http://schemas.openxmlformats.org/drawingml/2006/main"/>
           <a:p xmlns:a="http://schemas.openxmlformats.org/drawingml/2006/main">
             <a:pPr>
-              <a:buNone/>
               <a:defRPr sz="1875" b="0">
                 <a:solidFill>
-                  <a:srgbClr val="5E706B"/>
+                  <a:srgbClr val="156E58"/>
                 </a:solidFill>
                 <a:latin typeface="Apple SD Gothic Neo"/>
                 <a:ea typeface="Apple SD Gothic Neo"/>
@@ -7520,37 +7576,25 @@
             <a:r>
               <a:rPr sz="1875" b="0">
                 <a:solidFill>
-                  <a:srgbClr val="5E706B"/>
-                </a:solidFill>
-                <a:latin typeface="Apple SD Gothic Neo"/>
-                <a:ea typeface="Apple SD Gothic Neo"/>
-                <a:cs typeface="Apple SD Gothic Neo"/>
-              </a:rPr>
-              <a:t>비교: Jev1.13 ↔ GPT-6 Luna low. 심사자는 기존 예측·공급사 이름을 보지 않았습니다.</a:t>
-            </a:r>
-          </a:p>
-          <a:p xmlns:a="http://schemas.openxmlformats.org/drawingml/2006/main">
-            <a:pPr>
-              <a:buNone/>
-              <a:defRPr sz="1875" b="0">
-                <a:solidFill>
-                  <a:srgbClr val="5E706B"/>
-                </a:solidFill>
-                <a:latin typeface="Apple SD Gothic Neo"/>
-                <a:ea typeface="Apple SD Gothic Neo"/>
-                <a:cs typeface="Apple SD Gothic Neo"/>
-              </a:defRPr>
-            </a:pPr>
+                  <a:srgbClr val="156E58"/>
+                </a:solidFill>
+                <a:latin typeface="Apple SD Gothic Neo"/>
+                <a:ea typeface="Apple SD Gothic Neo"/>
+                <a:cs typeface="Apple SD Gothic Neo"/>
+              </a:rPr>
+              <a:t>HSCodeComp 원본: </a:t>
+            </a:r>
             <a:r>
               <a:rPr sz="1875" b="0">
                 <a:solidFill>
-                  <a:srgbClr val="5E706B"/>
-                </a:solidFill>
-                <a:latin typeface="Apple SD Gothic Neo"/>
-                <a:ea typeface="Apple SD Gothic Neo"/>
-                <a:cs typeface="Apple SD Gothic Neo"/>
-              </a:rPr>
-              <a:t>텍스트만 사용한 단일 경로 비교이며 웹 검색·이미지 분석을 제외했습니다.</a:t>
+                  <a:srgbClr val="156E58"/>
+                </a:solidFill>
+                <a:latin typeface="Apple SD Gothic Neo"/>
+                <a:ea typeface="Apple SD Gothic Neo"/>
+                <a:cs typeface="Apple SD Gothic Neo"/>
+                <a:hlinkClick xmlns:r="http://schemas.openxmlformats.org/officeDocument/2006/relationships" r:id="R50a12f88ed144c3b"/>
+              </a:rPr>
+              <a:t>huggingface.co/datasets/ATH-MaaS/HSCodeComp</a:t>
             </a:r>
           </a:p>
         </p:txBody>
@@ -7560,7 +7604,7 @@
           <p:cNvPr id="7" name="">
             <a:extLst xmlns:a="http://schemas.openxmlformats.org/drawingml/2006/main">
               <a:ext uri="{FF2B5EF4-FFF2-40B4-BE49-F238E27FC236}">
-                <a16:creationId xmlns:a16="http://schemas.microsoft.com/office/drawing/2014/main" id="{4D396F42-9085-4613-962A-A2E6EC17D4F0}"/>
+                <a16:creationId xmlns:a16="http://schemas.microsoft.com/office/drawing/2014/main" id="{1591DE84-6F71-428E-B7A9-03E9308EC3B0}"/>
               </a:ext>
             </a:extLst>
           </p:cNvPr>
@@ -7589,10 +7633,9 @@
           <a:lstStyle xmlns:a="http://schemas.openxmlformats.org/drawingml/2006/main"/>
           <a:p xmlns:a="http://schemas.openxmlformats.org/drawingml/2006/main">
             <a:pPr>
-              <a:buNone/>
               <a:defRPr sz="1725" b="0">
                 <a:solidFill>
-                  <a:srgbClr val="156E58"/>
+                  <a:srgbClr val="5E706B"/>
                 </a:solidFill>
                 <a:latin typeface="Apple SD Gothic Neo"/>
                 <a:ea typeface="Apple SD Gothic Neo"/>
@@ -7602,25 +7645,13 @@
             <a:r>
               <a:rPr sz="1725" b="0">
                 <a:solidFill>
-                  <a:srgbClr val="156E58"/>
-                </a:solidFill>
-                <a:latin typeface="Apple SD Gothic Neo"/>
-                <a:ea typeface="Apple SD Gothic Neo"/>
-                <a:cs typeface="Apple SD Gothic Neo"/>
-              </a:rPr>
-              <a:t>데이터셋 원본: </a:t>
-            </a:r>
-            <a:r>
-              <a:rPr sz="1725" b="0">
-                <a:solidFill>
-                  <a:srgbClr val="156E58"/>
-                </a:solidFill>
-                <a:latin typeface="Apple SD Gothic Neo"/>
-                <a:ea typeface="Apple SD Gothic Neo"/>
-                <a:cs typeface="Apple SD Gothic Neo"/>
-                <a:hlinkClick xmlns:r="http://schemas.openxmlformats.org/officeDocument/2006/relationships" r:id="Rafd9e5ae71504e74"/>
-              </a:rPr>
-              <a:t>huggingface.co/datasets/ATH-MaaS/HSCodeComp</a:t>
+                  <a:srgbClr val="5E706B"/>
+                </a:solidFill>
+                <a:latin typeface="Apple SD Gothic Neo"/>
+                <a:ea typeface="Apple SD Gothic Neo"/>
+                <a:cs typeface="Apple SD Gothic Neo"/>
+              </a:rPr>
+              <a:t>텍스트만 사용했습니다. 웹 검색·이미지 분석·복수 경로 재선택은 이번 비교에서 제외했습니다.</a:t>
             </a:r>
           </a:p>
         </p:txBody>
@@ -7628,7 +7659,7 @@
     </p:spTree>
     <p:extLst>
       <p:ext uri="{BB962C8B-B14F-4D97-AF65-F5344CB8AC3E}">
-        <p14:creationId xmlns:p14="http://schemas.microsoft.com/office/powerpoint/2010/main" val="1928326010"/>
+        <p14:creationId xmlns:p14="http://schemas.microsoft.com/office/powerpoint/2010/main" val="1753230773"/>
       </p:ext>
     </p:extLst>
   </p:cSld>
@@ -7659,7 +7690,7 @@
           <p:cNvPr id="12" name="">
             <a:extLst xmlns:a="http://schemas.openxmlformats.org/drawingml/2006/main">
               <a:ext uri="{FF2B5EF4-FFF2-40B4-BE49-F238E27FC236}">
-                <a16:creationId xmlns:a16="http://schemas.microsoft.com/office/drawing/2014/main" id="{76AFBD16-BB63-40AD-A67C-25EBF9EE0FE8}"/>
+                <a16:creationId xmlns:a16="http://schemas.microsoft.com/office/drawing/2014/main" id="{D80A9B6B-FFBE-4769-8FD8-78C260F3E315}"/>
               </a:ext>
             </a:extLst>
           </p:cNvPr>
@@ -7688,7 +7719,6 @@
           <a:lstStyle xmlns:a="http://schemas.openxmlformats.org/drawingml/2006/main"/>
           <a:p xmlns:a="http://schemas.openxmlformats.org/drawingml/2006/main">
             <a:pPr>
-              <a:buNone/>
               <a:defRPr sz="3675" b="1">
                 <a:solidFill>
                   <a:srgbClr val="182C29"/>
@@ -7707,7 +7737,7 @@
                 <a:ea typeface="Apple SD Gothic Neo"/>
                 <a:cs typeface="Apple SD Gothic Neo"/>
               </a:rPr>
-              <a:t>HS 후보 판단시간을 5~6배 줄였습니다</a:t>
+              <a:t>HS 후보 판단시간을 약7배 줄였습니다</a:t>
             </a:r>
           </a:p>
         </p:txBody>
@@ -7717,7 +7747,7 @@
           <p:cNvPr id="2" name="">
             <a:extLst xmlns:a="http://schemas.openxmlformats.org/drawingml/2006/main">
               <a:ext uri="{FF2B5EF4-FFF2-40B4-BE49-F238E27FC236}">
-                <a16:creationId xmlns:a16="http://schemas.microsoft.com/office/drawing/2014/main" id="{811E44A2-D536-469D-98DF-20510C7E28F6}"/>
+                <a16:creationId xmlns:a16="http://schemas.microsoft.com/office/drawing/2014/main" id="{B95B1DE0-2524-4100-8CF6-7BEE21F1EC68}"/>
               </a:ext>
             </a:extLst>
           </p:cNvPr>
@@ -7746,7 +7776,6 @@
           <a:lstStyle xmlns:a="http://schemas.openxmlformats.org/drawingml/2006/main"/>
           <a:p xmlns:a="http://schemas.openxmlformats.org/drawingml/2006/main">
             <a:pPr>
-              <a:buNone/>
               <a:defRPr sz="2100" b="0">
                 <a:solidFill>
                   <a:srgbClr val="5E706B"/>
@@ -7765,7 +7794,7 @@
                 <a:ea typeface="Apple SD Gothic Neo"/>
                 <a:cs typeface="Apple SD Gothic Neo"/>
               </a:rPr>
-              <a:t>동일한 입력에서 Jev의 중앙 처리시간과 추정 비용이 더 낮았습니다.</a:t>
+              <a:t>새 서비스 범위93개에서 Jev의 중앙 처리시간과 추정 비용이 더 낮았습니다.</a:t>
             </a:r>
           </a:p>
         </p:txBody>
@@ -7775,7 +7804,7 @@
           <p:cNvPr id="3" name="">
             <a:extLst xmlns:a="http://schemas.openxmlformats.org/drawingml/2006/main">
               <a:ext uri="{FF2B5EF4-FFF2-40B4-BE49-F238E27FC236}">
-                <a16:creationId xmlns:a16="http://schemas.microsoft.com/office/drawing/2014/main" id="{E58BD48B-AC29-45F2-A860-07B1D6838A80}"/>
+                <a16:creationId xmlns:a16="http://schemas.microsoft.com/office/drawing/2014/main" id="{54C1D405-F07D-43A3-962D-4374BD2D1545}"/>
               </a:ext>
             </a:extLst>
           </p:cNvPr>
@@ -7804,7 +7833,6 @@
           <a:lstStyle xmlns:a="http://schemas.openxmlformats.org/drawingml/2006/main"/>
           <a:p xmlns:a="http://schemas.openxmlformats.org/drawingml/2006/main">
             <a:pPr>
-              <a:buNone/>
               <a:defRPr sz="1350" b="0">
                 <a:solidFill>
                   <a:srgbClr val="5E706B"/>
@@ -7823,14 +7851,14 @@
                 <a:ea typeface="Apple SD Gothic Neo"/>
                 <a:cs typeface="Apple SD Gothic Neo"/>
               </a:rPr>
-              <a:t>17   윤장한 · 직구 조사와 도구 구현 · 부록 · 2026.10.06</a:t>
+              <a:t>17   윤장한 · 직구 조사와 도구 구현 · 부록 · 2026.10.07</a:t>
             </a:r>
           </a:p>
         </p:txBody>
       </p:sp>
       <p:graphicFrame>
         <p:nvGraphicFramePr>
-          <p:cNvPr id="17" name="Chart"/>
+          <p:cNvPr id="15" name="Chart"/>
           <p:cNvGraphicFramePr/>
           <p:nvPr/>
         </p:nvGraphicFramePr>
@@ -7840,7 +7868,7 @@
         </p:xfrm>
         <a:graphic xmlns:a="http://schemas.openxmlformats.org/drawingml/2006/main">
           <a:graphicData uri="http://schemas.openxmlformats.org/drawingml/2006/chart">
-            <c:chart xmlns:r="http://schemas.openxmlformats.org/officeDocument/2006/relationships" xmlns:c="http://schemas.openxmlformats.org/drawingml/2006/chart" r:id="R8867b879a4614beb"/>
+            <c:chart xmlns:r="http://schemas.openxmlformats.org/officeDocument/2006/relationships" xmlns:c="http://schemas.openxmlformats.org/drawingml/2006/chart" r:id="R774ca97f29534967"/>
           </a:graphicData>
         </a:graphic>
       </p:graphicFrame>
@@ -7849,7 +7877,7 @@
           <p:cNvPr id="5" name="">
             <a:extLst xmlns:a="http://schemas.openxmlformats.org/drawingml/2006/main">
               <a:ext uri="{FF2B5EF4-FFF2-40B4-BE49-F238E27FC236}">
-                <a16:creationId xmlns:a16="http://schemas.microsoft.com/office/drawing/2014/main" id="{904456F5-EC6A-4EC9-B4F5-432C07FB1370}"/>
+                <a16:creationId xmlns:a16="http://schemas.microsoft.com/office/drawing/2014/main" id="{89D8A43C-DB18-4CEA-99D3-90D9037E320C}"/>
               </a:ext>
             </a:extLst>
           </p:cNvPr>
@@ -7878,7 +7906,6 @@
           <a:lstStyle xmlns:a="http://schemas.openxmlformats.org/drawingml/2006/main"/>
           <a:p xmlns:a="http://schemas.openxmlformats.org/drawingml/2006/main">
             <a:pPr>
-              <a:buNone/>
               <a:defRPr sz="2400" b="1">
                 <a:solidFill>
                   <a:srgbClr val="156E58"/>
@@ -7897,7 +7924,7 @@
                 <a:ea typeface="Apple SD Gothic Neo"/>
                 <a:cs typeface="Apple SD Gothic Neo"/>
               </a:rPr>
-              <a:t>HF 표본</a:t>
+              <a:t>판단시간</a:t>
             </a:r>
           </a:p>
         </p:txBody>
@@ -7907,7 +7934,7 @@
           <p:cNvPr id="6" name="">
             <a:extLst xmlns:a="http://schemas.openxmlformats.org/drawingml/2006/main">
               <a:ext uri="{FF2B5EF4-FFF2-40B4-BE49-F238E27FC236}">
-                <a16:creationId xmlns:a16="http://schemas.microsoft.com/office/drawing/2014/main" id="{476D8F6E-DA11-4B04-8FF1-8241BA08D036}"/>
+                <a16:creationId xmlns:a16="http://schemas.microsoft.com/office/drawing/2014/main" id="{A6E35CC9-F8DD-48F2-AE0B-DD732F7AF5A7}"/>
               </a:ext>
             </a:extLst>
           </p:cNvPr>
@@ -7936,7 +7963,6 @@
           <a:lstStyle xmlns:a="http://schemas.openxmlformats.org/drawingml/2006/main"/>
           <a:p xmlns:a="http://schemas.openxmlformats.org/drawingml/2006/main">
             <a:pPr>
-              <a:buNone/>
               <a:defRPr sz="3150" b="1">
                 <a:solidFill>
                   <a:srgbClr val="182C29"/>
@@ -7955,7 +7981,7 @@
                 <a:ea typeface="Apple SD Gothic Neo"/>
                 <a:cs typeface="Apple SD Gothic Neo"/>
               </a:rPr>
-              <a:t>6.4배 빠르게</a:t>
+              <a:t>약7배 빠르게</a:t>
             </a:r>
           </a:p>
         </p:txBody>
@@ -7965,7 +7991,7 @@
           <p:cNvPr id="7" name="">
             <a:extLst xmlns:a="http://schemas.openxmlformats.org/drawingml/2006/main">
               <a:ext uri="{FF2B5EF4-FFF2-40B4-BE49-F238E27FC236}">
-                <a16:creationId xmlns:a16="http://schemas.microsoft.com/office/drawing/2014/main" id="{A22D3943-DD8F-4BFC-A707-D7FAAAE682F2}"/>
+                <a16:creationId xmlns:a16="http://schemas.microsoft.com/office/drawing/2014/main" id="{02201935-53BF-405C-8716-1867321D6B85}"/>
               </a:ext>
             </a:extLst>
           </p:cNvPr>
@@ -7994,7 +8020,6 @@
           <a:lstStyle xmlns:a="http://schemas.openxmlformats.org/drawingml/2006/main"/>
           <a:p xmlns:a="http://schemas.openxmlformats.org/drawingml/2006/main">
             <a:pPr>
-              <a:buNone/>
               <a:defRPr sz="2100" b="0">
                 <a:solidFill>
                   <a:srgbClr val="182C29"/>
@@ -8013,7 +8038,7 @@
                 <a:ea typeface="Apple SD Gothic Neo"/>
                 <a:cs typeface="Apple SD Gothic Neo"/>
               </a:rPr>
-              <a:t>추정 비용57.0% 감소</a:t>
+              <a:t>0.645초 ↔ 4.510초</a:t>
             </a:r>
           </a:p>
         </p:txBody>
@@ -8023,7 +8048,7 @@
           <p:cNvPr id="8" name="">
             <a:extLst xmlns:a="http://schemas.openxmlformats.org/drawingml/2006/main">
               <a:ext uri="{FF2B5EF4-FFF2-40B4-BE49-F238E27FC236}">
-                <a16:creationId xmlns:a16="http://schemas.microsoft.com/office/drawing/2014/main" id="{4945892D-3F47-4E7B-BC70-D5DCD05FA923}"/>
+                <a16:creationId xmlns:a16="http://schemas.microsoft.com/office/drawing/2014/main" id="{3253A803-5A86-42C3-A064-71C775ABA443}"/>
               </a:ext>
             </a:extLst>
           </p:cNvPr>
@@ -8052,7 +8077,6 @@
           <a:lstStyle xmlns:a="http://schemas.openxmlformats.org/drawingml/2006/main"/>
           <a:p xmlns:a="http://schemas.openxmlformats.org/drawingml/2006/main">
             <a:pPr>
-              <a:buNone/>
               <a:defRPr sz="2400" b="1">
                 <a:solidFill>
                   <a:srgbClr val="156E58"/>
@@ -8071,7 +8095,7 @@
                 <a:ea typeface="Apple SD Gothic Neo"/>
                 <a:cs typeface="Apple SD Gothic Neo"/>
               </a:rPr>
-              <a:t>메루카리</a:t>
+              <a:t>추정 API 비용</a:t>
             </a:r>
           </a:p>
         </p:txBody>
@@ -8081,7 +8105,7 @@
           <p:cNvPr id="9" name="">
             <a:extLst xmlns:a="http://schemas.openxmlformats.org/drawingml/2006/main">
               <a:ext uri="{FF2B5EF4-FFF2-40B4-BE49-F238E27FC236}">
-                <a16:creationId xmlns:a16="http://schemas.microsoft.com/office/drawing/2014/main" id="{1833C4A1-62AA-4EDC-A677-F0E4BE2AFFC6}"/>
+                <a16:creationId xmlns:a16="http://schemas.microsoft.com/office/drawing/2014/main" id="{9774D6CB-1B40-40E6-9B2A-5AAB85B4746A}"/>
               </a:ext>
             </a:extLst>
           </p:cNvPr>
@@ -8110,7 +8134,6 @@
           <a:lstStyle xmlns:a="http://schemas.openxmlformats.org/drawingml/2006/main"/>
           <a:p xmlns:a="http://schemas.openxmlformats.org/drawingml/2006/main">
             <a:pPr>
-              <a:buNone/>
               <a:defRPr sz="3150" b="1">
                 <a:solidFill>
                   <a:srgbClr val="182C29"/>
@@ -8129,7 +8152,7 @@
                 <a:ea typeface="Apple SD Gothic Neo"/>
                 <a:cs typeface="Apple SD Gothic Neo"/>
               </a:rPr>
-              <a:t>5.7배 빠르게</a:t>
+              <a:t>57.1% 감소</a:t>
             </a:r>
           </a:p>
         </p:txBody>
@@ -8139,7 +8162,7 @@
           <p:cNvPr id="10" name="">
             <a:extLst xmlns:a="http://schemas.openxmlformats.org/drawingml/2006/main">
               <a:ext uri="{FF2B5EF4-FFF2-40B4-BE49-F238E27FC236}">
-                <a16:creationId xmlns:a16="http://schemas.microsoft.com/office/drawing/2014/main" id="{E85F53D6-3058-4200-A49A-1E71C9BA66B9}"/>
+                <a16:creationId xmlns:a16="http://schemas.microsoft.com/office/drawing/2014/main" id="{441321F8-FCBF-4850-9DD8-96507F6D142E}"/>
               </a:ext>
             </a:extLst>
           </p:cNvPr>
@@ -8168,26 +8191,25 @@
           <a:lstStyle xmlns:a="http://schemas.openxmlformats.org/drawingml/2006/main"/>
           <a:p xmlns:a="http://schemas.openxmlformats.org/drawingml/2006/main">
             <a:pPr>
-              <a:buNone/>
-              <a:defRPr sz="2100" b="0">
-                <a:solidFill>
-                  <a:srgbClr val="182C29"/>
-                </a:solidFill>
-                <a:latin typeface="Apple SD Gothic Neo"/>
-                <a:ea typeface="Apple SD Gothic Neo"/>
-                <a:cs typeface="Apple SD Gothic Neo"/>
-              </a:defRPr>
-            </a:pPr>
-            <a:r>
-              <a:rPr sz="2100" b="0">
-                <a:solidFill>
-                  <a:srgbClr val="182C29"/>
-                </a:solidFill>
-                <a:latin typeface="Apple SD Gothic Neo"/>
-                <a:ea typeface="Apple SD Gothic Neo"/>
-                <a:cs typeface="Apple SD Gothic Neo"/>
-              </a:rPr>
-              <a:t>추정 비용53.9% 감소</a:t>
+              <a:defRPr sz="1800" b="0">
+                <a:solidFill>
+                  <a:srgbClr val="182C29"/>
+                </a:solidFill>
+                <a:latin typeface="Apple SD Gothic Neo"/>
+                <a:ea typeface="Apple SD Gothic Neo"/>
+                <a:cs typeface="Apple SD Gothic Neo"/>
+              </a:defRPr>
+            </a:pPr>
+            <a:r>
+              <a:rPr sz="1800" b="0">
+                <a:solidFill>
+                  <a:srgbClr val="182C29"/>
+                </a:solidFill>
+                <a:latin typeface="Apple SD Gothic Neo"/>
+                <a:ea typeface="Apple SD Gothic Neo"/>
+                <a:cs typeface="Apple SD Gothic Neo"/>
+              </a:rPr>
+              <a:t>93개 합계 $0.0226 ↔ $0.0527</a:t>
             </a:r>
           </a:p>
         </p:txBody>
@@ -8197,7 +8219,7 @@
           <p:cNvPr id="11" name="">
             <a:extLst xmlns:a="http://schemas.openxmlformats.org/drawingml/2006/main">
               <a:ext uri="{FF2B5EF4-FFF2-40B4-BE49-F238E27FC236}">
-                <a16:creationId xmlns:a16="http://schemas.microsoft.com/office/drawing/2014/main" id="{15120C3A-8949-40DB-8D2F-14A2E8DA50D6}"/>
+                <a16:creationId xmlns:a16="http://schemas.microsoft.com/office/drawing/2014/main" id="{9065420C-E203-4A55-AD94-948D72BA346B}"/>
               </a:ext>
             </a:extLst>
           </p:cNvPr>
@@ -8226,7 +8248,6 @@
           <a:lstStyle xmlns:a="http://schemas.openxmlformats.org/drawingml/2006/main"/>
           <a:p xmlns:a="http://schemas.openxmlformats.org/drawingml/2006/main">
             <a:pPr>
-              <a:buNone/>
               <a:defRPr sz="1875" b="0">
                 <a:solidFill>
                   <a:srgbClr val="5E706B"/>
@@ -8245,7 +8266,7 @@
                 <a:ea typeface="Apple SD Gothic Neo"/>
                 <a:cs typeface="Apple SD Gothic Neo"/>
               </a:rPr>
-              <a:t>HS 분류 단계만 비교했습니다. 전체 URL 분석시간이나 운영 SLA의 개선율이 아닙니다.</a:t>
+              <a:t>분류 단계의 실험 수치입니다. 전체 URL 분석시간이나 운영 서비스 개선율이 아닙니다.</a:t>
             </a:r>
           </a:p>
         </p:txBody>
@@ -8253,7 +8274,7 @@
     </p:spTree>
     <p:extLst>
       <p:ext uri="{BB962C8B-B14F-4D97-AF65-F5344CB8AC3E}">
-        <p14:creationId xmlns:p14="http://schemas.microsoft.com/office/powerpoint/2010/main" val="2062628700"/>
+        <p14:creationId xmlns:p14="http://schemas.microsoft.com/office/powerpoint/2010/main" val="1755162290"/>
       </p:ext>
     </p:extLst>
   </p:cSld>
@@ -8284,7 +8305,7 @@
           <p:cNvPr id="8" name="">
             <a:extLst xmlns:a="http://schemas.openxmlformats.org/drawingml/2006/main">
               <a:ext uri="{FF2B5EF4-FFF2-40B4-BE49-F238E27FC236}">
-                <a16:creationId xmlns:a16="http://schemas.microsoft.com/office/drawing/2014/main" id="{0BED836E-2E09-4737-8347-3EBAA0C1B807}"/>
+                <a16:creationId xmlns:a16="http://schemas.microsoft.com/office/drawing/2014/main" id="{DD082C56-FD94-4B62-B649-C3276BB957FD}"/>
               </a:ext>
             </a:extLst>
           </p:cNvPr>
@@ -8313,7 +8334,6 @@
           <a:lstStyle xmlns:a="http://schemas.openxmlformats.org/drawingml/2006/main"/>
           <a:p xmlns:a="http://schemas.openxmlformats.org/drawingml/2006/main">
             <a:pPr>
-              <a:buNone/>
               <a:defRPr sz="3675" b="1">
                 <a:solidFill>
                   <a:srgbClr val="182C29"/>
@@ -8332,7 +8352,7 @@
                 <a:ea typeface="Apple SD Gothic Neo"/>
                 <a:cs typeface="Apple SD Gothic Neo"/>
               </a:rPr>
-              <a:t>품질은 평가 기준별로 구분했습니다</a:t>
+              <a:t>빠른 후보 판단과 최종 검토를 구분했습니다</a:t>
             </a:r>
           </a:p>
         </p:txBody>
@@ -8342,7 +8362,7 @@
           <p:cNvPr id="2" name="">
             <a:extLst xmlns:a="http://schemas.openxmlformats.org/drawingml/2006/main">
               <a:ext uri="{FF2B5EF4-FFF2-40B4-BE49-F238E27FC236}">
-                <a16:creationId xmlns:a16="http://schemas.microsoft.com/office/drawing/2014/main" id="{6AEFAC60-7114-4DA1-86BC-D3A68574D6B6}"/>
+                <a16:creationId xmlns:a16="http://schemas.microsoft.com/office/drawing/2014/main" id="{BD4ED953-A43C-4932-A8AA-B0CBA276972D}"/>
               </a:ext>
             </a:extLst>
           </p:cNvPr>
@@ -8371,7 +8391,6 @@
           <a:lstStyle xmlns:a="http://schemas.openxmlformats.org/drawingml/2006/main"/>
           <a:p xmlns:a="http://schemas.openxmlformats.org/drawingml/2006/main">
             <a:pPr>
-              <a:buNone/>
               <a:defRPr sz="2100" b="0">
                 <a:solidFill>
                   <a:srgbClr val="5E706B"/>
@@ -8390,7 +8409,7 @@
                 <a:ea typeface="Apple SD Gothic Neo"/>
                 <a:cs typeface="Apple SD Gothic Neo"/>
               </a:rPr>
-              <a:t>메루카리의 상위 모델 HS6 일치율84%를 기록했고, HF 정확도 차이도 확인했습니다.</a:t>
+              <a:t>처리시간·비용 이점과 함께, 재질·용도·정보 부족에 따른 판단 한계를 확인했습니다.</a:t>
             </a:r>
           </a:p>
         </p:txBody>
@@ -8400,7 +8419,7 @@
           <p:cNvPr id="3" name="">
             <a:extLst xmlns:a="http://schemas.openxmlformats.org/drawingml/2006/main">
               <a:ext uri="{FF2B5EF4-FFF2-40B4-BE49-F238E27FC236}">
-                <a16:creationId xmlns:a16="http://schemas.microsoft.com/office/drawing/2014/main" id="{E248D299-3D70-4881-8335-A473265A68D3}"/>
+                <a16:creationId xmlns:a16="http://schemas.microsoft.com/office/drawing/2014/main" id="{CD762081-D92A-45D5-ABA9-2207BC89C8C9}"/>
               </a:ext>
             </a:extLst>
           </p:cNvPr>
@@ -8429,7 +8448,6 @@
           <a:lstStyle xmlns:a="http://schemas.openxmlformats.org/drawingml/2006/main"/>
           <a:p xmlns:a="http://schemas.openxmlformats.org/drawingml/2006/main">
             <a:pPr>
-              <a:buNone/>
               <a:defRPr sz="1350" b="0">
                 <a:solidFill>
                   <a:srgbClr val="5E706B"/>
@@ -8448,14 +8466,14 @@
                 <a:ea typeface="Apple SD Gothic Neo"/>
                 <a:cs typeface="Apple SD Gothic Neo"/>
               </a:rPr>
-              <a:t>18   윤장한 · 직구 조사와 도구 구현 · 부록 · 2026.10.06</a:t>
+              <a:t>18   윤장한 · 직구 조사와 도구 구현 · 부록 · 2026.10.07</a:t>
             </a:r>
           </a:p>
         </p:txBody>
       </p:sp>
       <p:graphicFrame>
         <p:nvGraphicFramePr>
-          <p:cNvPr id="13" name=""/>
+          <p:cNvPr id="11" name=""/>
           <p:cNvGraphicFramePr/>
           <p:nvPr/>
         </p:nvGraphicFramePr>
@@ -8468,9 +8486,9 @@
             <a:tbl>
               <a:tblPr/>
               <a:tblGrid>
-                <a:gridCol w="7734300"/>
-                <a:gridCol w="2933700"/>
-                <a:gridCol w="2933700"/>
+                <a:gridCol w="3238500"/>
+                <a:gridCol w="5048250"/>
+                <a:gridCol w="5314950"/>
               </a:tblGrid>
               <a:tr h="695325">
                 <a:tc>
@@ -8487,7 +8505,7 @@
                           <a:ea typeface="Apple SD Gothic Neo"/>
                           <a:cs typeface="Apple SD Gothic Neo"/>
                         </a:rPr>
-                        <a:t>평가 기준</a:t>
+                        <a:t>검토 항목</a:t>
                       </a:r>
                     </a:p>
                   </a:txBody>
@@ -8511,7 +8529,7 @@
                           <a:ea typeface="Apple SD Gothic Neo"/>
                           <a:cs typeface="Apple SD Gothic Neo"/>
                         </a:rPr>
-                        <a:t>Jev</a:t>
+                        <a:t>관찰한 사례</a:t>
                       </a:r>
                     </a:p>
                   </a:txBody>
@@ -8535,7 +8553,7 @@
                           <a:ea typeface="Apple SD Gothic Neo"/>
                           <a:cs typeface="Apple SD Gothic Neo"/>
                         </a:rPr>
-                        <a:t>GPT-6 Luna</a:t>
+                        <a:t>적용 범위 (제안)</a:t>
                       </a:r>
                     </a:p>
                   </a:txBody>
@@ -8561,7 +8579,7 @@
                           <a:ea typeface="Apple SD Gothic Neo"/>
                           <a:cs typeface="Apple SD Gothic Neo"/>
                         </a:rPr>
-                        <a:t>HF 전문가 라벨 · 전체94개 HS6 정확도</a:t>
+                        <a:t>재질·제품 용도</a:t>
                       </a:r>
                     </a:p>
                   </a:txBody>
@@ -8585,7 +8603,7 @@
                           <a:ea typeface="Apple SD Gothic Neo"/>
                           <a:cs typeface="Apple SD Gothic Neo"/>
                         </a:rPr>
-                        <a:t>29.8% (28/94)</a:t>
+                        <a:t>PU 인조가죽 / 인형용 모자</a:t>
                       </a:r>
                     </a:p>
                   </a:txBody>
@@ -8609,7 +8627,7 @@
                           <a:ea typeface="Apple SD Gothic Neo"/>
                           <a:cs typeface="Apple SD Gothic Neo"/>
                         </a:rPr>
-                        <a:t>38.3% (36/94)</a:t>
+                        <a:t>추가 근거를 확인해 분류</a:t>
                       </a:r>
                     </a:p>
                   </a:txBody>
@@ -8635,7 +8653,7 @@
                           <a:ea typeface="Apple SD Gothic Neo"/>
                           <a:cs typeface="Apple SD Gothic Neo"/>
                         </a:rPr>
-                        <a:t>메루카리 · 심사자 HS6 일치 (25개)</a:t>
+                        <a:t>복합 재질·세트·부품</a:t>
                       </a:r>
                     </a:p>
                   </a:txBody>
@@ -8659,7 +8677,7 @@
                           <a:ea typeface="Apple SD Gothic Neo"/>
                           <a:cs typeface="Apple SD Gothic Neo"/>
                         </a:rPr>
-                        <a:t>84.0% (21/25)</a:t>
+                        <a:t>제목·속성·용도가 서로 충돌</a:t>
                       </a:r>
                     </a:p>
                   </a:txBody>
@@ -8683,7 +8701,7 @@
                           <a:ea typeface="Apple SD Gothic Neo"/>
                           <a:cs typeface="Apple SD Gothic Neo"/>
                         </a:rPr>
-                        <a:t>76.0% (19/25)</a:t>
+                        <a:t>불충분한 정보는 보류</a:t>
                       </a:r>
                     </a:p>
                   </a:txBody>
@@ -8709,7 +8727,7 @@
                           <a:ea typeface="Apple SD Gothic Neo"/>
                           <a:cs typeface="Apple SD Gothic Neo"/>
                         </a:rPr>
-                        <a:t>메루카리 · 보류 포함 전체 판단 일치</a:t>
+                        <a:t>입력과 참조 라벨</a:t>
                       </a:r>
                     </a:p>
                   </a:txBody>
@@ -8733,7 +8751,7 @@
                           <a:ea typeface="Apple SD Gothic Neo"/>
                           <a:cs typeface="Apple SD Gothic Neo"/>
                         </a:rPr>
-                        <a:t>70.0% (21/30)</a:t>
+                        <a:t>상품 정보와 라벨의 불일치</a:t>
                       </a:r>
                     </a:p>
                   </a:txBody>
@@ -8757,7 +8775,7 @@
                           <a:ea typeface="Apple SD Gothic Neo"/>
                           <a:cs typeface="Apple SD Gothic Neo"/>
                         </a:rPr>
-                        <a:t>76.7% (23/30)</a:t>
+                        <a:t>분류 결과와 데이터 함께 검토</a:t>
                       </a:r>
                     </a:p>
                   </a:txBody>
@@ -8777,7 +8795,7 @@
           <p:cNvPr id="5" name="">
             <a:extLst xmlns:a="http://schemas.openxmlformats.org/drawingml/2006/main">
               <a:ext uri="{FF2B5EF4-FFF2-40B4-BE49-F238E27FC236}">
-                <a16:creationId xmlns:a16="http://schemas.microsoft.com/office/drawing/2014/main" id="{224A75FC-55E6-4362-9697-AAD1F7632591}"/>
+                <a16:creationId xmlns:a16="http://schemas.microsoft.com/office/drawing/2014/main" id="{1DE8C92F-5FCE-4341-9265-E987EBAA192E}"/>
               </a:ext>
             </a:extLst>
           </p:cNvPr>
@@ -8789,7 +8807,7 @@
         <p:spPr>
           <a:xfrm xmlns:a="http://schemas.openxmlformats.org/drawingml/2006/main">
             <a:off x="819150" y="5791200"/>
-            <a:ext cx="13525500" cy="523875"/>
+            <a:ext cx="13525500" cy="619125"/>
           </a:xfrm>
           <a:prstGeom xmlns:a="http://schemas.openxmlformats.org/drawingml/2006/main" prst="rect">
             <a:avLst/>
@@ -8806,7 +8824,6 @@
           <a:lstStyle xmlns:a="http://schemas.openxmlformats.org/drawingml/2006/main"/>
           <a:p xmlns:a="http://schemas.openxmlformats.org/drawingml/2006/main">
             <a:pPr>
-              <a:buNone/>
               <a:defRPr sz="2025" b="0">
                 <a:solidFill>
                   <a:srgbClr val="5E706B"/>
@@ -8825,7 +8842,7 @@
                 <a:ea typeface="Apple SD Gothic Neo"/>
                 <a:cs typeface="Apple SD Gothic Neo"/>
               </a:rPr>
-              <a:t>상위 모델과의 일치는 정답 정확도가 아닙니다. HF에서는 Jev의 정확도가 더 낮았습니다.</a:t>
+              <a:t>판단 품질과 답변률에는 차이가 있습니다. 최종 관세 분류를 자동 확정하는 근거로 쓰지 않습니다.</a:t>
             </a:r>
           </a:p>
         </p:txBody>
@@ -8835,7 +8852,7 @@
           <p:cNvPr id="6" name="">
             <a:extLst xmlns:a="http://schemas.openxmlformats.org/drawingml/2006/main">
               <a:ext uri="{FF2B5EF4-FFF2-40B4-BE49-F238E27FC236}">
-                <a16:creationId xmlns:a16="http://schemas.microsoft.com/office/drawing/2014/main" id="{697E0B6D-485E-479C-BC00-9607A4BF7AE8}"/>
+                <a16:creationId xmlns:a16="http://schemas.microsoft.com/office/drawing/2014/main" id="{0EEC2F91-F13D-4AE3-B727-98FFA5623C84}"/>
               </a:ext>
             </a:extLst>
           </p:cNvPr>
@@ -8846,8 +8863,8 @@
         </p:nvSpPr>
         <p:spPr>
           <a:xfrm xmlns:a="http://schemas.openxmlformats.org/drawingml/2006/main">
-            <a:off x="819150" y="6477000"/>
-            <a:ext cx="13525500" cy="590550"/>
+            <a:off x="819150" y="6648450"/>
+            <a:ext cx="13525500" cy="495300"/>
           </a:xfrm>
           <a:prstGeom xmlns:a="http://schemas.openxmlformats.org/drawingml/2006/main" prst="rect">
             <a:avLst/>
@@ -8864,8 +8881,7 @@
           <a:lstStyle xmlns:a="http://schemas.openxmlformats.org/drawingml/2006/main"/>
           <a:p xmlns:a="http://schemas.openxmlformats.org/drawingml/2006/main">
             <a:pPr>
-              <a:buNone/>
-              <a:defRPr sz="2250" b="1">
+              <a:defRPr sz="2100" b="1">
                 <a:solidFill>
                   <a:srgbClr val="156E58"/>
                 </a:solidFill>
@@ -8875,7 +8891,7 @@
               </a:defRPr>
             </a:pPr>
             <a:r>
-              <a:rPr sz="2250" b="1">
+              <a:rPr sz="2100" b="1">
                 <a:solidFill>
                   <a:srgbClr val="156E58"/>
                 </a:solidFill>
@@ -8883,7 +8899,7 @@
                 <a:ea typeface="Apple SD Gothic Neo"/>
                 <a:cs typeface="Apple SD Gothic Neo"/>
               </a:rPr>
-              <a:t>도입 방향(제안): 초기 후보 판단을 빠르게 처리하고, 근거 부족·최종 분류는 추가 검토합니다.</a:t>
+              <a:t>검증 결과: 정확도·답변률·토큰·실패 사례를 공개 레포에서 확인할 수 있습니다.</a:t>
             </a:r>
           </a:p>
         </p:txBody>
@@ -8893,7 +8909,7 @@
           <p:cNvPr id="7" name="">
             <a:extLst xmlns:a="http://schemas.openxmlformats.org/drawingml/2006/main">
               <a:ext uri="{FF2B5EF4-FFF2-40B4-BE49-F238E27FC236}">
-                <a16:creationId xmlns:a16="http://schemas.microsoft.com/office/drawing/2014/main" id="{0D8741C7-5AF5-4B15-B2C9-E7206E5AC3BB}"/>
+                <a16:creationId xmlns:a16="http://schemas.microsoft.com/office/drawing/2014/main" id="{9965D73E-900A-49F2-B93C-95B6BCA8DC04}"/>
               </a:ext>
             </a:extLst>
           </p:cNvPr>
@@ -8904,8 +8920,8 @@
         </p:nvSpPr>
         <p:spPr>
           <a:xfrm xmlns:a="http://schemas.openxmlformats.org/drawingml/2006/main">
-            <a:off x="819150" y="7448550"/>
-            <a:ext cx="13525500" cy="371475"/>
+            <a:off x="819150" y="7429500"/>
+            <a:ext cx="13525500" cy="381000"/>
           </a:xfrm>
           <a:prstGeom xmlns:a="http://schemas.openxmlformats.org/drawingml/2006/main" prst="rect">
             <a:avLst/>
@@ -8922,26 +8938,37 @@
           <a:lstStyle xmlns:a="http://schemas.openxmlformats.org/drawingml/2006/main"/>
           <a:p xmlns:a="http://schemas.openxmlformats.org/drawingml/2006/main">
             <a:pPr>
-              <a:buNone/>
-              <a:defRPr sz="1725" b="0">
-                <a:solidFill>
-                  <a:srgbClr val="5E706B"/>
-                </a:solidFill>
-                <a:latin typeface="Apple SD Gothic Neo"/>
-                <a:ea typeface="Apple SD Gothic Neo"/>
-                <a:cs typeface="Apple SD Gothic Neo"/>
-              </a:defRPr>
-            </a:pPr>
-            <a:r>
-              <a:rPr sz="1725" b="0">
-                <a:solidFill>
-                  <a:srgbClr val="5E706B"/>
-                </a:solidFill>
-                <a:latin typeface="Apple SD Gothic Neo"/>
-                <a:ea typeface="Apple SD Gothic Neo"/>
-                <a:cs typeface="Apple SD Gothic Neo"/>
-              </a:rPr>
-              <a:t>실험 코드·노트북·측정 결과: github.com/y00nZZang/product-catalog/tree/main/notebooks</a:t>
+              <a:defRPr sz="1875" b="0">
+                <a:solidFill>
+                  <a:srgbClr val="156E58"/>
+                </a:solidFill>
+                <a:latin typeface="Apple SD Gothic Neo"/>
+                <a:ea typeface="Apple SD Gothic Neo"/>
+                <a:cs typeface="Apple SD Gothic Neo"/>
+              </a:defRPr>
+            </a:pPr>
+            <a:r>
+              <a:rPr sz="1875" b="0">
+                <a:solidFill>
+                  <a:srgbClr val="156E58"/>
+                </a:solidFill>
+                <a:latin typeface="Apple SD Gothic Neo"/>
+                <a:ea typeface="Apple SD Gothic Neo"/>
+                <a:cs typeface="Apple SD Gothic Neo"/>
+              </a:rPr>
+              <a:t>공개 실험 기록 · </a:t>
+            </a:r>
+            <a:r>
+              <a:rPr sz="1875" b="0">
+                <a:solidFill>
+                  <a:srgbClr val="156E58"/>
+                </a:solidFill>
+                <a:latin typeface="Apple SD Gothic Neo"/>
+                <a:ea typeface="Apple SD Gothic Neo"/>
+                <a:cs typeface="Apple SD Gothic Neo"/>
+                <a:hlinkClick xmlns:r="http://schemas.openxmlformats.org/officeDocument/2006/relationships" r:id="Raf335aa5e8c24561"/>
+              </a:rPr>
+              <a:t>github.com/y00nZZang/product-catalog</a:t>
             </a:r>
           </a:p>
         </p:txBody>
@@ -8949,7 +8976,7 @@
     </p:spTree>
     <p:extLst>
       <p:ext uri="{BB962C8B-B14F-4D97-AF65-F5344CB8AC3E}">
-        <p14:creationId xmlns:p14="http://schemas.microsoft.com/office/powerpoint/2010/main" val="1627327697"/>
+        <p14:creationId xmlns:p14="http://schemas.microsoft.com/office/powerpoint/2010/main" val="1964270569"/>
       </p:ext>
     </p:extLst>
   </p:cSld>
@@ -10293,7 +10320,7 @@
           <p:nvPr/>
         </p:nvPicPr>
         <p:blipFill>
-          <a:blip xmlns:r="http://schemas.openxmlformats.org/officeDocument/2006/relationships" xmlns:a="http://schemas.openxmlformats.org/drawingml/2006/main" r:embed="R222b191908ff469c"/>
+          <a:blip xmlns:r="http://schemas.openxmlformats.org/officeDocument/2006/relationships" xmlns:a="http://schemas.openxmlformats.org/drawingml/2006/main" r:embed="Rc867388c9d57432b"/>
           <a:stretch xmlns:a="http://schemas.openxmlformats.org/drawingml/2006/main"/>
         </p:blipFill>
         <p:spPr>
@@ -13098,7 +13125,7 @@
       </p:sp>
       <p:cxnSp>
         <p:nvCxnSpPr>
-          <p:cNvPr id="49" name=""/>
+          <p:cNvPr id="37" name=""/>
           <p:cNvCxnSpPr>
             <a:stCxn xmlns:a="http://schemas.openxmlformats.org/drawingml/2006/main" id="4" idx="3"/>
             <a:endCxn xmlns:a="http://schemas.openxmlformats.org/drawingml/2006/main" id="5" idx="1"/>
@@ -13183,7 +13210,7 @@
       </p:sp>
       <p:cxnSp>
         <p:nvCxnSpPr>
-          <p:cNvPr id="51" name=""/>
+          <p:cNvPr id="39" name=""/>
           <p:cNvCxnSpPr>
             <a:stCxn xmlns:a="http://schemas.openxmlformats.org/drawingml/2006/main" id="5" idx="3"/>
             <a:endCxn xmlns:a="http://schemas.openxmlformats.org/drawingml/2006/main" id="7" idx="1"/>
@@ -13268,7 +13295,7 @@
       </p:sp>
       <p:cxnSp>
         <p:nvCxnSpPr>
-          <p:cNvPr id="53" name=""/>
+          <p:cNvPr id="41" name=""/>
           <p:cNvCxnSpPr>
             <a:stCxn xmlns:a="http://schemas.openxmlformats.org/drawingml/2006/main" id="7" idx="3"/>
             <a:endCxn xmlns:a="http://schemas.openxmlformats.org/drawingml/2006/main" id="9" idx="1"/>
@@ -13353,7 +13380,7 @@
       </p:sp>
       <p:cxnSp>
         <p:nvCxnSpPr>
-          <p:cNvPr id="55" name=""/>
+          <p:cNvPr id="43" name=""/>
           <p:cNvCxnSpPr>
             <a:stCxn xmlns:a="http://schemas.openxmlformats.org/drawingml/2006/main" id="9" idx="3"/>
             <a:endCxn xmlns:a="http://schemas.openxmlformats.org/drawingml/2006/main" id="11" idx="1"/>
@@ -14628,7 +14655,7 @@
           <p:nvPr/>
         </p:nvPicPr>
         <p:blipFill>
-          <a:blip xmlns:r="http://schemas.openxmlformats.org/officeDocument/2006/relationships" xmlns:a="http://schemas.openxmlformats.org/drawingml/2006/main" r:embed="R24eaa77ad35f4beb"/>
+          <a:blip xmlns:r="http://schemas.openxmlformats.org/officeDocument/2006/relationships" xmlns:a="http://schemas.openxmlformats.org/drawingml/2006/main" r:embed="Reae30a489f91448a"/>
           <a:stretch xmlns:a="http://schemas.openxmlformats.org/drawingml/2006/main"/>
         </p:blipFill>
         <p:spPr>
@@ -15082,7 +15109,7 @@
       </p:sp>
       <p:cxnSp>
         <p:nvCxnSpPr>
-          <p:cNvPr id="34" name=""/>
+          <p:cNvPr id="26" name=""/>
           <p:cNvCxnSpPr>
             <a:stCxn xmlns:a="http://schemas.openxmlformats.org/drawingml/2006/main" id="4" idx="3"/>
             <a:endCxn xmlns:a="http://schemas.openxmlformats.org/drawingml/2006/main" id="5" idx="1"/>
@@ -15167,7 +15194,7 @@
       </p:sp>
       <p:cxnSp>
         <p:nvCxnSpPr>
-          <p:cNvPr id="36" name=""/>
+          <p:cNvPr id="28" name=""/>
           <p:cNvCxnSpPr>
             <a:stCxn xmlns:a="http://schemas.openxmlformats.org/drawingml/2006/main" id="5" idx="3"/>
             <a:endCxn xmlns:a="http://schemas.openxmlformats.org/drawingml/2006/main" id="7" idx="1"/>

</xml_diff>

<commit_message>
Introduce Jev and explain HS classification experiment motivation
</commit_message>
<xml_diff>
--- a/portfolio/crossborder-portfolio.pptx
+++ b/portfolio/crossborder-portfolio.pptx
@@ -2,30 +2,30 @@
 <file path=ppt/presentation.xml><?xml version="1.0" encoding="utf-8"?>
 <p:presentation xmlns:p="http://schemas.openxmlformats.org/presentationml/2006/main">
   <p:sldMasterIdLst>
-    <p:sldMasterId xmlns:r="http://schemas.openxmlformats.org/officeDocument/2006/relationships" id="2147483648" r:id="Ra56d68c42fbb43a4"/>
+    <p:sldMasterId xmlns:r="http://schemas.openxmlformats.org/officeDocument/2006/relationships" id="2147483648" r:id="R5bd7558566b34a75"/>
   </p:sldMasterIdLst>
   <p:notesMasterIdLst>
-    <p:notesMasterId xmlns:r="http://schemas.openxmlformats.org/officeDocument/2006/relationships" r:id="R58e65546b5ec41dc"/>
+    <p:notesMasterId xmlns:r="http://schemas.openxmlformats.org/officeDocument/2006/relationships" r:id="R1ca19feec93d4778"/>
   </p:notesMasterIdLst>
   <p:sldIdLst>
-    <p:sldId xmlns:r="http://schemas.openxmlformats.org/officeDocument/2006/relationships" id="256" r:id="Ra4f0161fb4fd45e3"/>
-    <p:sldId xmlns:r="http://schemas.openxmlformats.org/officeDocument/2006/relationships" id="257" r:id="R93324130f41847b2"/>
-    <p:sldId xmlns:r="http://schemas.openxmlformats.org/officeDocument/2006/relationships" id="258" r:id="Raa59b28199364315"/>
-    <p:sldId xmlns:r="http://schemas.openxmlformats.org/officeDocument/2006/relationships" id="259" r:id="R8b357fa08a984173"/>
-    <p:sldId xmlns:r="http://schemas.openxmlformats.org/officeDocument/2006/relationships" id="260" r:id="R54383c14146d4815"/>
-    <p:sldId xmlns:r="http://schemas.openxmlformats.org/officeDocument/2006/relationships" id="261" r:id="R717176e21e0946bb"/>
-    <p:sldId xmlns:r="http://schemas.openxmlformats.org/officeDocument/2006/relationships" id="262" r:id="R0503203391ae4767"/>
-    <p:sldId xmlns:r="http://schemas.openxmlformats.org/officeDocument/2006/relationships" id="263" r:id="Rcb5688d1376243b7"/>
-    <p:sldId xmlns:r="http://schemas.openxmlformats.org/officeDocument/2006/relationships" id="264" r:id="R4953180543214287"/>
-    <p:sldId xmlns:r="http://schemas.openxmlformats.org/officeDocument/2006/relationships" id="265" r:id="Rd6bd13580fc54007"/>
-    <p:sldId xmlns:r="http://schemas.openxmlformats.org/officeDocument/2006/relationships" id="266" r:id="R047d32cdd79c4b7a"/>
-    <p:sldId xmlns:r="http://schemas.openxmlformats.org/officeDocument/2006/relationships" id="267" r:id="R52b493f1e3b54f86"/>
-    <p:sldId xmlns:r="http://schemas.openxmlformats.org/officeDocument/2006/relationships" id="268" r:id="Rf5024eb4406c4c88"/>
-    <p:sldId xmlns:r="http://schemas.openxmlformats.org/officeDocument/2006/relationships" id="269" r:id="R25e688f042b142e9"/>
-    <p:sldId xmlns:r="http://schemas.openxmlformats.org/officeDocument/2006/relationships" id="270" r:id="R0bf3e0af4376485f"/>
-    <p:sldId xmlns:r="http://schemas.openxmlformats.org/officeDocument/2006/relationships" id="271" r:id="Rddfa3c180f964570"/>
-    <p:sldId xmlns:r="http://schemas.openxmlformats.org/officeDocument/2006/relationships" id="272" r:id="R4268af0c7dd643d0"/>
-    <p:sldId xmlns:r="http://schemas.openxmlformats.org/officeDocument/2006/relationships" id="273" r:id="R0f43f7c3c6cd44e1"/>
+    <p:sldId xmlns:r="http://schemas.openxmlformats.org/officeDocument/2006/relationships" id="256" r:id="Rf814da61dcd74b6f"/>
+    <p:sldId xmlns:r="http://schemas.openxmlformats.org/officeDocument/2006/relationships" id="257" r:id="R491bd7e7b0284f9d"/>
+    <p:sldId xmlns:r="http://schemas.openxmlformats.org/officeDocument/2006/relationships" id="258" r:id="R82b668be0dfa4f54"/>
+    <p:sldId xmlns:r="http://schemas.openxmlformats.org/officeDocument/2006/relationships" id="259" r:id="Rf2ab83515cda4666"/>
+    <p:sldId xmlns:r="http://schemas.openxmlformats.org/officeDocument/2006/relationships" id="260" r:id="R56b463af0ce74596"/>
+    <p:sldId xmlns:r="http://schemas.openxmlformats.org/officeDocument/2006/relationships" id="261" r:id="R509751778c324cbd"/>
+    <p:sldId xmlns:r="http://schemas.openxmlformats.org/officeDocument/2006/relationships" id="262" r:id="R96dec3ab60514f3f"/>
+    <p:sldId xmlns:r="http://schemas.openxmlformats.org/officeDocument/2006/relationships" id="263" r:id="Re022e4fb9c9a4a2f"/>
+    <p:sldId xmlns:r="http://schemas.openxmlformats.org/officeDocument/2006/relationships" id="264" r:id="R2d02fd27abda4ad1"/>
+    <p:sldId xmlns:r="http://schemas.openxmlformats.org/officeDocument/2006/relationships" id="265" r:id="R89ae46e3537e49ed"/>
+    <p:sldId xmlns:r="http://schemas.openxmlformats.org/officeDocument/2006/relationships" id="266" r:id="R7b8eb2193a7b46ec"/>
+    <p:sldId xmlns:r="http://schemas.openxmlformats.org/officeDocument/2006/relationships" id="267" r:id="R907fc0063b0f47f8"/>
+    <p:sldId xmlns:r="http://schemas.openxmlformats.org/officeDocument/2006/relationships" id="268" r:id="R48f6787eaaca428b"/>
+    <p:sldId xmlns:r="http://schemas.openxmlformats.org/officeDocument/2006/relationships" id="269" r:id="Rfe6fcd32a2a24478"/>
+    <p:sldId xmlns:r="http://schemas.openxmlformats.org/officeDocument/2006/relationships" id="270" r:id="Rcf7dbc1d04364416"/>
+    <p:sldId xmlns:r="http://schemas.openxmlformats.org/officeDocument/2006/relationships" id="271" r:id="R1c134b966d9a43b0"/>
+    <p:sldId xmlns:r="http://schemas.openxmlformats.org/officeDocument/2006/relationships" id="272" r:id="R70ed73d8e7774ce5"/>
+    <p:sldId xmlns:r="http://schemas.openxmlformats.org/officeDocument/2006/relationships" id="273" r:id="R63386d9aabce4293"/>
   </p:sldIdLst>
   <p:sldSz cx="15240000" cy="8572500"/>
   <p:notesSz cx="6858000" cy="9144000"/>
@@ -949,7 +949,7 @@
           <a:lstStyle xmlns:a="http://schemas.openxmlformats.org/drawingml/2006/main"/>
           <a:p xmlns:a="http://schemas.openxmlformats.org/drawingml/2006/main">
             <a:r>
-              <a:t>https://github.com/y00nZZang/product-catalog/blob/main/docs/service-scope-jev-experiment-2026-10-07.md ; https://huggingface.co/datasets/ATH-MaaS/HSCodeComp ; https://docs.typesafe.ai/primitives/choice . 서비스 범위는 연구 초안으로 사조의 검증된 정책이 아니다. 기존 단일 경로 Jev와 Luna만 비교. 정답/보류/실패는 공개 레포에서 확인.</a:t>
+              <a:t>https://github.com/y00nZZang/product-catalog/blob/main/docs/service-scope-jev-experiment-2026-10-07.md ; https://typesafe.ai/blog/introducing-system-one-models-and-jev ; https://huggingface.co/datasets/ATH-MaaS/HSCodeComp ; https://docs.typesafe.ai/primitives/choice . 서비스 범위는 연구 초안으로 사조의 검증된 정책이 아니다. 기존 단일 경로 Jev와 Luna만 비교. 정답/보류/실패는 공개 레포에서 확인.</a:t>
             </a:r>
           </a:p>
         </p:txBody>
@@ -1717,7 +1717,7 @@
   </p:cSld>
   <p:clrMap bg1="lt1" tx1="dk1" bg2="lt2" tx2="dk2" accent1="accent1" accent2="accent2" accent3="accent3" accent4="accent4" accent5="accent5" accent6="accent6" hlink="hlink" folHlink="folHlink"/>
   <p:sldLayoutIdLst>
-    <p:sldLayoutId xmlns:r="http://schemas.openxmlformats.org/officeDocument/2006/relationships" id="2147483649" r:id="Rfe025f4721fd4067"/>
+    <p:sldLayoutId xmlns:r="http://schemas.openxmlformats.org/officeDocument/2006/relationships" id="2147483649" r:id="Re0776635f88449a6"/>
   </p:sldLayoutIdLst>
   <p:txStyles>
     <p:titleStyle>
@@ -3122,7 +3122,7 @@
           <p:nvPr/>
         </p:nvPicPr>
         <p:blipFill>
-          <a:blip xmlns:r="http://schemas.openxmlformats.org/officeDocument/2006/relationships" xmlns:a="http://schemas.openxmlformats.org/drawingml/2006/main" r:embed="R28a6c3b97fa147f7"/>
+          <a:blip xmlns:r="http://schemas.openxmlformats.org/officeDocument/2006/relationships" xmlns:a="http://schemas.openxmlformats.org/drawingml/2006/main" r:embed="Rffb6d602995c4d5f"/>
           <a:stretch xmlns:a="http://schemas.openxmlformats.org/drawingml/2006/main"/>
         </p:blipFill>
         <p:spPr>
@@ -6962,10 +6962,10 @@
       </p:grpSpPr>
       <p:sp>
         <p:nvSpPr>
-          <p:cNvPr id="8" name="">
+          <p:cNvPr id="10" name="">
             <a:extLst xmlns:a="http://schemas.openxmlformats.org/drawingml/2006/main">
               <a:ext uri="{FF2B5EF4-FFF2-40B4-BE49-F238E27FC236}">
-                <a16:creationId xmlns:a16="http://schemas.microsoft.com/office/drawing/2014/main" id="{257E9C89-36F8-44F5-9A6D-3FA9FE32B6EE}"/>
+                <a16:creationId xmlns:a16="http://schemas.microsoft.com/office/drawing/2014/main" id="{316806A6-F786-4B6E-BDFB-378080108CAF}"/>
               </a:ext>
             </a:extLst>
           </p:cNvPr>
@@ -7022,7 +7022,7 @@
           <p:cNvPr id="2" name="">
             <a:extLst xmlns:a="http://schemas.openxmlformats.org/drawingml/2006/main">
               <a:ext uri="{FF2B5EF4-FFF2-40B4-BE49-F238E27FC236}">
-                <a16:creationId xmlns:a16="http://schemas.microsoft.com/office/drawing/2014/main" id="{CC463259-6DB3-4276-946A-81F3A6C6913F}"/>
+                <a16:creationId xmlns:a16="http://schemas.microsoft.com/office/drawing/2014/main" id="{66E38F28-9B54-42B0-8C13-AD4F0AA927AC}"/>
               </a:ext>
             </a:extLst>
           </p:cNvPr>
@@ -7079,7 +7079,7 @@
           <p:cNvPr id="3" name="">
             <a:extLst xmlns:a="http://schemas.openxmlformats.org/drawingml/2006/main">
               <a:ext uri="{FF2B5EF4-FFF2-40B4-BE49-F238E27FC236}">
-                <a16:creationId xmlns:a16="http://schemas.microsoft.com/office/drawing/2014/main" id="{43BC3CF6-1C90-41B1-B0A3-F0B83D628E76}"/>
+                <a16:creationId xmlns:a16="http://schemas.microsoft.com/office/drawing/2014/main" id="{18ABA3E3-8AAD-466E-9ECE-58D1D538D6E5}"/>
               </a:ext>
             </a:extLst>
           </p:cNvPr>
@@ -7136,7 +7136,7 @@
           <p:cNvPr id="4" name="">
             <a:extLst xmlns:a="http://schemas.openxmlformats.org/drawingml/2006/main">
               <a:ext uri="{FF2B5EF4-FFF2-40B4-BE49-F238E27FC236}">
-                <a16:creationId xmlns:a16="http://schemas.microsoft.com/office/drawing/2014/main" id="{184A043A-B990-499F-B282-A1D59D3ED6A8}"/>
+                <a16:creationId xmlns:a16="http://schemas.microsoft.com/office/drawing/2014/main" id="{A2395409-DF95-4667-8EF3-535E724111E4}"/>
               </a:ext>
             </a:extLst>
           </p:cNvPr>
@@ -7147,8 +7147,8 @@
         </p:nvSpPr>
         <p:spPr>
           <a:xfrm xmlns:a="http://schemas.openxmlformats.org/drawingml/2006/main">
-            <a:off x="819150" y="2638425"/>
-            <a:ext cx="13525500" cy="1095375"/>
+            <a:off x="819150" y="2543175"/>
+            <a:ext cx="13525500" cy="857250"/>
           </a:xfrm>
           <a:prstGeom xmlns:a="http://schemas.openxmlformats.org/drawingml/2006/main" prst="rect">
             <a:avLst/>
@@ -7183,7 +7183,7 @@
                 <a:ea typeface="Apple SD Gothic Neo"/>
                 <a:cs typeface="Apple SD Gothic Neo"/>
               </a:rPr>
-              <a:t>HSCodeComp는 실제 전자상거래 상품632개에 전문가가 HS 코드를 붙인 공개 평가셋입니다.</a:t>
+              <a:t>Jev는 TypeSafe AI가 만든 선택·분류 중심의 판단 모델입니다.</a:t>
             </a:r>
           </a:p>
           <a:p xmlns:a="http://schemas.openxmlformats.org/drawingml/2006/main">
@@ -7206,20 +7206,157 @@
                 <a:ea typeface="Apple SD Gothic Neo"/>
                 <a:cs typeface="Apple SD Gothic Neo"/>
               </a:rPr>
-              <a:t>가정용·취미 범위에서 이전 실험과 겹치지 않는 새 상품93개를 평가했습니다.</a:t>
+              <a:t>설명문 대신 미리 정한 후보에서 선택하고, 후보별 확률을 반환합니다.</a:t>
+            </a:r>
+          </a:p>
+        </p:txBody>
+      </p:sp>
+      <p:sp>
+        <p:nvSpPr>
+          <p:cNvPr id="5" name="">
+            <a:extLst xmlns:a="http://schemas.openxmlformats.org/drawingml/2006/main">
+              <a:ext uri="{FF2B5EF4-FFF2-40B4-BE49-F238E27FC236}">
+                <a16:creationId xmlns:a16="http://schemas.microsoft.com/office/drawing/2014/main" id="{36923EE0-E4ED-442F-BCF0-3EF96DDF64DF}"/>
+              </a:ext>
+            </a:extLst>
+          </p:cNvPr>
+          <p:cNvSpPr>
+            <a:spLocks xmlns:a="http://schemas.openxmlformats.org/drawingml/2006/main" noGrp="1"/>
+          </p:cNvSpPr>
+          <p:nvPr/>
+        </p:nvSpPr>
+        <p:spPr>
+          <a:xfrm xmlns:a="http://schemas.openxmlformats.org/drawingml/2006/main">
+            <a:off x="819150" y="3638550"/>
+            <a:ext cx="13525500" cy="828675"/>
+          </a:xfrm>
+          <a:prstGeom xmlns:a="http://schemas.openxmlformats.org/drawingml/2006/main" prst="rect">
+            <a:avLst/>
+          </a:prstGeom>
+          <a:noFill xmlns:a="http://schemas.openxmlformats.org/drawingml/2006/main"/>
+          <a:ln xmlns:a="http://schemas.openxmlformats.org/drawingml/2006/main" w="0">
+            <a:noFill/>
+          </a:ln>
+        </p:spPr>
+        <p:txBody>
+          <a:bodyPr xmlns:a="http://schemas.openxmlformats.org/drawingml/2006/main" wrap="square" lIns="0" tIns="0" rIns="0" bIns="0">
+            <a:noAutofit/>
+          </a:bodyPr>
+          <a:lstStyle xmlns:a="http://schemas.openxmlformats.org/drawingml/2006/main"/>
+          <a:p xmlns:a="http://schemas.openxmlformats.org/drawingml/2006/main">
+            <a:pPr>
+              <a:defRPr sz="2100" b="0">
+                <a:solidFill>
+                  <a:srgbClr val="156E58"/>
+                </a:solidFill>
+                <a:latin typeface="Apple SD Gothic Neo"/>
+                <a:ea typeface="Apple SD Gothic Neo"/>
+                <a:cs typeface="Apple SD Gothic Neo"/>
+              </a:defRPr>
+            </a:pPr>
+            <a:r>
+              <a:rPr sz="2100" b="0">
+                <a:solidFill>
+                  <a:srgbClr val="156E58"/>
+                </a:solidFill>
+                <a:latin typeface="Apple SD Gothic Neo"/>
+                <a:ea typeface="Apple SD Gothic Neo"/>
+                <a:cs typeface="Apple SD Gothic Neo"/>
+              </a:rPr>
+              <a:t>HS 코드 추론도 정해진 코드 중에서 고르는 작업이므로,</a:t>
+            </a:r>
+          </a:p>
+          <a:p xmlns:a="http://schemas.openxmlformats.org/drawingml/2006/main">
+            <a:pPr>
+              <a:defRPr sz="2100" b="0">
+                <a:solidFill>
+                  <a:srgbClr val="156E58"/>
+                </a:solidFill>
+                <a:latin typeface="Apple SD Gothic Neo"/>
+                <a:ea typeface="Apple SD Gothic Neo"/>
+                <a:cs typeface="Apple SD Gothic Neo"/>
+              </a:defRPr>
+            </a:pPr>
+            <a:r>
+              <a:rPr sz="2100" b="0">
+                <a:solidFill>
+                  <a:srgbClr val="156E58"/>
+                </a:solidFill>
+                <a:latin typeface="Apple SD Gothic Neo"/>
+                <a:ea typeface="Apple SD Gothic Neo"/>
+                <a:cs typeface="Apple SD Gothic Neo"/>
+              </a:rPr>
+              <a:t>LLM 대신 Jev를 쓰면 판단시간과 비용을 줄일 수 있는지 확인했습니다.</a:t>
+            </a:r>
+          </a:p>
+        </p:txBody>
+      </p:sp>
+      <p:sp>
+        <p:nvSpPr>
+          <p:cNvPr id="6" name="">
+            <a:extLst xmlns:a="http://schemas.openxmlformats.org/drawingml/2006/main">
+              <a:ext uri="{FF2B5EF4-FFF2-40B4-BE49-F238E27FC236}">
+                <a16:creationId xmlns:a16="http://schemas.microsoft.com/office/drawing/2014/main" id="{BDF34998-7140-4FE5-AD09-945F9BF38B7B}"/>
+              </a:ext>
+            </a:extLst>
+          </p:cNvPr>
+          <p:cNvSpPr>
+            <a:spLocks xmlns:a="http://schemas.openxmlformats.org/drawingml/2006/main" noGrp="1"/>
+          </p:cNvSpPr>
+          <p:nvPr/>
+        </p:nvSpPr>
+        <p:spPr>
+          <a:xfrm xmlns:a="http://schemas.openxmlformats.org/drawingml/2006/main">
+            <a:off x="819150" y="4638675"/>
+            <a:ext cx="13525500" cy="381000"/>
+          </a:xfrm>
+          <a:prstGeom xmlns:a="http://schemas.openxmlformats.org/drawingml/2006/main" prst="rect">
+            <a:avLst/>
+          </a:prstGeom>
+          <a:noFill xmlns:a="http://schemas.openxmlformats.org/drawingml/2006/main"/>
+          <a:ln xmlns:a="http://schemas.openxmlformats.org/drawingml/2006/main" w="0">
+            <a:noFill/>
+          </a:ln>
+        </p:spPr>
+        <p:txBody>
+          <a:bodyPr xmlns:a="http://schemas.openxmlformats.org/drawingml/2006/main" wrap="square" lIns="0" tIns="0" rIns="0" bIns="0">
+            <a:noAutofit/>
+          </a:bodyPr>
+          <a:lstStyle xmlns:a="http://schemas.openxmlformats.org/drawingml/2006/main"/>
+          <a:p xmlns:a="http://schemas.openxmlformats.org/drawingml/2006/main">
+            <a:pPr>
+              <a:defRPr sz="1725" b="0">
+                <a:solidFill>
+                  <a:srgbClr val="5E706B"/>
+                </a:solidFill>
+                <a:latin typeface="Apple SD Gothic Neo"/>
+                <a:ea typeface="Apple SD Gothic Neo"/>
+                <a:cs typeface="Apple SD Gothic Neo"/>
+              </a:defRPr>
+            </a:pPr>
+            <a:r>
+              <a:rPr sz="1725" b="0">
+                <a:solidFill>
+                  <a:srgbClr val="5E706B"/>
+                </a:solidFill>
+                <a:latin typeface="Apple SD Gothic Neo"/>
+                <a:ea typeface="Apple SD Gothic Neo"/>
+                <a:cs typeface="Apple SD Gothic Neo"/>
+              </a:rPr>
+              <a:t>평가: HSCodeComp(전자상거래 상품632개·전문가 라벨)에서 이전과 겹치지 않는 새93개 선별</a:t>
             </a:r>
           </a:p>
         </p:txBody>
       </p:sp>
       <p:graphicFrame>
         <p:nvGraphicFramePr>
-          <p:cNvPr id="12" name=""/>
+          <p:cNvPr id="16" name=""/>
           <p:cNvGraphicFramePr/>
           <p:nvPr/>
         </p:nvGraphicFramePr>
         <p:xfrm>
-          <a:off xmlns:a="http://schemas.openxmlformats.org/drawingml/2006/main" x="819150" y="4124325"/>
-          <a:ext xmlns:a="http://schemas.openxmlformats.org/drawingml/2006/main" cx="13601700" cy="2266950"/>
+          <a:off xmlns:a="http://schemas.openxmlformats.org/drawingml/2006/main" x="819150" y="5238750"/>
+          <a:ext xmlns:a="http://schemas.openxmlformats.org/drawingml/2006/main" cx="13601700" cy="1352550"/>
         </p:xfrm>
         <a:graphic xmlns:a="http://schemas.openxmlformats.org/drawingml/2006/main">
           <a:graphicData uri="http://schemas.openxmlformats.org/drawingml/2006/table">
@@ -7230,14 +7367,14 @@
                 <a:gridCol w="5143500"/>
                 <a:gridCol w="5791200"/>
               </a:tblGrid>
-              <a:tr h="566738">
+              <a:tr h="338138">
                 <a:tc>
                   <a:txBody>
                     <a:bodyPr/>
                     <a:lstStyle/>
                     <a:p>
                       <a:r>
-                        <a:rPr sz="2025" b="1">
+                        <a:rPr sz="1800" b="1">
                           <a:solidFill>
                             <a:srgbClr val="FFFFFF"/>
                           </a:solidFill>
@@ -7261,7 +7398,7 @@
                     <a:lstStyle/>
                     <a:p>
                       <a:r>
-                        <a:rPr sz="2025" b="1">
+                        <a:rPr sz="1800" b="1">
                           <a:solidFill>
                             <a:srgbClr val="FFFFFF"/>
                           </a:solidFill>
@@ -7285,7 +7422,7 @@
                     <a:lstStyle/>
                     <a:p>
                       <a:r>
-                        <a:rPr sz="2025" b="1">
+                        <a:rPr sz="1800" b="1">
                           <a:solidFill>
                             <a:srgbClr val="FFFFFF"/>
                           </a:solidFill>
@@ -7304,14 +7441,14 @@
                   </a:tcPr>
                 </a:tc>
               </a:tr>
-              <a:tr h="566738">
+              <a:tr h="338138">
                 <a:tc>
                   <a:txBody>
                     <a:bodyPr/>
                     <a:lstStyle/>
                     <a:p>
                       <a:r>
-                        <a:rPr sz="2175" b="0">
+                        <a:rPr sz="1800" b="0">
                           <a:solidFill>
                             <a:srgbClr val="182C29"/>
                           </a:solidFill>
@@ -7335,7 +7472,7 @@
                     <a:lstStyle/>
                     <a:p>
                       <a:r>
-                        <a:rPr sz="2175" b="0">
+                        <a:rPr sz="1800" b="0">
                           <a:solidFill>
                             <a:srgbClr val="182C29"/>
                           </a:solidFill>
@@ -7359,7 +7496,7 @@
                     <a:lstStyle/>
                     <a:p>
                       <a:r>
-                        <a:rPr sz="2175" b="0">
+                        <a:rPr sz="1800" b="0">
                           <a:solidFill>
                             <a:srgbClr val="182C29"/>
                           </a:solidFill>
@@ -7378,14 +7515,14 @@
                   </a:tcPr>
                 </a:tc>
               </a:tr>
-              <a:tr h="566738">
+              <a:tr h="338138">
                 <a:tc>
                   <a:txBody>
                     <a:bodyPr/>
                     <a:lstStyle/>
                     <a:p>
                       <a:r>
-                        <a:rPr sz="2175" b="0">
+                        <a:rPr sz="1800" b="0">
                           <a:solidFill>
                             <a:srgbClr val="182C29"/>
                           </a:solidFill>
@@ -7409,7 +7546,7 @@
                     <a:lstStyle/>
                     <a:p>
                       <a:r>
-                        <a:rPr sz="2175" b="0">
+                        <a:rPr sz="1800" b="0">
                           <a:solidFill>
                             <a:srgbClr val="182C29"/>
                           </a:solidFill>
@@ -7433,7 +7570,7 @@
                     <a:lstStyle/>
                     <a:p>
                       <a:r>
-                        <a:rPr sz="2175" b="0">
+                        <a:rPr sz="1800" b="0">
                           <a:solidFill>
                             <a:srgbClr val="182C29"/>
                           </a:solidFill>
@@ -7452,14 +7589,14 @@
                   </a:tcPr>
                 </a:tc>
               </a:tr>
-              <a:tr h="566738">
+              <a:tr h="338138">
                 <a:tc>
                   <a:txBody>
                     <a:bodyPr/>
                     <a:lstStyle/>
                     <a:p>
                       <a:r>
-                        <a:rPr sz="2175" b="0">
+                        <a:rPr sz="1800" b="0">
                           <a:solidFill>
                             <a:srgbClr val="182C29"/>
                           </a:solidFill>
@@ -7483,7 +7620,7 @@
                     <a:lstStyle/>
                     <a:p>
                       <a:r>
-                        <a:rPr sz="2175" b="0">
+                        <a:rPr sz="1800" b="0">
                           <a:solidFill>
                             <a:srgbClr val="182C29"/>
                           </a:solidFill>
@@ -7507,7 +7644,7 @@
                     <a:lstStyle/>
                     <a:p>
                       <a:r>
-                        <a:rPr sz="2175" b="0">
+                        <a:rPr sz="1800" b="0">
                           <a:solidFill>
                             <a:srgbClr val="182C29"/>
                           </a:solidFill>
@@ -7532,10 +7669,10 @@
       </p:graphicFrame>
       <p:sp>
         <p:nvSpPr>
-          <p:cNvPr id="6" name="">
+          <p:cNvPr id="8" name="">
             <a:extLst xmlns:a="http://schemas.openxmlformats.org/drawingml/2006/main">
               <a:ext uri="{FF2B5EF4-FFF2-40B4-BE49-F238E27FC236}">
-                <a16:creationId xmlns:a16="http://schemas.microsoft.com/office/drawing/2014/main" id="{E44A524F-98D4-4099-9EF4-56CADF8D8408}"/>
+                <a16:creationId xmlns:a16="http://schemas.microsoft.com/office/drawing/2014/main" id="{F37F75C3-77F2-4358-8190-891113A0B851}"/>
               </a:ext>
             </a:extLst>
           </p:cNvPr>
@@ -7592,7 +7729,7 @@
                 <a:latin typeface="Apple SD Gothic Neo"/>
                 <a:ea typeface="Apple SD Gothic Neo"/>
                 <a:cs typeface="Apple SD Gothic Neo"/>
-                <a:hlinkClick xmlns:r="http://schemas.openxmlformats.org/officeDocument/2006/relationships" r:id="R50a12f88ed144c3b"/>
+                <a:hlinkClick xmlns:r="http://schemas.openxmlformats.org/officeDocument/2006/relationships" r:id="R757a087ce54845ce"/>
               </a:rPr>
               <a:t>huggingface.co/datasets/ATH-MaaS/HSCodeComp</a:t>
             </a:r>
@@ -7601,10 +7738,10 @@
       </p:sp>
       <p:sp>
         <p:nvSpPr>
-          <p:cNvPr id="7" name="">
+          <p:cNvPr id="9" name="">
             <a:extLst xmlns:a="http://schemas.openxmlformats.org/drawingml/2006/main">
               <a:ext uri="{FF2B5EF4-FFF2-40B4-BE49-F238E27FC236}">
-                <a16:creationId xmlns:a16="http://schemas.microsoft.com/office/drawing/2014/main" id="{1591DE84-6F71-428E-B7A9-03E9308EC3B0}"/>
+                <a16:creationId xmlns:a16="http://schemas.microsoft.com/office/drawing/2014/main" id="{43C7C9F7-B097-41FD-8B4E-C49478311751}"/>
               </a:ext>
             </a:extLst>
           </p:cNvPr>
@@ -7659,7 +7796,7 @@
     </p:spTree>
     <p:extLst>
       <p:ext uri="{BB962C8B-B14F-4D97-AF65-F5344CB8AC3E}">
-        <p14:creationId xmlns:p14="http://schemas.microsoft.com/office/powerpoint/2010/main" val="1753230773"/>
+        <p14:creationId xmlns:p14="http://schemas.microsoft.com/office/powerpoint/2010/main" val="1798917796"/>
       </p:ext>
     </p:extLst>
   </p:cSld>
@@ -7690,7 +7827,7 @@
           <p:cNvPr id="12" name="">
             <a:extLst xmlns:a="http://schemas.openxmlformats.org/drawingml/2006/main">
               <a:ext uri="{FF2B5EF4-FFF2-40B4-BE49-F238E27FC236}">
-                <a16:creationId xmlns:a16="http://schemas.microsoft.com/office/drawing/2014/main" id="{D80A9B6B-FFBE-4769-8FD8-78C260F3E315}"/>
+                <a16:creationId xmlns:a16="http://schemas.microsoft.com/office/drawing/2014/main" id="{B9B284BC-558D-48EF-AAFC-9802195FD924}"/>
               </a:ext>
             </a:extLst>
           </p:cNvPr>
@@ -7747,7 +7884,7 @@
           <p:cNvPr id="2" name="">
             <a:extLst xmlns:a="http://schemas.openxmlformats.org/drawingml/2006/main">
               <a:ext uri="{FF2B5EF4-FFF2-40B4-BE49-F238E27FC236}">
-                <a16:creationId xmlns:a16="http://schemas.microsoft.com/office/drawing/2014/main" id="{B95B1DE0-2524-4100-8CF6-7BEE21F1EC68}"/>
+                <a16:creationId xmlns:a16="http://schemas.microsoft.com/office/drawing/2014/main" id="{1C9AE6E5-BF83-4A46-8B14-15C4EC058083}"/>
               </a:ext>
             </a:extLst>
           </p:cNvPr>
@@ -7804,7 +7941,7 @@
           <p:cNvPr id="3" name="">
             <a:extLst xmlns:a="http://schemas.openxmlformats.org/drawingml/2006/main">
               <a:ext uri="{FF2B5EF4-FFF2-40B4-BE49-F238E27FC236}">
-                <a16:creationId xmlns:a16="http://schemas.microsoft.com/office/drawing/2014/main" id="{54C1D405-F07D-43A3-962D-4374BD2D1545}"/>
+                <a16:creationId xmlns:a16="http://schemas.microsoft.com/office/drawing/2014/main" id="{02F1044C-C249-4C72-A7A2-FB90BE217D99}"/>
               </a:ext>
             </a:extLst>
           </p:cNvPr>
@@ -7868,7 +8005,7 @@
         </p:xfrm>
         <a:graphic xmlns:a="http://schemas.openxmlformats.org/drawingml/2006/main">
           <a:graphicData uri="http://schemas.openxmlformats.org/drawingml/2006/chart">
-            <c:chart xmlns:r="http://schemas.openxmlformats.org/officeDocument/2006/relationships" xmlns:c="http://schemas.openxmlformats.org/drawingml/2006/chart" r:id="R774ca97f29534967"/>
+            <c:chart xmlns:r="http://schemas.openxmlformats.org/officeDocument/2006/relationships" xmlns:c="http://schemas.openxmlformats.org/drawingml/2006/chart" r:id="R94bf9dced78d4785"/>
           </a:graphicData>
         </a:graphic>
       </p:graphicFrame>
@@ -7877,7 +8014,7 @@
           <p:cNvPr id="5" name="">
             <a:extLst xmlns:a="http://schemas.openxmlformats.org/drawingml/2006/main">
               <a:ext uri="{FF2B5EF4-FFF2-40B4-BE49-F238E27FC236}">
-                <a16:creationId xmlns:a16="http://schemas.microsoft.com/office/drawing/2014/main" id="{89D8A43C-DB18-4CEA-99D3-90D9037E320C}"/>
+                <a16:creationId xmlns:a16="http://schemas.microsoft.com/office/drawing/2014/main" id="{E2D91EE4-61DC-4071-B64F-45A83EC089D3}"/>
               </a:ext>
             </a:extLst>
           </p:cNvPr>
@@ -7934,7 +8071,7 @@
           <p:cNvPr id="6" name="">
             <a:extLst xmlns:a="http://schemas.openxmlformats.org/drawingml/2006/main">
               <a:ext uri="{FF2B5EF4-FFF2-40B4-BE49-F238E27FC236}">
-                <a16:creationId xmlns:a16="http://schemas.microsoft.com/office/drawing/2014/main" id="{A6E35CC9-F8DD-48F2-AE0B-DD732F7AF5A7}"/>
+                <a16:creationId xmlns:a16="http://schemas.microsoft.com/office/drawing/2014/main" id="{C9B02663-9758-4045-B18D-4D138A2DDAC3}"/>
               </a:ext>
             </a:extLst>
           </p:cNvPr>
@@ -7991,7 +8128,7 @@
           <p:cNvPr id="7" name="">
             <a:extLst xmlns:a="http://schemas.openxmlformats.org/drawingml/2006/main">
               <a:ext uri="{FF2B5EF4-FFF2-40B4-BE49-F238E27FC236}">
-                <a16:creationId xmlns:a16="http://schemas.microsoft.com/office/drawing/2014/main" id="{02201935-53BF-405C-8716-1867321D6B85}"/>
+                <a16:creationId xmlns:a16="http://schemas.microsoft.com/office/drawing/2014/main" id="{2103D890-A168-44BF-B04D-42104B0FEBB7}"/>
               </a:ext>
             </a:extLst>
           </p:cNvPr>
@@ -8048,7 +8185,7 @@
           <p:cNvPr id="8" name="">
             <a:extLst xmlns:a="http://schemas.openxmlformats.org/drawingml/2006/main">
               <a:ext uri="{FF2B5EF4-FFF2-40B4-BE49-F238E27FC236}">
-                <a16:creationId xmlns:a16="http://schemas.microsoft.com/office/drawing/2014/main" id="{3253A803-5A86-42C3-A064-71C775ABA443}"/>
+                <a16:creationId xmlns:a16="http://schemas.microsoft.com/office/drawing/2014/main" id="{AAC6CCC4-C53A-4AE7-B2E5-96BEFF0C985F}"/>
               </a:ext>
             </a:extLst>
           </p:cNvPr>
@@ -8105,7 +8242,7 @@
           <p:cNvPr id="9" name="">
             <a:extLst xmlns:a="http://schemas.openxmlformats.org/drawingml/2006/main">
               <a:ext uri="{FF2B5EF4-FFF2-40B4-BE49-F238E27FC236}">
-                <a16:creationId xmlns:a16="http://schemas.microsoft.com/office/drawing/2014/main" id="{9774D6CB-1B40-40E6-9B2A-5AAB85B4746A}"/>
+                <a16:creationId xmlns:a16="http://schemas.microsoft.com/office/drawing/2014/main" id="{E5EDB073-8AC7-41CA-BD65-BAE93548E6AC}"/>
               </a:ext>
             </a:extLst>
           </p:cNvPr>
@@ -8162,7 +8299,7 @@
           <p:cNvPr id="10" name="">
             <a:extLst xmlns:a="http://schemas.openxmlformats.org/drawingml/2006/main">
               <a:ext uri="{FF2B5EF4-FFF2-40B4-BE49-F238E27FC236}">
-                <a16:creationId xmlns:a16="http://schemas.microsoft.com/office/drawing/2014/main" id="{441321F8-FCBF-4850-9DD8-96507F6D142E}"/>
+                <a16:creationId xmlns:a16="http://schemas.microsoft.com/office/drawing/2014/main" id="{8DC95117-CCD6-4A33-8726-CC589C2C5A3E}"/>
               </a:ext>
             </a:extLst>
           </p:cNvPr>
@@ -8219,7 +8356,7 @@
           <p:cNvPr id="11" name="">
             <a:extLst xmlns:a="http://schemas.openxmlformats.org/drawingml/2006/main">
               <a:ext uri="{FF2B5EF4-FFF2-40B4-BE49-F238E27FC236}">
-                <a16:creationId xmlns:a16="http://schemas.microsoft.com/office/drawing/2014/main" id="{9065420C-E203-4A55-AD94-948D72BA346B}"/>
+                <a16:creationId xmlns:a16="http://schemas.microsoft.com/office/drawing/2014/main" id="{EC718635-1D1B-4495-A8ED-5473D30D4CC1}"/>
               </a:ext>
             </a:extLst>
           </p:cNvPr>
@@ -8274,7 +8411,7 @@
     </p:spTree>
     <p:extLst>
       <p:ext uri="{BB962C8B-B14F-4D97-AF65-F5344CB8AC3E}">
-        <p14:creationId xmlns:p14="http://schemas.microsoft.com/office/powerpoint/2010/main" val="1755162290"/>
+        <p14:creationId xmlns:p14="http://schemas.microsoft.com/office/powerpoint/2010/main" val="642437264"/>
       </p:ext>
     </p:extLst>
   </p:cSld>
@@ -8305,7 +8442,7 @@
           <p:cNvPr id="8" name="">
             <a:extLst xmlns:a="http://schemas.openxmlformats.org/drawingml/2006/main">
               <a:ext uri="{FF2B5EF4-FFF2-40B4-BE49-F238E27FC236}">
-                <a16:creationId xmlns:a16="http://schemas.microsoft.com/office/drawing/2014/main" id="{DD082C56-FD94-4B62-B649-C3276BB957FD}"/>
+                <a16:creationId xmlns:a16="http://schemas.microsoft.com/office/drawing/2014/main" id="{E359D3C5-7ED1-47A0-BD6D-B8639247FD6D}"/>
               </a:ext>
             </a:extLst>
           </p:cNvPr>
@@ -8362,7 +8499,7 @@
           <p:cNvPr id="2" name="">
             <a:extLst xmlns:a="http://schemas.openxmlformats.org/drawingml/2006/main">
               <a:ext uri="{FF2B5EF4-FFF2-40B4-BE49-F238E27FC236}">
-                <a16:creationId xmlns:a16="http://schemas.microsoft.com/office/drawing/2014/main" id="{BD4ED953-A43C-4932-A8AA-B0CBA276972D}"/>
+                <a16:creationId xmlns:a16="http://schemas.microsoft.com/office/drawing/2014/main" id="{E547C8DE-80AC-4CFC-8FCB-C0211D4B5D47}"/>
               </a:ext>
             </a:extLst>
           </p:cNvPr>
@@ -8419,7 +8556,7 @@
           <p:cNvPr id="3" name="">
             <a:extLst xmlns:a="http://schemas.openxmlformats.org/drawingml/2006/main">
               <a:ext uri="{FF2B5EF4-FFF2-40B4-BE49-F238E27FC236}">
-                <a16:creationId xmlns:a16="http://schemas.microsoft.com/office/drawing/2014/main" id="{CD762081-D92A-45D5-ABA9-2207BC89C8C9}"/>
+                <a16:creationId xmlns:a16="http://schemas.microsoft.com/office/drawing/2014/main" id="{E7ED515F-05C8-4D3B-9C52-6FFADD79ABDC}"/>
               </a:ext>
             </a:extLst>
           </p:cNvPr>
@@ -8795,7 +8932,7 @@
           <p:cNvPr id="5" name="">
             <a:extLst xmlns:a="http://schemas.openxmlformats.org/drawingml/2006/main">
               <a:ext uri="{FF2B5EF4-FFF2-40B4-BE49-F238E27FC236}">
-                <a16:creationId xmlns:a16="http://schemas.microsoft.com/office/drawing/2014/main" id="{1DE8C92F-5FCE-4341-9265-E987EBAA192E}"/>
+                <a16:creationId xmlns:a16="http://schemas.microsoft.com/office/drawing/2014/main" id="{A5EFBBB2-6052-4D62-950C-419678F792E5}"/>
               </a:ext>
             </a:extLst>
           </p:cNvPr>
@@ -8852,7 +8989,7 @@
           <p:cNvPr id="6" name="">
             <a:extLst xmlns:a="http://schemas.openxmlformats.org/drawingml/2006/main">
               <a:ext uri="{FF2B5EF4-FFF2-40B4-BE49-F238E27FC236}">
-                <a16:creationId xmlns:a16="http://schemas.microsoft.com/office/drawing/2014/main" id="{0EEC2F91-F13D-4AE3-B727-98FFA5623C84}"/>
+                <a16:creationId xmlns:a16="http://schemas.microsoft.com/office/drawing/2014/main" id="{B4BDCF6B-56D0-4305-9DA3-E3CBEC109804}"/>
               </a:ext>
             </a:extLst>
           </p:cNvPr>
@@ -8909,7 +9046,7 @@
           <p:cNvPr id="7" name="">
             <a:extLst xmlns:a="http://schemas.openxmlformats.org/drawingml/2006/main">
               <a:ext uri="{FF2B5EF4-FFF2-40B4-BE49-F238E27FC236}">
-                <a16:creationId xmlns:a16="http://schemas.microsoft.com/office/drawing/2014/main" id="{9965D73E-900A-49F2-B93C-95B6BCA8DC04}"/>
+                <a16:creationId xmlns:a16="http://schemas.microsoft.com/office/drawing/2014/main" id="{A88FF3A2-44F7-46AF-9D2F-70D7D12619F0}"/>
               </a:ext>
             </a:extLst>
           </p:cNvPr>
@@ -8966,7 +9103,7 @@
                 <a:latin typeface="Apple SD Gothic Neo"/>
                 <a:ea typeface="Apple SD Gothic Neo"/>
                 <a:cs typeface="Apple SD Gothic Neo"/>
-                <a:hlinkClick xmlns:r="http://schemas.openxmlformats.org/officeDocument/2006/relationships" r:id="Raf335aa5e8c24561"/>
+                <a:hlinkClick xmlns:r="http://schemas.openxmlformats.org/officeDocument/2006/relationships" r:id="Ra1f44fc0758a43fe"/>
               </a:rPr>
               <a:t>github.com/y00nZZang/product-catalog</a:t>
             </a:r>
@@ -8976,7 +9113,7 @@
     </p:spTree>
     <p:extLst>
       <p:ext uri="{BB962C8B-B14F-4D97-AF65-F5344CB8AC3E}">
-        <p14:creationId xmlns:p14="http://schemas.microsoft.com/office/powerpoint/2010/main" val="1964270569"/>
+        <p14:creationId xmlns:p14="http://schemas.microsoft.com/office/powerpoint/2010/main" val="2038980969"/>
       </p:ext>
     </p:extLst>
   </p:cSld>
@@ -10320,7 +10457,7 @@
           <p:nvPr/>
         </p:nvPicPr>
         <p:blipFill>
-          <a:blip xmlns:r="http://schemas.openxmlformats.org/officeDocument/2006/relationships" xmlns:a="http://schemas.openxmlformats.org/drawingml/2006/main" r:embed="Rc867388c9d57432b"/>
+          <a:blip xmlns:r="http://schemas.openxmlformats.org/officeDocument/2006/relationships" xmlns:a="http://schemas.openxmlformats.org/drawingml/2006/main" r:embed="Rec4f853f77264a7b"/>
           <a:stretch xmlns:a="http://schemas.openxmlformats.org/drawingml/2006/main"/>
         </p:blipFill>
         <p:spPr>
@@ -14655,7 +14792,7 @@
           <p:nvPr/>
         </p:nvPicPr>
         <p:blipFill>
-          <a:blip xmlns:r="http://schemas.openxmlformats.org/officeDocument/2006/relationships" xmlns:a="http://schemas.openxmlformats.org/drawingml/2006/main" r:embed="Reae30a489f91448a"/>
+          <a:blip xmlns:r="http://schemas.openxmlformats.org/officeDocument/2006/relationships" xmlns:a="http://schemas.openxmlformats.org/drawingml/2006/main" r:embed="R1e34c2d461b34ae7"/>
           <a:stretch xmlns:a="http://schemas.openxmlformats.org/drawingml/2006/main"/>
         </p:blipFill>
         <p:spPr>

</xml_diff>